<commit_message>
v4 — police 12pt min, gradient mostly-navy, footer band uniforme
- FS_FLOOR à 12pt ; échelle typo bumpée (body 12, section 13,
  domaine 15, titre 24, initiales 48). Footer reste 10pt (exception
  pour la mention légale).
- Gradient stops à 3 points : navy tenu jusqu'à 85 % de la diagonale,
  cyan confiné au seul coin bas-droite. Navy assombri (#07227A) pour
  garantir le contraste du texte blanc.
- Bandeau footer uniforme (NAVY_SIDEBAR full-width au bas du slide)
  — la mention de confidentialité ne traverse plus deux couleurs.
- Sidebar élargie à 35,2 % pour héberger engagements + hobbies.
- Estimateur d'overflow recalibré pour 12pt (line_pt=14, CPL sidebar
  42 / main 80).
- Caps resserrés en conséquence : 2 bullets/exp, 5 expertises,
  3 engagements, 200 chars résumé, 140 chars bullet, 40 chars degré,
  35 chars description d'engagement.

Co-Authored-By: Claude Opus 4.7 <noreply@anthropic.com>
Claude-Session: https://claude.ai/code/session_01P34Y9PqaSyqWxj7EA7cQyd
</commit_message>
<xml_diff>
--- a/outputs/A.P._ai_governance.pptx
+++ b/outputs/A.P._ai_governance.pptx
@@ -3110,10 +3110,10 @@
           <a:gradFill flip="none" rotWithShape="1">
             <a:gsLst>
               <a:gs pos="0">
-                <a:srgbClr val="0C2A8E"/>
+                <a:srgbClr val="07227A"/>
               </a:gs>
-              <a:gs pos="70000">
-                <a:srgbClr val="0C2A8E"/>
+              <a:gs pos="85000">
+                <a:srgbClr val="07227A"/>
               </a:gs>
               <a:gs pos="100000">
                 <a:srgbClr val="1FCBD9"/>
@@ -3159,7 +3159,7 @@
             <a:avLst/>
           </a:prstGeom>
           <a:solidFill>
-            <a:srgbClr val="071F66"/>
+            <a:srgbClr val="061A5E"/>
           </a:solidFill>
           <a:ln>
             <a:noFill/>
@@ -3190,7 +3190,51 @@
       </p:sp>
       <p:sp>
         <p:nvSpPr>
-          <p:cNvPr id="4" name="TextBox 3"/>
+          <p:cNvPr id="4" name="Rectangle 3"/>
+          <p:cNvSpPr/>
+          <p:nvPr/>
+        </p:nvSpPr>
+        <p:spPr>
+          <a:xfrm>
+            <a:off x="0" y="6578000"/>
+            <a:ext cx="12192000" cy="280000"/>
+          </a:xfrm>
+          <a:prstGeom prst="rect">
+            <a:avLst/>
+          </a:prstGeom>
+          <a:solidFill>
+            <a:srgbClr val="061A5E"/>
+          </a:solidFill>
+          <a:ln>
+            <a:noFill/>
+          </a:ln>
+          <a:effectLst/>
+        </p:spPr>
+        <p:style>
+          <a:lnRef idx="1">
+            <a:schemeClr val="accent1"/>
+          </a:lnRef>
+          <a:fillRef idx="3">
+            <a:schemeClr val="accent1"/>
+          </a:fillRef>
+          <a:effectRef idx="2">
+            <a:schemeClr val="accent1"/>
+          </a:effectRef>
+          <a:fontRef idx="minor">
+            <a:schemeClr val="lt1"/>
+          </a:fontRef>
+        </p:style>
+        <p:txBody>
+          <a:bodyPr rtlCol="0" anchor="ctr"/>
+          <a:lstStyle/>
+          <a:p>
+            <a:pPr algn="ctr"/>
+          </a:p>
+        </p:txBody>
+      </p:sp>
+      <p:sp>
+        <p:nvSpPr>
+          <p:cNvPr id="5" name="TextBox 4"/>
           <p:cNvSpPr txBox="1"/>
           <p:nvPr/>
         </p:nvSpPr>
@@ -3212,7 +3256,7 @@
           <a:p>
             <a:pPr algn="l"/>
             <a:r>
-              <a:rPr sz="4400" b="1" i="0">
+              <a:rPr sz="4800" b="1" i="0">
                 <a:solidFill>
                   <a:srgbClr val="3AEDE5"/>
                 </a:solidFill>
@@ -3225,7 +3269,7 @@
       </p:sp>
       <p:sp>
         <p:nvSpPr>
-          <p:cNvPr id="5" name="TextBox 4"/>
+          <p:cNvPr id="6" name="TextBox 5"/>
           <p:cNvSpPr txBox="1"/>
           <p:nvPr/>
         </p:nvSpPr>
@@ -3246,7 +3290,7 @@
           <a:lstStyle/>
           <a:p>
             <a:r>
-              <a:rPr sz="2000" b="1" i="0">
+              <a:rPr sz="2400" b="1" i="0">
                 <a:solidFill>
                   <a:srgbClr val="FFFFFF"/>
                 </a:solidFill>
@@ -3262,7 +3306,7 @@
               </a:spcBef>
             </a:pPr>
             <a:r>
-              <a:rPr sz="1300" b="0" i="1">
+              <a:rPr sz="1500" b="0" i="1">
                 <a:solidFill>
                   <a:srgbClr val="3AEDE5"/>
                 </a:solidFill>
@@ -3275,7 +3319,7 @@
       </p:sp>
       <p:sp>
         <p:nvSpPr>
-          <p:cNvPr id="6" name="TextBox 5"/>
+          <p:cNvPr id="7" name="TextBox 6"/>
           <p:cNvSpPr txBox="1"/>
           <p:nvPr/>
         </p:nvSpPr>
@@ -3301,7 +3345,7 @@
               </a:spcAft>
             </a:pPr>
             <a:r>
-              <a:rPr sz="1100" b="1" i="0">
+              <a:rPr sz="1300" b="1" i="0">
                 <a:solidFill>
                   <a:srgbClr val="3AEDE5"/>
                 </a:solidFill>
@@ -3317,7 +3361,7 @@
               </a:spcAft>
             </a:pPr>
             <a:r>
-              <a:rPr sz="1000" b="1" i="0">
+              <a:rPr sz="1200" b="1" i="0">
                 <a:solidFill>
                   <a:srgbClr val="3AEDE5"/>
                 </a:solidFill>
@@ -3326,7 +3370,7 @@
               <a:t>•  </a:t>
             </a:r>
             <a:r>
-              <a:rPr sz="1000" b="0" i="0">
+              <a:rPr sz="1200" b="0" i="0">
                 <a:solidFill>
                   <a:srgbClr val="FFFFFF"/>
                 </a:solidFill>
@@ -3342,7 +3386,7 @@
               </a:spcAft>
             </a:pPr>
             <a:r>
-              <a:rPr sz="1000" b="1" i="0">
+              <a:rPr sz="1200" b="1" i="0">
                 <a:solidFill>
                   <a:srgbClr val="3AEDE5"/>
                 </a:solidFill>
@@ -3351,7 +3395,7 @@
               <a:t>•  </a:t>
             </a:r>
             <a:r>
-              <a:rPr sz="1000" b="0" i="0">
+              <a:rPr sz="1200" b="0" i="0">
                 <a:solidFill>
                   <a:srgbClr val="FFFFFF"/>
                 </a:solidFill>
@@ -3367,7 +3411,7 @@
               </a:spcAft>
             </a:pPr>
             <a:r>
-              <a:rPr sz="1000" b="1" i="0">
+              <a:rPr sz="1200" b="1" i="0">
                 <a:solidFill>
                   <a:srgbClr val="3AEDE5"/>
                 </a:solidFill>
@@ -3376,7 +3420,7 @@
               <a:t>•  </a:t>
             </a:r>
             <a:r>
-              <a:rPr sz="1000" b="0" i="0">
+              <a:rPr sz="1200" b="0" i="0">
                 <a:solidFill>
                   <a:srgbClr val="FFFFFF"/>
                 </a:solidFill>
@@ -3392,7 +3436,7 @@
               </a:spcAft>
             </a:pPr>
             <a:r>
-              <a:rPr sz="1000" b="1" i="0">
+              <a:rPr sz="1200" b="1" i="0">
                 <a:solidFill>
                   <a:srgbClr val="3AEDE5"/>
                 </a:solidFill>
@@ -3401,7 +3445,7 @@
               <a:t>•  </a:t>
             </a:r>
             <a:r>
-              <a:rPr sz="1000" b="0" i="0">
+              <a:rPr sz="1200" b="0" i="0">
                 <a:solidFill>
                   <a:srgbClr val="FFFFFF"/>
                 </a:solidFill>
@@ -3417,7 +3461,7 @@
               </a:spcAft>
             </a:pPr>
             <a:r>
-              <a:rPr sz="1000" b="1" i="0">
+              <a:rPr sz="1200" b="1" i="0">
                 <a:solidFill>
                   <a:srgbClr val="3AEDE5"/>
                 </a:solidFill>
@@ -3426,7 +3470,7 @@
               <a:t>•  </a:t>
             </a:r>
             <a:r>
-              <a:rPr sz="1000" b="0" i="0">
+              <a:rPr sz="1200" b="0" i="0">
                 <a:solidFill>
                   <a:srgbClr val="FFFFFF"/>
                 </a:solidFill>
@@ -3445,7 +3489,7 @@
               </a:spcAft>
             </a:pPr>
             <a:r>
-              <a:rPr sz="1100" b="1" i="0">
+              <a:rPr sz="1300" b="1" i="0">
                 <a:solidFill>
                   <a:srgbClr val="3AEDE5"/>
                 </a:solidFill>
@@ -3461,7 +3505,7 @@
               </a:spcAft>
             </a:pPr>
             <a:r>
-              <a:rPr sz="1000" b="1" i="0">
+              <a:rPr sz="1200" b="1" i="0">
                 <a:solidFill>
                   <a:srgbClr val="3AEDE5"/>
                 </a:solidFill>
@@ -3470,7 +3514,7 @@
               <a:t>•  </a:t>
             </a:r>
             <a:r>
-              <a:rPr sz="1000" b="0" i="0">
+              <a:rPr sz="1200" b="0" i="0">
                 <a:solidFill>
                   <a:srgbClr val="FFFFFF"/>
                 </a:solidFill>
@@ -3486,7 +3530,7 @@
               </a:spcAft>
             </a:pPr>
             <a:r>
-              <a:rPr sz="1000" b="1" i="0">
+              <a:rPr sz="1200" b="1" i="0">
                 <a:solidFill>
                   <a:srgbClr val="3AEDE5"/>
                 </a:solidFill>
@@ -3495,7 +3539,7 @@
               <a:t>•  </a:t>
             </a:r>
             <a:r>
-              <a:rPr sz="1000" b="0" i="0">
+              <a:rPr sz="1200" b="0" i="0">
                 <a:solidFill>
                   <a:srgbClr val="FFFFFF"/>
                 </a:solidFill>
@@ -3514,7 +3558,7 @@
               </a:spcAft>
             </a:pPr>
             <a:r>
-              <a:rPr sz="1100" b="1" i="0">
+              <a:rPr sz="1300" b="1" i="0">
                 <a:solidFill>
                   <a:srgbClr val="3AEDE5"/>
                 </a:solidFill>
@@ -3530,7 +3574,7 @@
               </a:spcAft>
             </a:pPr>
             <a:r>
-              <a:rPr sz="1000" b="1" i="0">
+              <a:rPr sz="1200" b="1" i="0">
                 <a:solidFill>
                   <a:srgbClr val="3AEDE5"/>
                 </a:solidFill>
@@ -3539,7 +3583,7 @@
               <a:t>2024  </a:t>
             </a:r>
             <a:r>
-              <a:rPr sz="1000" b="1" i="0">
+              <a:rPr sz="1200" b="1" i="0">
                 <a:solidFill>
                   <a:srgbClr val="FFFFFF"/>
                 </a:solidFill>
@@ -3555,13 +3599,13 @@
               </a:spcAft>
             </a:pPr>
             <a:r>
-              <a:rPr sz="1000" b="0" i="1">
+              <a:rPr sz="1200" b="0" i="1">
                 <a:solidFill>
                   <a:srgbClr val="CCD6E8"/>
                 </a:solidFill>
                 <a:latin typeface="Alegreya Sans"/>
               </a:rPr>
-              <a:t>Certification Digital Ethics Officer (avec Me…</a:t>
+              <a:t>Certification Digital Ethics Officer (av…</a:t>
             </a:r>
           </a:p>
           <a:p>
@@ -3571,7 +3615,7 @@
               </a:spcAft>
             </a:pPr>
             <a:r>
-              <a:rPr sz="1000" b="1" i="0">
+              <a:rPr sz="1200" b="1" i="0">
                 <a:solidFill>
                   <a:srgbClr val="3AEDE5"/>
                 </a:solidFill>
@@ -3580,7 +3624,7 @@
               <a:t>2015 — 2020  </a:t>
             </a:r>
             <a:r>
-              <a:rPr sz="1000" b="1" i="0">
+              <a:rPr sz="1200" b="1" i="0">
                 <a:solidFill>
                   <a:srgbClr val="FFFFFF"/>
                 </a:solidFill>
@@ -3596,13 +3640,13 @@
               </a:spcAft>
             </a:pPr>
             <a:r>
-              <a:rPr sz="1000" b="0" i="1">
+              <a:rPr sz="1200" b="0" i="1">
                 <a:solidFill>
                   <a:srgbClr val="CCD6E8"/>
                 </a:solidFill>
                 <a:latin typeface="Alegreya Sans"/>
               </a:rPr>
-              <a:t>Master II Affaires européennes et internation…</a:t>
+              <a:t>Master II Affaires européennes et intern…</a:t>
             </a:r>
           </a:p>
           <a:p>
@@ -3612,7 +3656,7 @@
               </a:spcAft>
             </a:pPr>
             <a:r>
-              <a:rPr sz="1000" b="1" i="0">
+              <a:rPr sz="1200" b="1" i="0">
                 <a:solidFill>
                   <a:srgbClr val="3AEDE5"/>
                 </a:solidFill>
@@ -3621,7 +3665,7 @@
               <a:t>2020  </a:t>
             </a:r>
             <a:r>
-              <a:rPr sz="1000" b="1" i="0">
+              <a:rPr sz="1200" b="1" i="0">
                 <a:solidFill>
                   <a:srgbClr val="FFFFFF"/>
                 </a:solidFill>
@@ -3637,13 +3681,13 @@
               </a:spcAft>
             </a:pPr>
             <a:r>
-              <a:rPr sz="1000" b="0" i="1">
+              <a:rPr sz="1200" b="0" i="1">
                 <a:solidFill>
                   <a:srgbClr val="CCD6E8"/>
                 </a:solidFill>
                 <a:latin typeface="Alegreya Sans"/>
               </a:rPr>
-              <a:t>Master II Influence &amp; Affaires publiques (ave…</a:t>
+              <a:t>Master II Influence &amp; Affaires publiques…</a:t>
             </a:r>
           </a:p>
           <a:p>
@@ -3656,7 +3700,7 @@
               </a:spcAft>
             </a:pPr>
             <a:r>
-              <a:rPr sz="1100" b="1" i="0">
+              <a:rPr sz="1300" b="1" i="0">
                 <a:solidFill>
                   <a:srgbClr val="3AEDE5"/>
                 </a:solidFill>
@@ -3672,7 +3716,7 @@
               </a:spcAft>
             </a:pPr>
             <a:r>
-              <a:rPr sz="1000" b="1" i="0">
+              <a:rPr sz="1200" b="1" i="0">
                 <a:solidFill>
                   <a:srgbClr val="3AEDE5"/>
                 </a:solidFill>
@@ -3681,7 +3725,7 @@
               <a:t>• </a:t>
             </a:r>
             <a:r>
-              <a:rPr sz="1000" b="1" i="0">
+              <a:rPr sz="1200" b="1" i="0">
                 <a:solidFill>
                   <a:srgbClr val="FFFFFF"/>
                 </a:solidFill>
@@ -3690,13 +3734,13 @@
               <a:t>Conseiller Numérique</a:t>
             </a:r>
             <a:r>
-              <a:rPr sz="1000" b="0" i="1">
+              <a:rPr sz="1200" b="0" i="1">
                 <a:solidFill>
                   <a:srgbClr val="CCD6E8"/>
                 </a:solidFill>
                 <a:latin typeface="Alegreya Sans"/>
               </a:rPr>
-              <a:t> — Bénévole au sein du Conseil du Numérique…</a:t>
+              <a:t> — Bénévole au sein du Conseil du Numé…</a:t>
             </a:r>
           </a:p>
           <a:p>
@@ -3706,7 +3750,7 @@
               </a:spcAft>
             </a:pPr>
             <a:r>
-              <a:rPr sz="1000" b="1" i="0">
+              <a:rPr sz="1200" b="1" i="0">
                 <a:solidFill>
                   <a:srgbClr val="3AEDE5"/>
                 </a:solidFill>
@@ -3715,7 +3759,7 @@
               <a:t>• </a:t>
             </a:r>
             <a:r>
-              <a:rPr sz="1000" b="1" i="0">
+              <a:rPr sz="1200" b="1" i="0">
                 <a:solidFill>
                   <a:srgbClr val="FFFFFF"/>
                 </a:solidFill>
@@ -3724,13 +3768,13 @@
               <a:t>Podcasteur</a:t>
             </a:r>
             <a:r>
-              <a:rPr sz="1000" b="0" i="1">
+              <a:rPr sz="1200" b="0" i="1">
                 <a:solidFill>
                   <a:srgbClr val="CCD6E8"/>
                 </a:solidFill>
                 <a:latin typeface="Alegreya Sans"/>
               </a:rPr>
-              <a:t> — Créateur et animateur d'un podcast sur l…</a:t>
+              <a:t> — Créateur et animateur d'un podcast…</a:t>
             </a:r>
           </a:p>
           <a:p>
@@ -3740,7 +3784,7 @@
               </a:spcAft>
             </a:pPr>
             <a:r>
-              <a:rPr sz="1000" b="1" i="0">
+              <a:rPr sz="1200" b="1" i="0">
                 <a:solidFill>
                   <a:srgbClr val="3AEDE5"/>
                 </a:solidFill>
@@ -3749,7 +3793,7 @@
               <a:t>• </a:t>
             </a:r>
             <a:r>
-              <a:rPr sz="1000" b="1" i="0">
+              <a:rPr sz="1200" b="1" i="0">
                 <a:solidFill>
                   <a:srgbClr val="FFFFFF"/>
                 </a:solidFill>
@@ -3758,20 +3802,20 @@
               <a:t>Conférencier</a:t>
             </a:r>
             <a:r>
-              <a:rPr sz="1000" b="0" i="1">
+              <a:rPr sz="1200" b="0" i="1">
                 <a:solidFill>
                   <a:srgbClr val="CCD6E8"/>
                 </a:solidFill>
                 <a:latin typeface="Alegreya Sans"/>
               </a:rPr>
-              <a:t> — Intervenant sur l'IA et ses enjeux (écol…</a:t>
-            </a:r>
-          </a:p>
-        </p:txBody>
-      </p:sp>
-      <p:sp>
-        <p:nvSpPr>
-          <p:cNvPr id="7" name="TextBox 6"/>
+              <a:t> — Intervenant sur l'IA et ses enjeux…</a:t>
+            </a:r>
+          </a:p>
+        </p:txBody>
+      </p:sp>
+      <p:sp>
+        <p:nvSpPr>
+          <p:cNvPr id="8" name="TextBox 7"/>
           <p:cNvSpPr txBox="1"/>
           <p:nvPr/>
         </p:nvSpPr>
@@ -3797,7 +3841,7 @@
               </a:spcAft>
             </a:pPr>
             <a:r>
-              <a:rPr sz="1100" b="1" i="0">
+              <a:rPr sz="1300" b="1" i="0">
                 <a:solidFill>
                   <a:srgbClr val="3AEDE5"/>
                 </a:solidFill>
@@ -3813,13 +3857,13 @@
               </a:spcAft>
             </a:pPr>
             <a:r>
-              <a:rPr sz="1000" b="0" i="0">
-                <a:solidFill>
-                  <a:srgbClr val="FFFFFF"/>
-                </a:solidFill>
-                <a:latin typeface="Alegreya Sans"/>
-              </a:rPr>
-              <a:t>Expert en gouvernance de l'IA, AI Risk Management et conformité réglementaire, avec près de 8 ans d'expérience auprès de grandes institutions bancaires. Spécialisé dans l'EU AI Act et le déploiement de dispositifs de gou…</a:t>
+              <a:rPr sz="1200" b="0" i="0">
+                <a:solidFill>
+                  <a:srgbClr val="FFFFFF"/>
+                </a:solidFill>
+                <a:latin typeface="Alegreya Sans"/>
+              </a:rPr>
+              <a:t>Expert en gouvernance de l'IA, AI Risk Management et conformité réglementaire, avec près de 8 ans d'expérience auprès de grandes institutions bancaires. Spécialisé dans l'EU AI Act et le déploiement d…</a:t>
             </a:r>
           </a:p>
           <a:p>
@@ -3832,7 +3876,7 @@
               </a:spcAft>
             </a:pPr>
             <a:r>
-              <a:rPr sz="1100" b="1" i="0">
+              <a:rPr sz="1300" b="1" i="0">
                 <a:solidFill>
                   <a:srgbClr val="3AEDE5"/>
                 </a:solidFill>
@@ -3848,7 +3892,7 @@
               </a:spcAft>
             </a:pPr>
             <a:r>
-              <a:rPr sz="1000" b="1" i="0">
+              <a:rPr sz="1200" b="1" i="0">
                 <a:solidFill>
                   <a:srgbClr val="3AEDE5"/>
                 </a:solidFill>
@@ -3857,7 +3901,7 @@
               <a:t>▸ </a:t>
             </a:r>
             <a:r>
-              <a:rPr sz="1000" b="1" i="0">
+              <a:rPr sz="1200" b="1" i="0">
                 <a:solidFill>
                   <a:srgbClr val="FFFFFF"/>
                 </a:solidFill>
@@ -3866,7 +3910,7 @@
               <a:t>Top-tier CIB européenne</a:t>
             </a:r>
             <a:r>
-              <a:rPr sz="1000" b="0" i="0">
+              <a:rPr sz="1200" b="0" i="0">
                 <a:solidFill>
                   <a:srgbClr val="FFFFFF"/>
                 </a:solidFill>
@@ -3875,7 +3919,7 @@
               <a:t> — AI Compliance Lead (consultant)</a:t>
             </a:r>
             <a:r>
-              <a:rPr sz="1000" b="0" i="1">
+              <a:rPr sz="1200" b="0" i="1">
                 <a:solidFill>
                   <a:srgbClr val="3AEDE5"/>
                 </a:solidFill>
@@ -3891,7 +3935,7 @@
               </a:spcAft>
             </a:pPr>
             <a:r>
-              <a:rPr sz="1000" b="1" i="0">
+              <a:rPr sz="1200" b="1" i="0">
                 <a:solidFill>
                   <a:srgbClr val="3AEDE5"/>
                 </a:solidFill>
@@ -3900,13 +3944,13 @@
               <a:t>•  </a:t>
             </a:r>
             <a:r>
-              <a:rPr sz="1000" b="0" i="0">
-                <a:solidFill>
-                  <a:srgbClr val="FFFFFF"/>
-                </a:solidFill>
-                <a:latin typeface="Alegreya Sans"/>
-              </a:rPr>
-              <a:t>Finalisation et mise en œuvre du cadre de gouvernance des risques IA : politiques internes, cartographie des risques, comitologie et coordination des fonctions…</a:t>
+              <a:rPr sz="1200" b="0" i="0">
+                <a:solidFill>
+                  <a:srgbClr val="FFFFFF"/>
+                </a:solidFill>
+                <a:latin typeface="Alegreya Sans"/>
+              </a:rPr>
+              <a:t>Finalisation et mise en œuvre du cadre de gouvernance des risques IA : politiques internes, cartographie des risques, comitologie et coordin…</a:t>
             </a:r>
           </a:p>
           <a:p>
@@ -3916,7 +3960,7 @@
               </a:spcAft>
             </a:pPr>
             <a:r>
-              <a:rPr sz="1000" b="1" i="0">
+              <a:rPr sz="1200" b="1" i="0">
                 <a:solidFill>
                   <a:srgbClr val="3AEDE5"/>
                 </a:solidFill>
@@ -3925,7 +3969,7 @@
               <a:t>•  </a:t>
             </a:r>
             <a:r>
-              <a:rPr sz="1000" b="0" i="0">
+              <a:rPr sz="1200" b="0" i="0">
                 <a:solidFill>
                   <a:srgbClr val="FFFFFF"/>
                 </a:solidFill>
@@ -3941,7 +3985,7 @@
               </a:spcAft>
             </a:pPr>
             <a:r>
-              <a:rPr sz="1000" b="1" i="0">
+              <a:rPr sz="1200" b="1" i="0">
                 <a:solidFill>
                   <a:srgbClr val="3AEDE5"/>
                 </a:solidFill>
@@ -3950,7 +3994,7 @@
               <a:t>▸ </a:t>
             </a:r>
             <a:r>
-              <a:rPr sz="1000" b="1" i="0">
+              <a:rPr sz="1200" b="1" i="0">
                 <a:solidFill>
                   <a:srgbClr val="FFFFFF"/>
                 </a:solidFill>
@@ -3959,7 +4003,7 @@
               <a:t>Sia Partners</a:t>
             </a:r>
             <a:r>
-              <a:rPr sz="1000" b="0" i="0">
+              <a:rPr sz="1200" b="0" i="0">
                 <a:solidFill>
                   <a:srgbClr val="FFFFFF"/>
                 </a:solidFill>
@@ -3968,7 +4012,7 @@
               <a:t> — Associate Manager</a:t>
             </a:r>
             <a:r>
-              <a:rPr sz="1000" b="0" i="1">
+              <a:rPr sz="1200" b="0" i="1">
                 <a:solidFill>
                   <a:srgbClr val="3AEDE5"/>
                 </a:solidFill>
@@ -3984,7 +4028,7 @@
               </a:spcAft>
             </a:pPr>
             <a:r>
-              <a:rPr sz="1000" b="1" i="0">
+              <a:rPr sz="1200" b="1" i="0">
                 <a:solidFill>
                   <a:srgbClr val="3AEDE5"/>
                 </a:solidFill>
@@ -3993,13 +4037,13 @@
               <a:t>•  </a:t>
             </a:r>
             <a:r>
-              <a:rPr sz="1000" b="0" i="0">
-                <a:solidFill>
-                  <a:srgbClr val="FFFFFF"/>
-                </a:solidFill>
-                <a:latin typeface="Alegreya Sans"/>
-              </a:rPr>
-              <a:t>Responsable de l'offre AI Risk Management : coordination des réponses aux appels d'offres, veille stratégique et réglementaire, développement commercial et anim…</a:t>
+              <a:rPr sz="1200" b="0" i="0">
+                <a:solidFill>
+                  <a:srgbClr val="FFFFFF"/>
+                </a:solidFill>
+                <a:latin typeface="Alegreya Sans"/>
+              </a:rPr>
+              <a:t>Responsable de l'offre AI Risk Management : coordination des réponses aux appels d'offres, veille stratégique et réglementaire, développemen…</a:t>
             </a:r>
           </a:p>
           <a:p>
@@ -4009,7 +4053,7 @@
               </a:spcAft>
             </a:pPr>
             <a:r>
-              <a:rPr sz="1000" b="1" i="0">
+              <a:rPr sz="1200" b="1" i="0">
                 <a:solidFill>
                   <a:srgbClr val="3AEDE5"/>
                 </a:solidFill>
@@ -4018,13 +4062,13 @@
               <a:t>•  </a:t>
             </a:r>
             <a:r>
-              <a:rPr sz="1000" b="0" i="0">
-                <a:solidFill>
-                  <a:srgbClr val="FFFFFF"/>
-                </a:solidFill>
-                <a:latin typeface="Alegreya Sans"/>
-              </a:rPr>
-              <a:t>Pilotage et animation du groupe de travail IA de l'association Paris Europlace (+40 responsables du secteur financier) : rédaction de position papers et de répo…</a:t>
+              <a:rPr sz="1200" b="0" i="0">
+                <a:solidFill>
+                  <a:srgbClr val="FFFFFF"/>
+                </a:solidFill>
+                <a:latin typeface="Alegreya Sans"/>
+              </a:rPr>
+              <a:t>Pilotage et animation du groupe de travail IA de l'association Paris Europlace (+40 responsables du secteur financier) : rédaction de positi…</a:t>
             </a:r>
           </a:p>
           <a:p>
@@ -4034,7 +4078,7 @@
               </a:spcAft>
             </a:pPr>
             <a:r>
-              <a:rPr sz="1000" b="1" i="0">
+              <a:rPr sz="1200" b="1" i="0">
                 <a:solidFill>
                   <a:srgbClr val="3AEDE5"/>
                 </a:solidFill>
@@ -4043,7 +4087,7 @@
               <a:t>▸ </a:t>
             </a:r>
             <a:r>
-              <a:rPr sz="1000" b="1" i="0">
+              <a:rPr sz="1200" b="1" i="0">
                 <a:solidFill>
                   <a:srgbClr val="FFFFFF"/>
                 </a:solidFill>
@@ -4052,7 +4096,7 @@
               <a:t>Groupe BPCE</a:t>
             </a:r>
             <a:r>
-              <a:rPr sz="1000" b="0" i="0">
+              <a:rPr sz="1200" b="0" i="0">
                 <a:solidFill>
                   <a:srgbClr val="FFFFFF"/>
                 </a:solidFill>
@@ -4061,7 +4105,7 @@
               <a:t> — Group EU AI Act Project Manager</a:t>
             </a:r>
             <a:r>
-              <a:rPr sz="1000" b="0" i="1">
+              <a:rPr sz="1200" b="0" i="1">
                 <a:solidFill>
                   <a:srgbClr val="3AEDE5"/>
                 </a:solidFill>
@@ -4077,7 +4121,7 @@
               </a:spcAft>
             </a:pPr>
             <a:r>
-              <a:rPr sz="1000" b="1" i="0">
+              <a:rPr sz="1200" b="1" i="0">
                 <a:solidFill>
                   <a:srgbClr val="3AEDE5"/>
                 </a:solidFill>
@@ -4086,13 +4130,13 @@
               <a:t>•  </a:t>
             </a:r>
             <a:r>
-              <a:rPr sz="1000" b="0" i="0">
-                <a:solidFill>
-                  <a:srgbClr val="FFFFFF"/>
-                </a:solidFill>
-                <a:latin typeface="Alegreya Sans"/>
-              </a:rPr>
-              <a:t>Responsable du programme de mise en conformité EU AI Act du Groupe BPCE et de ses entités (Natixis, Oney, BRED, etc.) : cartographie et évaluation des risques I…</a:t>
+              <a:rPr sz="1200" b="0" i="0">
+                <a:solidFill>
+                  <a:srgbClr val="FFFFFF"/>
+                </a:solidFill>
+                <a:latin typeface="Alegreya Sans"/>
+              </a:rPr>
+              <a:t>Responsable du programme de mise en conformité EU AI Act du Groupe BPCE et de ses entités (Natixis, Oney, BRED, etc.) : cartographie et éval…</a:t>
             </a:r>
           </a:p>
           <a:p>
@@ -4102,7 +4146,7 @@
               </a:spcAft>
             </a:pPr>
             <a:r>
-              <a:rPr sz="1000" b="1" i="0">
+              <a:rPr sz="1200" b="1" i="0">
                 <a:solidFill>
                   <a:srgbClr val="3AEDE5"/>
                 </a:solidFill>
@@ -4111,13 +4155,13 @@
               <a:t>•  </a:t>
             </a:r>
             <a:r>
-              <a:rPr sz="1000" b="0" i="0">
-                <a:solidFill>
-                  <a:srgbClr val="FFFFFF"/>
-                </a:solidFill>
-                <a:latin typeface="Alegreya Sans"/>
-              </a:rPr>
-              <a:t>Coordination et accompagnement de plus de 35 décideurs locaux (DPO, Chief Compliance Officer, CDO, etc.) dans la déclinaison du cadre normatif Groupe.</a:t>
+              <a:rPr sz="1200" b="0" i="0">
+                <a:solidFill>
+                  <a:srgbClr val="FFFFFF"/>
+                </a:solidFill>
+                <a:latin typeface="Alegreya Sans"/>
+              </a:rPr>
+              <a:t>Coordination et accompagnement de plus de 35 décideurs locaux (DPO, Chief Compliance Officer, CDO, etc.) dans la déclinaison du cadre normat…</a:t>
             </a:r>
           </a:p>
           <a:p>
@@ -4127,7 +4171,7 @@
               </a:spcAft>
             </a:pPr>
             <a:r>
-              <a:rPr sz="1000" b="1" i="0">
+              <a:rPr sz="1200" b="1" i="0">
                 <a:solidFill>
                   <a:srgbClr val="3AEDE5"/>
                 </a:solidFill>
@@ -4136,7 +4180,7 @@
               <a:t>▸ </a:t>
             </a:r>
             <a:r>
-              <a:rPr sz="1000" b="1" i="0">
+              <a:rPr sz="1200" b="1" i="0">
                 <a:solidFill>
                   <a:srgbClr val="FFFFFF"/>
                 </a:solidFill>
@@ -4145,7 +4189,7 @@
               <a:t>Oney / Oneytrust</a:t>
             </a:r>
             <a:r>
-              <a:rPr sz="1000" b="0" i="0">
+              <a:rPr sz="1200" b="0" i="0">
                 <a:solidFill>
                   <a:srgbClr val="FFFFFF"/>
                 </a:solidFill>
@@ -4154,7 +4198,7 @@
               <a:t> — Expert Leader — Digital &amp; AI Compliance Officer</a:t>
             </a:r>
             <a:r>
-              <a:rPr sz="1000" b="0" i="1">
+              <a:rPr sz="1200" b="0" i="1">
                 <a:solidFill>
                   <a:srgbClr val="3AEDE5"/>
                 </a:solidFill>
@@ -4170,7 +4214,7 @@
               </a:spcAft>
             </a:pPr>
             <a:r>
-              <a:rPr sz="1000" b="1" i="0">
+              <a:rPr sz="1200" b="1" i="0">
                 <a:solidFill>
                   <a:srgbClr val="3AEDE5"/>
                 </a:solidFill>
@@ -4179,13 +4223,13 @@
               <a:t>•  </a:t>
             </a:r>
             <a:r>
-              <a:rPr sz="1000" b="0" i="0">
-                <a:solidFill>
-                  <a:srgbClr val="FFFFFF"/>
-                </a:solidFill>
-                <a:latin typeface="Alegreya Sans"/>
-              </a:rPr>
-              <a:t>Structuration du cadre de gouvernance des risques IA avec le Chief Data Officer : inventaire des systèmes, formation des référents métiers et pilotage de la con…</a:t>
+              <a:rPr sz="1200" b="0" i="0">
+                <a:solidFill>
+                  <a:srgbClr val="FFFFFF"/>
+                </a:solidFill>
+                <a:latin typeface="Alegreya Sans"/>
+              </a:rPr>
+              <a:t>Structuration du cadre de gouvernance des risques IA avec le Chief Data Officer : inventaire des systèmes, formation des référents métiers e…</a:t>
             </a:r>
           </a:p>
           <a:p>
@@ -4195,7 +4239,7 @@
               </a:spcAft>
             </a:pPr>
             <a:r>
-              <a:rPr sz="1000" b="1" i="0">
+              <a:rPr sz="1200" b="1" i="0">
                 <a:solidFill>
                   <a:srgbClr val="3AEDE5"/>
                 </a:solidFill>
@@ -4204,7 +4248,7 @@
               <a:t>•  </a:t>
             </a:r>
             <a:r>
-              <a:rPr sz="1000" b="0" i="0">
+              <a:rPr sz="1200" b="0" i="0">
                 <a:solidFill>
                   <a:srgbClr val="FFFFFF"/>
                 </a:solidFill>
@@ -4223,7 +4267,7 @@
               </a:spcAft>
             </a:pPr>
             <a:r>
-              <a:rPr sz="1100" b="1" i="0">
+              <a:rPr sz="1300" b="1" i="0">
                 <a:solidFill>
                   <a:srgbClr val="3AEDE5"/>
                 </a:solidFill>
@@ -4239,7 +4283,7 @@
               </a:spcAft>
             </a:pPr>
             <a:r>
-              <a:rPr sz="1000" b="0" i="1">
+              <a:rPr sz="1200" b="0" i="1">
                 <a:solidFill>
                   <a:srgbClr val="FFFFFF"/>
                 </a:solidFill>
@@ -4252,7 +4296,7 @@
       </p:sp>
       <p:sp>
         <p:nvSpPr>
-          <p:cNvPr id="8" name="TextBox 7"/>
+          <p:cNvPr id="9" name="TextBox 8"/>
           <p:cNvSpPr txBox="1"/>
           <p:nvPr/>
         </p:nvSpPr>
@@ -4274,7 +4318,7 @@
           <a:p>
             <a:pPr algn="ctr"/>
             <a:r>
-              <a:rPr sz="900" b="0" i="1">
+              <a:rPr sz="1000" b="0" i="1">
                 <a:solidFill>
                   <a:srgbClr val="CCD6E8"/>
                 </a:solidFill>
@@ -4324,10 +4368,10 @@
           <a:gradFill flip="none" rotWithShape="1">
             <a:gsLst>
               <a:gs pos="0">
-                <a:srgbClr val="0C2A8E"/>
+                <a:srgbClr val="07227A"/>
               </a:gs>
-              <a:gs pos="70000">
-                <a:srgbClr val="0C2A8E"/>
+              <a:gs pos="85000">
+                <a:srgbClr val="07227A"/>
               </a:gs>
               <a:gs pos="100000">
                 <a:srgbClr val="1FCBD9"/>
@@ -4373,7 +4417,7 @@
             <a:avLst/>
           </a:prstGeom>
           <a:solidFill>
-            <a:srgbClr val="071F66"/>
+            <a:srgbClr val="061A5E"/>
           </a:solidFill>
           <a:ln>
             <a:noFill/>
@@ -4404,7 +4448,51 @@
       </p:sp>
       <p:sp>
         <p:nvSpPr>
-          <p:cNvPr id="4" name="TextBox 3"/>
+          <p:cNvPr id="4" name="Rectangle 3"/>
+          <p:cNvSpPr/>
+          <p:nvPr/>
+        </p:nvSpPr>
+        <p:spPr>
+          <a:xfrm>
+            <a:off x="0" y="6578000"/>
+            <a:ext cx="12192000" cy="280000"/>
+          </a:xfrm>
+          <a:prstGeom prst="rect">
+            <a:avLst/>
+          </a:prstGeom>
+          <a:solidFill>
+            <a:srgbClr val="061A5E"/>
+          </a:solidFill>
+          <a:ln>
+            <a:noFill/>
+          </a:ln>
+          <a:effectLst/>
+        </p:spPr>
+        <p:style>
+          <a:lnRef idx="1">
+            <a:schemeClr val="accent1"/>
+          </a:lnRef>
+          <a:fillRef idx="3">
+            <a:schemeClr val="accent1"/>
+          </a:fillRef>
+          <a:effectRef idx="2">
+            <a:schemeClr val="accent1"/>
+          </a:effectRef>
+          <a:fontRef idx="minor">
+            <a:schemeClr val="lt1"/>
+          </a:fontRef>
+        </p:style>
+        <p:txBody>
+          <a:bodyPr rtlCol="0" anchor="ctr"/>
+          <a:lstStyle/>
+          <a:p>
+            <a:pPr algn="ctr"/>
+          </a:p>
+        </p:txBody>
+      </p:sp>
+      <p:sp>
+        <p:nvSpPr>
+          <p:cNvPr id="5" name="TextBox 4"/>
           <p:cNvSpPr txBox="1"/>
           <p:nvPr/>
         </p:nvSpPr>
@@ -4426,7 +4514,7 @@
           <a:p>
             <a:pPr algn="l"/>
             <a:r>
-              <a:rPr sz="4400" b="1" i="0">
+              <a:rPr sz="4800" b="1" i="0">
                 <a:solidFill>
                   <a:srgbClr val="3AEDE5"/>
                 </a:solidFill>
@@ -4439,7 +4527,7 @@
       </p:sp>
       <p:sp>
         <p:nvSpPr>
-          <p:cNvPr id="5" name="TextBox 4"/>
+          <p:cNvPr id="6" name="TextBox 5"/>
           <p:cNvSpPr txBox="1"/>
           <p:nvPr/>
         </p:nvSpPr>
@@ -4460,7 +4548,7 @@
           <a:lstStyle/>
           <a:p>
             <a:r>
-              <a:rPr sz="2000" b="1" i="0">
+              <a:rPr sz="2400" b="1" i="0">
                 <a:solidFill>
                   <a:srgbClr val="FFFFFF"/>
                 </a:solidFill>
@@ -4476,7 +4564,7 @@
               </a:spcBef>
             </a:pPr>
             <a:r>
-              <a:rPr sz="1300" b="0" i="1">
+              <a:rPr sz="1500" b="0" i="1">
                 <a:solidFill>
                   <a:srgbClr val="3AEDE5"/>
                 </a:solidFill>
@@ -4489,7 +4577,7 @@
       </p:sp>
       <p:sp>
         <p:nvSpPr>
-          <p:cNvPr id="6" name="TextBox 5"/>
+          <p:cNvPr id="7" name="TextBox 6"/>
           <p:cNvSpPr txBox="1"/>
           <p:nvPr/>
         </p:nvSpPr>
@@ -4515,7 +4603,7 @@
               </a:spcAft>
             </a:pPr>
             <a:r>
-              <a:rPr sz="1100" b="1" i="0">
+              <a:rPr sz="1300" b="1" i="0">
                 <a:solidFill>
                   <a:srgbClr val="3AEDE5"/>
                 </a:solidFill>
@@ -4531,7 +4619,7 @@
               </a:spcAft>
             </a:pPr>
             <a:r>
-              <a:rPr sz="1000" b="1" i="0">
+              <a:rPr sz="1200" b="1" i="0">
                 <a:solidFill>
                   <a:srgbClr val="3AEDE5"/>
                 </a:solidFill>
@@ -4540,7 +4628,7 @@
               <a:t>•  </a:t>
             </a:r>
             <a:r>
-              <a:rPr sz="1000" b="0" i="0">
+              <a:rPr sz="1200" b="0" i="0">
                 <a:solidFill>
                   <a:srgbClr val="FFFFFF"/>
                 </a:solidFill>
@@ -4556,7 +4644,7 @@
               </a:spcAft>
             </a:pPr>
             <a:r>
-              <a:rPr sz="1000" b="1" i="0">
+              <a:rPr sz="1200" b="1" i="0">
                 <a:solidFill>
                   <a:srgbClr val="3AEDE5"/>
                 </a:solidFill>
@@ -4565,7 +4653,7 @@
               <a:t>•  </a:t>
             </a:r>
             <a:r>
-              <a:rPr sz="1000" b="0" i="0">
+              <a:rPr sz="1200" b="0" i="0">
                 <a:solidFill>
                   <a:srgbClr val="FFFFFF"/>
                 </a:solidFill>
@@ -4581,7 +4669,7 @@
               </a:spcAft>
             </a:pPr>
             <a:r>
-              <a:rPr sz="1000" b="1" i="0">
+              <a:rPr sz="1200" b="1" i="0">
                 <a:solidFill>
                   <a:srgbClr val="3AEDE5"/>
                 </a:solidFill>
@@ -4590,7 +4678,7 @@
               <a:t>•  </a:t>
             </a:r>
             <a:r>
-              <a:rPr sz="1000" b="0" i="0">
+              <a:rPr sz="1200" b="0" i="0">
                 <a:solidFill>
                   <a:srgbClr val="FFFFFF"/>
                 </a:solidFill>
@@ -4606,7 +4694,7 @@
               </a:spcAft>
             </a:pPr>
             <a:r>
-              <a:rPr sz="1000" b="1" i="0">
+              <a:rPr sz="1200" b="1" i="0">
                 <a:solidFill>
                   <a:srgbClr val="3AEDE5"/>
                 </a:solidFill>
@@ -4615,7 +4703,7 @@
               <a:t>•  </a:t>
             </a:r>
             <a:r>
-              <a:rPr sz="1000" b="0" i="0">
+              <a:rPr sz="1200" b="0" i="0">
                 <a:solidFill>
                   <a:srgbClr val="FFFFFF"/>
                 </a:solidFill>
@@ -4631,7 +4719,7 @@
               </a:spcAft>
             </a:pPr>
             <a:r>
-              <a:rPr sz="1000" b="1" i="0">
+              <a:rPr sz="1200" b="1" i="0">
                 <a:solidFill>
                   <a:srgbClr val="3AEDE5"/>
                 </a:solidFill>
@@ -4640,7 +4728,7 @@
               <a:t>•  </a:t>
             </a:r>
             <a:r>
-              <a:rPr sz="1000" b="0" i="0">
+              <a:rPr sz="1200" b="0" i="0">
                 <a:solidFill>
                   <a:srgbClr val="FFFFFF"/>
                 </a:solidFill>
@@ -4659,7 +4747,7 @@
               </a:spcAft>
             </a:pPr>
             <a:r>
-              <a:rPr sz="1100" b="1" i="0">
+              <a:rPr sz="1300" b="1" i="0">
                 <a:solidFill>
                   <a:srgbClr val="3AEDE5"/>
                 </a:solidFill>
@@ -4675,7 +4763,7 @@
               </a:spcAft>
             </a:pPr>
             <a:r>
-              <a:rPr sz="1000" b="1" i="0">
+              <a:rPr sz="1200" b="1" i="0">
                 <a:solidFill>
                   <a:srgbClr val="3AEDE5"/>
                 </a:solidFill>
@@ -4684,7 +4772,7 @@
               <a:t>•  </a:t>
             </a:r>
             <a:r>
-              <a:rPr sz="1000" b="0" i="0">
+              <a:rPr sz="1200" b="0" i="0">
                 <a:solidFill>
                   <a:srgbClr val="FFFFFF"/>
                 </a:solidFill>
@@ -4700,7 +4788,7 @@
               </a:spcAft>
             </a:pPr>
             <a:r>
-              <a:rPr sz="1000" b="1" i="0">
+              <a:rPr sz="1200" b="1" i="0">
                 <a:solidFill>
                   <a:srgbClr val="3AEDE5"/>
                 </a:solidFill>
@@ -4709,7 +4797,7 @@
               <a:t>•  </a:t>
             </a:r>
             <a:r>
-              <a:rPr sz="1000" b="0" i="0">
+              <a:rPr sz="1200" b="0" i="0">
                 <a:solidFill>
                   <a:srgbClr val="FFFFFF"/>
                 </a:solidFill>
@@ -4728,7 +4816,7 @@
               </a:spcAft>
             </a:pPr>
             <a:r>
-              <a:rPr sz="1100" b="1" i="0">
+              <a:rPr sz="1300" b="1" i="0">
                 <a:solidFill>
                   <a:srgbClr val="3AEDE5"/>
                 </a:solidFill>
@@ -4744,7 +4832,7 @@
               </a:spcAft>
             </a:pPr>
             <a:r>
-              <a:rPr sz="1000" b="1" i="0">
+              <a:rPr sz="1200" b="1" i="0">
                 <a:solidFill>
                   <a:srgbClr val="3AEDE5"/>
                 </a:solidFill>
@@ -4753,7 +4841,7 @@
               <a:t>2024  </a:t>
             </a:r>
             <a:r>
-              <a:rPr sz="1000" b="1" i="0">
+              <a:rPr sz="1200" b="1" i="0">
                 <a:solidFill>
                   <a:srgbClr val="FFFFFF"/>
                 </a:solidFill>
@@ -4769,13 +4857,13 @@
               </a:spcAft>
             </a:pPr>
             <a:r>
-              <a:rPr sz="1000" b="0" i="1">
+              <a:rPr sz="1200" b="0" i="1">
                 <a:solidFill>
                   <a:srgbClr val="CCD6E8"/>
                 </a:solidFill>
                 <a:latin typeface="Alegreya Sans"/>
               </a:rPr>
-              <a:t>Digital Ethics Officer certification (with Di…</a:t>
+              <a:t>Digital Ethics Officer certification (wi…</a:t>
             </a:r>
           </a:p>
           <a:p>
@@ -4785,7 +4873,7 @@
               </a:spcAft>
             </a:pPr>
             <a:r>
-              <a:rPr sz="1000" b="1" i="0">
+              <a:rPr sz="1200" b="1" i="0">
                 <a:solidFill>
                   <a:srgbClr val="3AEDE5"/>
                 </a:solidFill>
@@ -4794,7 +4882,7 @@
               <a:t>2015 — 2020  </a:t>
             </a:r>
             <a:r>
-              <a:rPr sz="1000" b="1" i="0">
+              <a:rPr sz="1200" b="1" i="0">
                 <a:solidFill>
                   <a:srgbClr val="FFFFFF"/>
                 </a:solidFill>
@@ -4810,13 +4898,13 @@
               </a:spcAft>
             </a:pPr>
             <a:r>
-              <a:rPr sz="1000" b="0" i="1">
+              <a:rPr sz="1200" b="0" i="1">
                 <a:solidFill>
                   <a:srgbClr val="CCD6E8"/>
                 </a:solidFill>
                 <a:latin typeface="Alegreya Sans"/>
               </a:rPr>
-              <a:t>Master's in European &amp; International Affairs…</a:t>
+              <a:t>Master's in European &amp; International Aff…</a:t>
             </a:r>
           </a:p>
           <a:p>
@@ -4826,7 +4914,7 @@
               </a:spcAft>
             </a:pPr>
             <a:r>
-              <a:rPr sz="1000" b="1" i="0">
+              <a:rPr sz="1200" b="1" i="0">
                 <a:solidFill>
                   <a:srgbClr val="3AEDE5"/>
                 </a:solidFill>
@@ -4835,7 +4923,7 @@
               <a:t>2020  </a:t>
             </a:r>
             <a:r>
-              <a:rPr sz="1000" b="1" i="0">
+              <a:rPr sz="1200" b="1" i="0">
                 <a:solidFill>
                   <a:srgbClr val="FFFFFF"/>
                 </a:solidFill>
@@ -4851,13 +4939,13 @@
               </a:spcAft>
             </a:pPr>
             <a:r>
-              <a:rPr sz="1000" b="0" i="1">
+              <a:rPr sz="1200" b="0" i="1">
                 <a:solidFill>
                   <a:srgbClr val="CCD6E8"/>
                 </a:solidFill>
                 <a:latin typeface="Alegreya Sans"/>
               </a:rPr>
-              <a:t>Master's in Influence &amp; Public Affairs (with…</a:t>
+              <a:t>Master's in Influence &amp; Public Affairs (…</a:t>
             </a:r>
           </a:p>
           <a:p>
@@ -4870,7 +4958,7 @@
               </a:spcAft>
             </a:pPr>
             <a:r>
-              <a:rPr sz="1100" b="1" i="0">
+              <a:rPr sz="1300" b="1" i="0">
                 <a:solidFill>
                   <a:srgbClr val="3AEDE5"/>
                 </a:solidFill>
@@ -4886,7 +4974,7 @@
               </a:spcAft>
             </a:pPr>
             <a:r>
-              <a:rPr sz="1000" b="1" i="0">
+              <a:rPr sz="1200" b="1" i="0">
                 <a:solidFill>
                   <a:srgbClr val="3AEDE5"/>
                 </a:solidFill>
@@ -4895,7 +4983,7 @@
               <a:t>• </a:t>
             </a:r>
             <a:r>
-              <a:rPr sz="1000" b="1" i="0">
+              <a:rPr sz="1200" b="1" i="0">
                 <a:solidFill>
                   <a:srgbClr val="FFFFFF"/>
                 </a:solidFill>
@@ -4904,13 +4992,13 @@
               <a:t>Digital Council Advisor</a:t>
             </a:r>
             <a:r>
-              <a:rPr sz="1000" b="0" i="1">
+              <a:rPr sz="1200" b="0" i="1">
                 <a:solidFill>
                   <a:srgbClr val="CCD6E8"/>
                 </a:solidFill>
                 <a:latin typeface="Alegreya Sans"/>
               </a:rPr>
-              <a:t> — Volunteer at a local Digital Council (Yv…</a:t>
+              <a:t> — Volunteer at a local Digital Counci…</a:t>
             </a:r>
           </a:p>
           <a:p>
@@ -4920,7 +5008,7 @@
               </a:spcAft>
             </a:pPr>
             <a:r>
-              <a:rPr sz="1000" b="1" i="0">
+              <a:rPr sz="1200" b="1" i="0">
                 <a:solidFill>
                   <a:srgbClr val="3AEDE5"/>
                 </a:solidFill>
@@ -4929,7 +5017,7 @@
               <a:t>• </a:t>
             </a:r>
             <a:r>
-              <a:rPr sz="1000" b="1" i="0">
+              <a:rPr sz="1200" b="1" i="0">
                 <a:solidFill>
                   <a:srgbClr val="FFFFFF"/>
                 </a:solidFill>
@@ -4938,13 +5026,13 @@
               <a:t>Podcaster</a:t>
             </a:r>
             <a:r>
-              <a:rPr sz="1000" b="0" i="1">
+              <a:rPr sz="1200" b="0" i="1">
                 <a:solidFill>
                   <a:srgbClr val="CCD6E8"/>
                 </a:solidFill>
                 <a:latin typeface="Alegreya Sans"/>
               </a:rPr>
-              <a:t> — Creator and host of an AI podcast featur…</a:t>
+              <a:t> — Creator and host of an AI podcast f…</a:t>
             </a:r>
           </a:p>
           <a:p>
@@ -4954,7 +5042,7 @@
               </a:spcAft>
             </a:pPr>
             <a:r>
-              <a:rPr sz="1000" b="1" i="0">
+              <a:rPr sz="1200" b="1" i="0">
                 <a:solidFill>
                   <a:srgbClr val="3AEDE5"/>
                 </a:solidFill>
@@ -4963,7 +5051,7 @@
               <a:t>• </a:t>
             </a:r>
             <a:r>
-              <a:rPr sz="1000" b="1" i="0">
+              <a:rPr sz="1200" b="1" i="0">
                 <a:solidFill>
                   <a:srgbClr val="FFFFFF"/>
                 </a:solidFill>
@@ -4972,20 +5060,20 @@
               <a:t>Speaker</a:t>
             </a:r>
             <a:r>
-              <a:rPr sz="1000" b="0" i="1">
+              <a:rPr sz="1200" b="0" i="1">
                 <a:solidFill>
                   <a:srgbClr val="CCD6E8"/>
                 </a:solidFill>
                 <a:latin typeface="Alegreya Sans"/>
               </a:rPr>
-              <a:t> — Speaker on AI and its challenges (busine…</a:t>
-            </a:r>
-          </a:p>
-        </p:txBody>
-      </p:sp>
-      <p:sp>
-        <p:nvSpPr>
-          <p:cNvPr id="7" name="TextBox 6"/>
+              <a:t> — Speaker on AI and its challenges (b…</a:t>
+            </a:r>
+          </a:p>
+        </p:txBody>
+      </p:sp>
+      <p:sp>
+        <p:nvSpPr>
+          <p:cNvPr id="8" name="TextBox 7"/>
           <p:cNvSpPr txBox="1"/>
           <p:nvPr/>
         </p:nvSpPr>
@@ -5011,7 +5099,7 @@
               </a:spcAft>
             </a:pPr>
             <a:r>
-              <a:rPr sz="1100" b="1" i="0">
+              <a:rPr sz="1300" b="1" i="0">
                 <a:solidFill>
                   <a:srgbClr val="3AEDE5"/>
                 </a:solidFill>
@@ -5027,13 +5115,13 @@
               </a:spcAft>
             </a:pPr>
             <a:r>
-              <a:rPr sz="1000" b="0" i="0">
-                <a:solidFill>
-                  <a:srgbClr val="FFFFFF"/>
-                </a:solidFill>
-                <a:latin typeface="Alegreya Sans"/>
-              </a:rPr>
-              <a:t>Expert in AI Governance, AI Risk Management and regulatory compliance, with nearly 8 years of experience advising major banking institutions. Specialised in the EU AI Act and the international rollout of AI governance fr…</a:t>
+              <a:rPr sz="1200" b="0" i="0">
+                <a:solidFill>
+                  <a:srgbClr val="FFFFFF"/>
+                </a:solidFill>
+                <a:latin typeface="Alegreya Sans"/>
+              </a:rPr>
+              <a:t>Expert in AI Governance, AI Risk Management and regulatory compliance, with nearly 8 years of experience advising major banking institutions. Specialised in the EU AI Act and the international rollout…</a:t>
             </a:r>
           </a:p>
           <a:p>
@@ -5046,7 +5134,7 @@
               </a:spcAft>
             </a:pPr>
             <a:r>
-              <a:rPr sz="1100" b="1" i="0">
+              <a:rPr sz="1300" b="1" i="0">
                 <a:solidFill>
                   <a:srgbClr val="3AEDE5"/>
                 </a:solidFill>
@@ -5062,7 +5150,7 @@
               </a:spcAft>
             </a:pPr>
             <a:r>
-              <a:rPr sz="1000" b="1" i="0">
+              <a:rPr sz="1200" b="1" i="0">
                 <a:solidFill>
                   <a:srgbClr val="3AEDE5"/>
                 </a:solidFill>
@@ -5071,7 +5159,7 @@
               <a:t>▸ </a:t>
             </a:r>
             <a:r>
-              <a:rPr sz="1000" b="1" i="0">
+              <a:rPr sz="1200" b="1" i="0">
                 <a:solidFill>
                   <a:srgbClr val="FFFFFF"/>
                 </a:solidFill>
@@ -5080,7 +5168,7 @@
               <a:t>Top-tier European CIB</a:t>
             </a:r>
             <a:r>
-              <a:rPr sz="1000" b="0" i="0">
+              <a:rPr sz="1200" b="0" i="0">
                 <a:solidFill>
                   <a:srgbClr val="FFFFFF"/>
                 </a:solidFill>
@@ -5089,7 +5177,7 @@
               <a:t> — AI Compliance Lead (consultant)</a:t>
             </a:r>
             <a:r>
-              <a:rPr sz="1000" b="0" i="1">
+              <a:rPr sz="1200" b="0" i="1">
                 <a:solidFill>
                   <a:srgbClr val="3AEDE5"/>
                 </a:solidFill>
@@ -5105,7 +5193,7 @@
               </a:spcAft>
             </a:pPr>
             <a:r>
-              <a:rPr sz="1000" b="1" i="0">
+              <a:rPr sz="1200" b="1" i="0">
                 <a:solidFill>
                   <a:srgbClr val="3AEDE5"/>
                 </a:solidFill>
@@ -5114,13 +5202,13 @@
               <a:t>•  </a:t>
             </a:r>
             <a:r>
-              <a:rPr sz="1000" b="0" i="0">
-                <a:solidFill>
-                  <a:srgbClr val="FFFFFF"/>
-                </a:solidFill>
-                <a:latin typeface="Alegreya Sans"/>
-              </a:rPr>
-              <a:t>Finalisation and rollout of the AI risk governance framework: internal policies, risk mapping, committee design, coordination of support and business functions.</a:t>
+              <a:rPr sz="1200" b="0" i="0">
+                <a:solidFill>
+                  <a:srgbClr val="FFFFFF"/>
+                </a:solidFill>
+                <a:latin typeface="Alegreya Sans"/>
+              </a:rPr>
+              <a:t>Finalisation and rollout of the AI risk governance framework: internal policies, risk mapping, committee design, coordination of support and…</a:t>
             </a:r>
           </a:p>
           <a:p>
@@ -5130,7 +5218,7 @@
               </a:spcAft>
             </a:pPr>
             <a:r>
-              <a:rPr sz="1000" b="1" i="0">
+              <a:rPr sz="1200" b="1" i="0">
                 <a:solidFill>
                   <a:srgbClr val="3AEDE5"/>
                 </a:solidFill>
@@ -5139,7 +5227,7 @@
               <a:t>•  </a:t>
             </a:r>
             <a:r>
-              <a:rPr sz="1000" b="0" i="0">
+              <a:rPr sz="1200" b="0" i="0">
                 <a:solidFill>
                   <a:srgbClr val="FFFFFF"/>
                 </a:solidFill>
@@ -5155,7 +5243,7 @@
               </a:spcAft>
             </a:pPr>
             <a:r>
-              <a:rPr sz="1000" b="1" i="0">
+              <a:rPr sz="1200" b="1" i="0">
                 <a:solidFill>
                   <a:srgbClr val="3AEDE5"/>
                 </a:solidFill>
@@ -5164,7 +5252,7 @@
               <a:t>▸ </a:t>
             </a:r>
             <a:r>
-              <a:rPr sz="1000" b="1" i="0">
+              <a:rPr sz="1200" b="1" i="0">
                 <a:solidFill>
                   <a:srgbClr val="FFFFFF"/>
                 </a:solidFill>
@@ -5173,7 +5261,7 @@
               <a:t>Sia Partners</a:t>
             </a:r>
             <a:r>
-              <a:rPr sz="1000" b="0" i="0">
+              <a:rPr sz="1200" b="0" i="0">
                 <a:solidFill>
                   <a:srgbClr val="FFFFFF"/>
                 </a:solidFill>
@@ -5182,7 +5270,7 @@
               <a:t> — Associate Manager</a:t>
             </a:r>
             <a:r>
-              <a:rPr sz="1000" b="0" i="1">
+              <a:rPr sz="1200" b="0" i="1">
                 <a:solidFill>
                   <a:srgbClr val="3AEDE5"/>
                 </a:solidFill>
@@ -5198,7 +5286,7 @@
               </a:spcAft>
             </a:pPr>
             <a:r>
-              <a:rPr sz="1000" b="1" i="0">
+              <a:rPr sz="1200" b="1" i="0">
                 <a:solidFill>
                   <a:srgbClr val="3AEDE5"/>
                 </a:solidFill>
@@ -5207,13 +5295,13 @@
               <a:t>•  </a:t>
             </a:r>
             <a:r>
-              <a:rPr sz="1000" b="0" i="0">
-                <a:solidFill>
-                  <a:srgbClr val="FFFFFF"/>
-                </a:solidFill>
-                <a:latin typeface="Alegreya Sans"/>
-              </a:rPr>
-              <a:t>Head of the AI Risk Management offering: RFP coordination, strategic and regulatory watch, business development and financial-ecosystem animation.</a:t>
+              <a:rPr sz="1200" b="0" i="0">
+                <a:solidFill>
+                  <a:srgbClr val="FFFFFF"/>
+                </a:solidFill>
+                <a:latin typeface="Alegreya Sans"/>
+              </a:rPr>
+              <a:t>Head of the AI Risk Management offering: RFP coordination, strategic and regulatory watch, business development and financial-ecosystem anim…</a:t>
             </a:r>
           </a:p>
           <a:p>
@@ -5223,7 +5311,7 @@
               </a:spcAft>
             </a:pPr>
             <a:r>
-              <a:rPr sz="1000" b="1" i="0">
+              <a:rPr sz="1200" b="1" i="0">
                 <a:solidFill>
                   <a:srgbClr val="3AEDE5"/>
                 </a:solidFill>
@@ -5232,13 +5320,13 @@
               <a:t>•  </a:t>
             </a:r>
             <a:r>
-              <a:rPr sz="1000" b="0" i="0">
-                <a:solidFill>
-                  <a:srgbClr val="FFFFFF"/>
-                </a:solidFill>
-                <a:latin typeface="Alegreya Sans"/>
-              </a:rPr>
-              <a:t>Lead of the AI working group at Paris Europlace association (40+ senior financial-sector representatives): position papers, EU consultation responses, benchmark…</a:t>
+              <a:rPr sz="1200" b="0" i="0">
+                <a:solidFill>
+                  <a:srgbClr val="FFFFFF"/>
+                </a:solidFill>
+                <a:latin typeface="Alegreya Sans"/>
+              </a:rPr>
+              <a:t>Lead of the AI working group at Paris Europlace association (40+ senior financial-sector representatives): position papers, EU consultation…</a:t>
             </a:r>
           </a:p>
           <a:p>
@@ -5248,7 +5336,7 @@
               </a:spcAft>
             </a:pPr>
             <a:r>
-              <a:rPr sz="1000" b="1" i="0">
+              <a:rPr sz="1200" b="1" i="0">
                 <a:solidFill>
                   <a:srgbClr val="3AEDE5"/>
                 </a:solidFill>
@@ -5257,7 +5345,7 @@
               <a:t>▸ </a:t>
             </a:r>
             <a:r>
-              <a:rPr sz="1000" b="1" i="0">
+              <a:rPr sz="1200" b="1" i="0">
                 <a:solidFill>
                   <a:srgbClr val="FFFFFF"/>
                 </a:solidFill>
@@ -5266,7 +5354,7 @@
               <a:t>Groupe BPCE</a:t>
             </a:r>
             <a:r>
-              <a:rPr sz="1000" b="0" i="0">
+              <a:rPr sz="1200" b="0" i="0">
                 <a:solidFill>
                   <a:srgbClr val="FFFFFF"/>
                 </a:solidFill>
@@ -5275,7 +5363,7 @@
               <a:t> — Group EU AI Act Project Manager</a:t>
             </a:r>
             <a:r>
-              <a:rPr sz="1000" b="0" i="1">
+              <a:rPr sz="1200" b="0" i="1">
                 <a:solidFill>
                   <a:srgbClr val="3AEDE5"/>
                 </a:solidFill>
@@ -5291,7 +5379,7 @@
               </a:spcAft>
             </a:pPr>
             <a:r>
-              <a:rPr sz="1000" b="1" i="0">
+              <a:rPr sz="1200" b="1" i="0">
                 <a:solidFill>
                   <a:srgbClr val="3AEDE5"/>
                 </a:solidFill>
@@ -5300,13 +5388,13 @@
               <a:t>•  </a:t>
             </a:r>
             <a:r>
-              <a:rPr sz="1000" b="0" i="0">
-                <a:solidFill>
-                  <a:srgbClr val="FFFFFF"/>
-                </a:solidFill>
-                <a:latin typeface="Alegreya Sans"/>
-              </a:rPr>
-              <a:t>Lead of the EU AI Act compliance programme for Groupe BPCE and its entities (Natixis, Oney, BRED, etc.): AI risk mapping and assessment, definition of Group pol…</a:t>
+              <a:rPr sz="1200" b="0" i="0">
+                <a:solidFill>
+                  <a:srgbClr val="FFFFFF"/>
+                </a:solidFill>
+                <a:latin typeface="Alegreya Sans"/>
+              </a:rPr>
+              <a:t>Lead of the EU AI Act compliance programme for Groupe BPCE and its entities (Natixis, Oney, BRED, etc.): AI risk mapping and assessment, def…</a:t>
             </a:r>
           </a:p>
           <a:p>
@@ -5316,7 +5404,7 @@
               </a:spcAft>
             </a:pPr>
             <a:r>
-              <a:rPr sz="1000" b="1" i="0">
+              <a:rPr sz="1200" b="1" i="0">
                 <a:solidFill>
                   <a:srgbClr val="3AEDE5"/>
                 </a:solidFill>
@@ -5325,7 +5413,7 @@
               <a:t>•  </a:t>
             </a:r>
             <a:r>
-              <a:rPr sz="1000" b="0" i="0">
+              <a:rPr sz="1200" b="0" i="0">
                 <a:solidFill>
                   <a:srgbClr val="FFFFFF"/>
                 </a:solidFill>
@@ -5341,7 +5429,7 @@
               </a:spcAft>
             </a:pPr>
             <a:r>
-              <a:rPr sz="1000" b="1" i="0">
+              <a:rPr sz="1200" b="1" i="0">
                 <a:solidFill>
                   <a:srgbClr val="3AEDE5"/>
                 </a:solidFill>
@@ -5350,7 +5438,7 @@
               <a:t>▸ </a:t>
             </a:r>
             <a:r>
-              <a:rPr sz="1000" b="1" i="0">
+              <a:rPr sz="1200" b="1" i="0">
                 <a:solidFill>
                   <a:srgbClr val="FFFFFF"/>
                 </a:solidFill>
@@ -5359,7 +5447,7 @@
               <a:t>Oney / Oneytrust</a:t>
             </a:r>
             <a:r>
-              <a:rPr sz="1000" b="0" i="0">
+              <a:rPr sz="1200" b="0" i="0">
                 <a:solidFill>
                   <a:srgbClr val="FFFFFF"/>
                 </a:solidFill>
@@ -5368,7 +5456,7 @@
               <a:t> — Expert Leader — Digital &amp; AI Compliance Officer</a:t>
             </a:r>
             <a:r>
-              <a:rPr sz="1000" b="0" i="1">
+              <a:rPr sz="1200" b="0" i="1">
                 <a:solidFill>
                   <a:srgbClr val="3AEDE5"/>
                 </a:solidFill>
@@ -5384,7 +5472,7 @@
               </a:spcAft>
             </a:pPr>
             <a:r>
-              <a:rPr sz="1000" b="1" i="0">
+              <a:rPr sz="1200" b="1" i="0">
                 <a:solidFill>
                   <a:srgbClr val="3AEDE5"/>
                 </a:solidFill>
@@ -5393,13 +5481,13 @@
               <a:t>•  </a:t>
             </a:r>
             <a:r>
-              <a:rPr sz="1000" b="0" i="0">
-                <a:solidFill>
-                  <a:srgbClr val="FFFFFF"/>
-                </a:solidFill>
-                <a:latin typeface="Alegreya Sans"/>
-              </a:rPr>
-              <a:t>Built the AI risk governance framework with the Chief Data Officer: systems inventory, training of business reference owners, EU AI Act compliance pilot across…</a:t>
+              <a:rPr sz="1200" b="0" i="0">
+                <a:solidFill>
+                  <a:srgbClr val="FFFFFF"/>
+                </a:solidFill>
+                <a:latin typeface="Alegreya Sans"/>
+              </a:rPr>
+              <a:t>Built the AI risk governance framework with the Chief Data Officer: systems inventory, training of business reference owners, EU AI Act comp…</a:t>
             </a:r>
           </a:p>
           <a:p>
@@ -5409,7 +5497,7 @@
               </a:spcAft>
             </a:pPr>
             <a:r>
-              <a:rPr sz="1000" b="1" i="0">
+              <a:rPr sz="1200" b="1" i="0">
                 <a:solidFill>
                   <a:srgbClr val="3AEDE5"/>
                 </a:solidFill>
@@ -5418,7 +5506,7 @@
               <a:t>•  </a:t>
             </a:r>
             <a:r>
-              <a:rPr sz="1000" b="0" i="0">
+              <a:rPr sz="1200" b="0" i="0">
                 <a:solidFill>
                   <a:srgbClr val="FFFFFF"/>
                 </a:solidFill>
@@ -5437,7 +5525,7 @@
               </a:spcAft>
             </a:pPr>
             <a:r>
-              <a:rPr sz="1100" b="1" i="0">
+              <a:rPr sz="1300" b="1" i="0">
                 <a:solidFill>
                   <a:srgbClr val="3AEDE5"/>
                 </a:solidFill>
@@ -5453,7 +5541,7 @@
               </a:spcAft>
             </a:pPr>
             <a:r>
-              <a:rPr sz="1000" b="0" i="1">
+              <a:rPr sz="1200" b="0" i="1">
                 <a:solidFill>
                   <a:srgbClr val="FFFFFF"/>
                 </a:solidFill>
@@ -5466,7 +5554,7 @@
       </p:sp>
       <p:sp>
         <p:nvSpPr>
-          <p:cNvPr id="8" name="TextBox 7"/>
+          <p:cNvPr id="9" name="TextBox 8"/>
           <p:cNvSpPr txBox="1"/>
           <p:nvPr/>
         </p:nvSpPr>
@@ -5488,7 +5576,7 @@
           <a:p>
             <a:pPr algn="ctr"/>
             <a:r>
-              <a:rPr sz="900" b="0" i="1">
+              <a:rPr sz="1000" b="0" i="1">
                 <a:solidFill>
                   <a:srgbClr val="CCD6E8"/>
                 </a:solidFill>

</xml_diff>

<commit_message>
v5 — intégration logo Inside Circle (top-right)
- Rename du logo uploadé en nom canonique : assets/inside_circle_logo.png
- Renderer PPT : _build_logo() ajoute le logo en haut à droite des 2
  slides (FR + EN), hauteur 0.98" (masse visuelle alignée sur le bloc
  initiales), aspect ratio natif respecté.
- Title box du header réduit en largeur (via LOGO_RESERVE_W) pour
  laisser la place au logo sans collision.
- Preview HTML : logo embarqué en data URI base64 (autonome, pas de
  fetch externe).
- Fallback gracieux si le PNG est absent — pas de plantage.

Co-Authored-By: Claude Opus 4.7 <noreply@anthropic.com>
Claude-Session: https://claude.ai/code/session_01P34Y9PqaSyqWxj7EA7cQyd
</commit_message>
<xml_diff>
--- a/outputs/A.P._ai_governance.pptx
+++ b/outputs/A.P._ai_governance.pptx
@@ -3232,9 +3232,33 @@
           </a:p>
         </p:txBody>
       </p:sp>
-      <p:sp>
-        <p:nvSpPr>
-          <p:cNvPr id="5" name="TextBox 4"/>
+      <p:pic>
+        <p:nvPicPr>
+          <p:cNvPr id="5" name="Picture 4" descr="inside_circle_logo.png"/>
+          <p:cNvPicPr>
+            <a:picLocks noChangeAspect="1"/>
+          </p:cNvPicPr>
+          <p:nvPr/>
+        </p:nvPicPr>
+        <p:blipFill>
+          <a:blip r:embed="rId2"/>
+          <a:stretch>
+            <a:fillRect/>
+          </a:stretch>
+        </p:blipFill>
+        <p:spPr>
+          <a:xfrm>
+            <a:off x="11012000" y="200000"/>
+            <a:ext cx="900000" cy="900000"/>
+          </a:xfrm>
+          <a:prstGeom prst="rect">
+            <a:avLst/>
+          </a:prstGeom>
+        </p:spPr>
+      </p:pic>
+      <p:sp>
+        <p:nvSpPr>
+          <p:cNvPr id="6" name="TextBox 5"/>
           <p:cNvSpPr txBox="1"/>
           <p:nvPr/>
         </p:nvSpPr>
@@ -3269,14 +3293,14 @@
       </p:sp>
       <p:sp>
         <p:nvSpPr>
-          <p:cNvPr id="6" name="TextBox 5"/>
+          <p:cNvPr id="7" name="TextBox 6"/>
           <p:cNvSpPr txBox="1"/>
           <p:nvPr/>
         </p:nvSpPr>
         <p:spPr>
           <a:xfrm>
             <a:off x="4528600" y="300000"/>
-            <a:ext cx="7434800" cy="800000"/>
+            <a:ext cx="6333400" cy="800000"/>
           </a:xfrm>
           <a:prstGeom prst="rect">
             <a:avLst/>
@@ -3319,7 +3343,7 @@
       </p:sp>
       <p:sp>
         <p:nvSpPr>
-          <p:cNvPr id="7" name="TextBox 6"/>
+          <p:cNvPr id="8" name="TextBox 7"/>
           <p:cNvSpPr txBox="1"/>
           <p:nvPr/>
         </p:nvSpPr>
@@ -3815,7 +3839,7 @@
       </p:sp>
       <p:sp>
         <p:nvSpPr>
-          <p:cNvPr id="8" name="TextBox 7"/>
+          <p:cNvPr id="9" name="TextBox 8"/>
           <p:cNvSpPr txBox="1"/>
           <p:nvPr/>
         </p:nvSpPr>
@@ -4296,7 +4320,7 @@
       </p:sp>
       <p:sp>
         <p:nvSpPr>
-          <p:cNvPr id="9" name="TextBox 8"/>
+          <p:cNvPr id="10" name="TextBox 9"/>
           <p:cNvSpPr txBox="1"/>
           <p:nvPr/>
         </p:nvSpPr>
@@ -4490,9 +4514,33 @@
           </a:p>
         </p:txBody>
       </p:sp>
-      <p:sp>
-        <p:nvSpPr>
-          <p:cNvPr id="5" name="TextBox 4"/>
+      <p:pic>
+        <p:nvPicPr>
+          <p:cNvPr id="5" name="Picture 4" descr="inside_circle_logo.png"/>
+          <p:cNvPicPr>
+            <a:picLocks noChangeAspect="1"/>
+          </p:cNvPicPr>
+          <p:nvPr/>
+        </p:nvPicPr>
+        <p:blipFill>
+          <a:blip r:embed="rId2"/>
+          <a:stretch>
+            <a:fillRect/>
+          </a:stretch>
+        </p:blipFill>
+        <p:spPr>
+          <a:xfrm>
+            <a:off x="11012000" y="200000"/>
+            <a:ext cx="900000" cy="900000"/>
+          </a:xfrm>
+          <a:prstGeom prst="rect">
+            <a:avLst/>
+          </a:prstGeom>
+        </p:spPr>
+      </p:pic>
+      <p:sp>
+        <p:nvSpPr>
+          <p:cNvPr id="6" name="TextBox 5"/>
           <p:cNvSpPr txBox="1"/>
           <p:nvPr/>
         </p:nvSpPr>
@@ -4527,14 +4575,14 @@
       </p:sp>
       <p:sp>
         <p:nvSpPr>
-          <p:cNvPr id="6" name="TextBox 5"/>
+          <p:cNvPr id="7" name="TextBox 6"/>
           <p:cNvSpPr txBox="1"/>
           <p:nvPr/>
         </p:nvSpPr>
         <p:spPr>
           <a:xfrm>
             <a:off x="4528600" y="300000"/>
-            <a:ext cx="7434800" cy="800000"/>
+            <a:ext cx="6333400" cy="800000"/>
           </a:xfrm>
           <a:prstGeom prst="rect">
             <a:avLst/>
@@ -4577,7 +4625,7 @@
       </p:sp>
       <p:sp>
         <p:nvSpPr>
-          <p:cNvPr id="7" name="TextBox 6"/>
+          <p:cNvPr id="8" name="TextBox 7"/>
           <p:cNvSpPr txBox="1"/>
           <p:nvPr/>
         </p:nvSpPr>
@@ -5073,7 +5121,7 @@
       </p:sp>
       <p:sp>
         <p:nvSpPr>
-          <p:cNvPr id="8" name="TextBox 7"/>
+          <p:cNvPr id="9" name="TextBox 8"/>
           <p:cNvSpPr txBox="1"/>
           <p:nvPr/>
         </p:nvSpPr>
@@ -5554,7 +5602,7 @@
       </p:sp>
       <p:sp>
         <p:nvSpPr>
-          <p:cNvPr id="9" name="TextBox 8"/>
+          <p:cNvPr id="10" name="TextBox 9"/>
           <p:cNvSpPr txBox="1"/>
           <p:nvPr/>
         </p:nvSpPr>

</xml_diff>

<commit_message>
Add Inside Circle logo top-right + resize per spec
- Embed assets/inside_circle_logo.png in the top-right corner of every
  slide (FR + EN) via python-pptx add_picture. Aspect ratio preserved
  via PIL probe.
- Logo height calé sur le mockup client : ~0.58" (compact, à hauteur
  du titre, pas des initiales). Marge top/right ~0.22".
- Renamed uploaded asset to canonical name `inside_circle_logo.png`.
- Title text padding-right augmenté pour ne pas colliser le logo.
- HTML preview embeds logo as base64 data URI for autonomy.
- Graceful fallback if the file is missing.

Co-Authored-By: Claude Opus 4.7 <noreply@anthropic.com>
Claude-Session: https://claude.ai/code/session_01P34Y9PqaSyqWxj7EA7cQyd
</commit_message>
<xml_diff>
--- a/outputs/A.P._ai_governance.pptx
+++ b/outputs/A.P._ai_governance.pptx
@@ -3248,8 +3248,8 @@
         </p:blipFill>
         <p:spPr>
           <a:xfrm>
-            <a:off x="11012000" y="200000"/>
-            <a:ext cx="900000" cy="900000"/>
+            <a:off x="11462000" y="230000"/>
+            <a:ext cx="530000" cy="530000"/>
           </a:xfrm>
           <a:prstGeom prst="rect">
             <a:avLst/>
@@ -3300,7 +3300,7 @@
         <p:spPr>
           <a:xfrm>
             <a:off x="4528600" y="300000"/>
-            <a:ext cx="6333400" cy="800000"/>
+            <a:ext cx="6783400" cy="800000"/>
           </a:xfrm>
           <a:prstGeom prst="rect">
             <a:avLst/>
@@ -4530,8 +4530,8 @@
         </p:blipFill>
         <p:spPr>
           <a:xfrm>
-            <a:off x="11012000" y="200000"/>
-            <a:ext cx="900000" cy="900000"/>
+            <a:off x="11462000" y="230000"/>
+            <a:ext cx="530000" cy="530000"/>
           </a:xfrm>
           <a:prstGeom prst="rect">
             <a:avLst/>
@@ -4582,7 +4582,7 @@
         <p:spPr>
           <a:xfrm>
             <a:off x="4528600" y="300000"/>
-            <a:ext cx="6333400" cy="800000"/>
+            <a:ext cx="6783400" cy="800000"/>
           </a:xfrm>
           <a:prstGeom prst="rect">
             <a:avLst/>

</xml_diff>

<commit_message>
Logo v5.2 — crop PNG to content bbox + recalibrate placement
Cause racine du bug "logo trop bas / trop petit" :
le PNG fourni était un canvas 2048×2048 avec 78 % de padding
transparent autour du contenu réel (1395×450, aspect 3.1:1).
À hauteur 0.58", le logo visible ne faisait que 0.13".

Fix :
- Crop assets/inside_circle_logo.png à son alpha bbox (1395×450).
- LOGO_H = 0.46", LOGO_TOP = 0.14" (quasi flush au bord supérieur),
  LOGO_RIGHT_PAD = 0.25".
- LOGO_RESERVE_W bumpé à 1.86" pour absorber l'aspect horizontal
  et éviter la collision avec le titre.
- Preview HTML : height 40px, top 14px, title padding-right 160px.

Co-Authored-By: Claude Opus 4.7 <noreply@anthropic.com>
Claude-Session: https://claude.ai/code/session_01P34Y9PqaSyqWxj7EA7cQyd
</commit_message>
<xml_diff>
--- a/outputs/A.P._ai_governance.pptx
+++ b/outputs/A.P._ai_governance.pptx
@@ -3248,8 +3248,8 @@
         </p:blipFill>
         <p:spPr>
           <a:xfrm>
-            <a:off x="11462000" y="230000"/>
-            <a:ext cx="530000" cy="530000"/>
+            <a:off x="10660000" y="130000"/>
+            <a:ext cx="1302000" cy="420000"/>
           </a:xfrm>
           <a:prstGeom prst="rect">
             <a:avLst/>
@@ -3300,7 +3300,7 @@
         <p:spPr>
           <a:xfrm>
             <a:off x="4528600" y="300000"/>
-            <a:ext cx="6783400" cy="800000"/>
+            <a:ext cx="5963400" cy="800000"/>
           </a:xfrm>
           <a:prstGeom prst="rect">
             <a:avLst/>
@@ -4530,8 +4530,8 @@
         </p:blipFill>
         <p:spPr>
           <a:xfrm>
-            <a:off x="11462000" y="230000"/>
-            <a:ext cx="530000" cy="530000"/>
+            <a:off x="10660000" y="130000"/>
+            <a:ext cx="1302000" cy="420000"/>
           </a:xfrm>
           <a:prstGeom prst="rect">
             <a:avLst/>
@@ -4582,7 +4582,7 @@
         <p:spPr>
           <a:xfrm>
             <a:off x="4528600" y="300000"/>
-            <a:ext cx="6783400" cy="800000"/>
+            <a:ext cx="5963400" cy="800000"/>
           </a:xfrm>
           <a:prstGeom prst="rect">
             <a:avLst/>

</xml_diff>

<commit_message>
v6 — fond uniforme navy + séparateur cyan vertical
Le gradient diagonal a été retiré : fond NAVY_SIDEBAR plein-slide
pour maximiser le contraste du texte blanc. Un trait vertical en
CYAN_ACCENT (15 000 EMU ≈ 0.016") marque la frontière entre la
sidebar et la main column.

- theme.py : retire NAVY_DEEP / CYAN_SOFT / GRADIENT_STOPS,
  ajoute SEPARATOR_W.
- generate_cv.py : _build_background = solid NAVY_SIDEBAR ;
  _build_separator = rectangle cyan vertical ; _build_footer_mask
  conservé (sert de cap visuel pour masquer un éventuel débordement
  des textboxes en bas de slide).
- preview_html.py : background uniforme, border-right cyan sur la
  sidebar pour matérialiser le séparateur.

Co-Authored-By: Claude Opus 4.7 <noreply@anthropic.com>
Claude-Session: https://claude.ai/code/session_01P34Y9PqaSyqWxj7EA7cQyd
</commit_message>
<xml_diff>
--- a/outputs/A.P._ai_governance.pptx
+++ b/outputs/A.P._ai_governance.pptx
@@ -3103,61 +3103,6 @@
           <a:prstGeom prst="rect">
             <a:avLst/>
           </a:prstGeom>
-          <a:ln>
-            <a:noFill/>
-          </a:ln>
-          <a:effectLst/>
-          <a:gradFill flip="none" rotWithShape="1">
-            <a:gsLst>
-              <a:gs pos="0">
-                <a:srgbClr val="07227A"/>
-              </a:gs>
-              <a:gs pos="85000">
-                <a:srgbClr val="07227A"/>
-              </a:gs>
-              <a:gs pos="100000">
-                <a:srgbClr val="1FCBD9"/>
-              </a:gs>
-            </a:gsLst>
-            <a:lin ang="2700000" scaled="0"/>
-          </a:gradFill>
-        </p:spPr>
-        <p:style>
-          <a:lnRef idx="1">
-            <a:schemeClr val="accent1"/>
-          </a:lnRef>
-          <a:fillRef idx="3">
-            <a:schemeClr val="accent1"/>
-          </a:fillRef>
-          <a:effectRef idx="2">
-            <a:schemeClr val="accent1"/>
-          </a:effectRef>
-          <a:fontRef idx="minor">
-            <a:schemeClr val="lt1"/>
-          </a:fontRef>
-        </p:style>
-        <p:txBody>
-          <a:bodyPr rtlCol="0" anchor="ctr"/>
-          <a:lstStyle/>
-          <a:p>
-            <a:pPr algn="ctr"/>
-          </a:p>
-        </p:txBody>
-      </p:sp>
-      <p:sp>
-        <p:nvSpPr>
-          <p:cNvPr id="3" name="Rectangle 2"/>
-          <p:cNvSpPr/>
-          <p:nvPr/>
-        </p:nvSpPr>
-        <p:spPr>
-          <a:xfrm>
-            <a:off x="0" y="0"/>
-            <a:ext cx="4300000" cy="6858000"/>
-          </a:xfrm>
-          <a:prstGeom prst="rect">
-            <a:avLst/>
-          </a:prstGeom>
           <a:solidFill>
             <a:srgbClr val="061A5E"/>
           </a:solidFill>
@@ -3190,7 +3135,1137 @@
       </p:sp>
       <p:sp>
         <p:nvSpPr>
-          <p:cNvPr id="4" name="Rectangle 3"/>
+          <p:cNvPr id="3" name="Rectangle 2"/>
+          <p:cNvSpPr/>
+          <p:nvPr/>
+        </p:nvSpPr>
+        <p:spPr>
+          <a:xfrm>
+            <a:off x="4300000" y="0"/>
+            <a:ext cx="15000" cy="6858000"/>
+          </a:xfrm>
+          <a:prstGeom prst="rect">
+            <a:avLst/>
+          </a:prstGeom>
+          <a:solidFill>
+            <a:srgbClr val="3AEDE5"/>
+          </a:solidFill>
+          <a:ln>
+            <a:noFill/>
+          </a:ln>
+          <a:effectLst/>
+        </p:spPr>
+        <p:style>
+          <a:lnRef idx="1">
+            <a:schemeClr val="accent1"/>
+          </a:lnRef>
+          <a:fillRef idx="3">
+            <a:schemeClr val="accent1"/>
+          </a:fillRef>
+          <a:effectRef idx="2">
+            <a:schemeClr val="accent1"/>
+          </a:effectRef>
+          <a:fontRef idx="minor">
+            <a:schemeClr val="lt1"/>
+          </a:fontRef>
+        </p:style>
+        <p:txBody>
+          <a:bodyPr rtlCol="0" anchor="ctr"/>
+          <a:lstStyle/>
+          <a:p>
+            <a:pPr algn="ctr"/>
+          </a:p>
+        </p:txBody>
+      </p:sp>
+      <p:pic>
+        <p:nvPicPr>
+          <p:cNvPr id="4" name="Picture 3" descr="inside_circle_logo.png"/>
+          <p:cNvPicPr>
+            <a:picLocks noChangeAspect="1"/>
+          </p:cNvPicPr>
+          <p:nvPr/>
+        </p:nvPicPr>
+        <p:blipFill>
+          <a:blip r:embed="rId2"/>
+          <a:stretch>
+            <a:fillRect/>
+          </a:stretch>
+        </p:blipFill>
+        <p:spPr>
+          <a:xfrm>
+            <a:off x="10660000" y="130000"/>
+            <a:ext cx="1302000" cy="420000"/>
+          </a:xfrm>
+          <a:prstGeom prst="rect">
+            <a:avLst/>
+          </a:prstGeom>
+        </p:spPr>
+      </p:pic>
+      <p:sp>
+        <p:nvSpPr>
+          <p:cNvPr id="5" name="TextBox 4"/>
+          <p:cNvSpPr txBox="1"/>
+          <p:nvPr/>
+        </p:nvSpPr>
+        <p:spPr>
+          <a:xfrm>
+            <a:off x="228600" y="260000"/>
+            <a:ext cx="3842800" cy="800000"/>
+          </a:xfrm>
+          <a:prstGeom prst="rect">
+            <a:avLst/>
+          </a:prstGeom>
+          <a:noFill/>
+        </p:spPr>
+        <p:txBody>
+          <a:bodyPr wrap="square" lIns="0" rIns="0" tIns="0" bIns="0">
+            <a:spAutoFit/>
+          </a:bodyPr>
+          <a:lstStyle/>
+          <a:p>
+            <a:pPr algn="l"/>
+            <a:r>
+              <a:rPr sz="4800" b="1" i="0">
+                <a:solidFill>
+                  <a:srgbClr val="3AEDE5"/>
+                </a:solidFill>
+                <a:latin typeface="Alegreya Sans"/>
+              </a:rPr>
+              <a:t>A.P.</a:t>
+            </a:r>
+          </a:p>
+        </p:txBody>
+      </p:sp>
+      <p:sp>
+        <p:nvSpPr>
+          <p:cNvPr id="6" name="TextBox 5"/>
+          <p:cNvSpPr txBox="1"/>
+          <p:nvPr/>
+        </p:nvSpPr>
+        <p:spPr>
+          <a:xfrm>
+            <a:off x="4528600" y="300000"/>
+            <a:ext cx="5963400" cy="800000"/>
+          </a:xfrm>
+          <a:prstGeom prst="rect">
+            <a:avLst/>
+          </a:prstGeom>
+          <a:noFill/>
+        </p:spPr>
+        <p:txBody>
+          <a:bodyPr wrap="square" lIns="0" rIns="0" tIns="0" bIns="0">
+            <a:spAutoFit/>
+          </a:bodyPr>
+          <a:lstStyle/>
+          <a:p>
+            <a:r>
+              <a:rPr sz="2400" b="1" i="0">
+                <a:solidFill>
+                  <a:srgbClr val="FFFFFF"/>
+                </a:solidFill>
+                <a:latin typeface="Alegreya Sans"/>
+              </a:rPr>
+              <a:t>Spécialiste AI Governance, AI Risk &amp; EU AI Act</a:t>
+            </a:r>
+          </a:p>
+          <a:p>
+            <a:pPr>
+              <a:spcBef>
+                <a:spcPts val="200"/>
+              </a:spcBef>
+            </a:pPr>
+            <a:r>
+              <a:rPr sz="1500" b="0" i="1">
+                <a:solidFill>
+                  <a:srgbClr val="3AEDE5"/>
+                </a:solidFill>
+                <a:latin typeface="Alegreya Sans"/>
+              </a:rPr>
+              <a:t>Gouvernance IA &amp; Conformité réglementaire — Services financiers</a:t>
+            </a:r>
+          </a:p>
+        </p:txBody>
+      </p:sp>
+      <p:sp>
+        <p:nvSpPr>
+          <p:cNvPr id="7" name="TextBox 6"/>
+          <p:cNvSpPr txBox="1"/>
+          <p:nvPr/>
+        </p:nvSpPr>
+        <p:spPr>
+          <a:xfrm>
+            <a:off x="228600" y="1180000"/>
+            <a:ext cx="3842800" cy="5318000"/>
+          </a:xfrm>
+          <a:prstGeom prst="rect">
+            <a:avLst/>
+          </a:prstGeom>
+          <a:noFill/>
+        </p:spPr>
+        <p:txBody>
+          <a:bodyPr wrap="square" lIns="0" rIns="0" tIns="0" bIns="0">
+            <a:spAutoFit/>
+          </a:bodyPr>
+          <a:lstStyle/>
+          <a:p>
+            <a:pPr algn="l">
+              <a:spcAft>
+                <a:spcPts val="300"/>
+              </a:spcAft>
+            </a:pPr>
+            <a:r>
+              <a:rPr sz="1300" b="1" i="0">
+                <a:solidFill>
+                  <a:srgbClr val="3AEDE5"/>
+                </a:solidFill>
+                <a:latin typeface="Alegreya Sans"/>
+              </a:rPr>
+              <a:t>DOMAINES D'EXPERTISE</a:t>
+            </a:r>
+          </a:p>
+          <a:p>
+            <a:pPr algn="l">
+              <a:spcAft>
+                <a:spcPts val="100"/>
+              </a:spcAft>
+            </a:pPr>
+            <a:r>
+              <a:rPr sz="1200" b="1" i="0">
+                <a:solidFill>
+                  <a:srgbClr val="3AEDE5"/>
+                </a:solidFill>
+                <a:latin typeface="Alegreya Sans"/>
+              </a:rPr>
+              <a:t>•  </a:t>
+            </a:r>
+            <a:r>
+              <a:rPr sz="1200" b="0" i="0">
+                <a:solidFill>
+                  <a:srgbClr val="FFFFFF"/>
+                </a:solidFill>
+                <a:latin typeface="Alegreya Sans"/>
+              </a:rPr>
+              <a:t>AI Governance</a:t>
+            </a:r>
+          </a:p>
+          <a:p>
+            <a:pPr algn="l">
+              <a:spcAft>
+                <a:spcPts val="100"/>
+              </a:spcAft>
+            </a:pPr>
+            <a:r>
+              <a:rPr sz="1200" b="1" i="0">
+                <a:solidFill>
+                  <a:srgbClr val="3AEDE5"/>
+                </a:solidFill>
+                <a:latin typeface="Alegreya Sans"/>
+              </a:rPr>
+              <a:t>•  </a:t>
+            </a:r>
+            <a:r>
+              <a:rPr sz="1200" b="0" i="0">
+                <a:solidFill>
+                  <a:srgbClr val="FFFFFF"/>
+                </a:solidFill>
+                <a:latin typeface="Alegreya Sans"/>
+              </a:rPr>
+              <a:t>AI Risk Management</a:t>
+            </a:r>
+          </a:p>
+          <a:p>
+            <a:pPr algn="l">
+              <a:spcAft>
+                <a:spcPts val="100"/>
+              </a:spcAft>
+            </a:pPr>
+            <a:r>
+              <a:rPr sz="1200" b="1" i="0">
+                <a:solidFill>
+                  <a:srgbClr val="3AEDE5"/>
+                </a:solidFill>
+                <a:latin typeface="Alegreya Sans"/>
+              </a:rPr>
+              <a:t>•  </a:t>
+            </a:r>
+            <a:r>
+              <a:rPr sz="1200" b="0" i="0">
+                <a:solidFill>
+                  <a:srgbClr val="FFFFFF"/>
+                </a:solidFill>
+                <a:latin typeface="Alegreya Sans"/>
+              </a:rPr>
+              <a:t>EU AI Act</a:t>
+            </a:r>
+          </a:p>
+          <a:p>
+            <a:pPr algn="l">
+              <a:spcAft>
+                <a:spcPts val="100"/>
+              </a:spcAft>
+            </a:pPr>
+            <a:r>
+              <a:rPr sz="1200" b="1" i="0">
+                <a:solidFill>
+                  <a:srgbClr val="3AEDE5"/>
+                </a:solidFill>
+                <a:latin typeface="Alegreya Sans"/>
+              </a:rPr>
+              <a:t>•  </a:t>
+            </a:r>
+            <a:r>
+              <a:rPr sz="1200" b="0" i="0">
+                <a:solidFill>
+                  <a:srgbClr val="FFFFFF"/>
+                </a:solidFill>
+                <a:latin typeface="Alegreya Sans"/>
+              </a:rPr>
+              <a:t>Digital Compliance</a:t>
+            </a:r>
+          </a:p>
+          <a:p>
+            <a:pPr algn="l">
+              <a:spcAft>
+                <a:spcPts val="100"/>
+              </a:spcAft>
+            </a:pPr>
+            <a:r>
+              <a:rPr sz="1200" b="1" i="0">
+                <a:solidFill>
+                  <a:srgbClr val="3AEDE5"/>
+                </a:solidFill>
+                <a:latin typeface="Alegreya Sans"/>
+              </a:rPr>
+              <a:t>•  </a:t>
+            </a:r>
+            <a:r>
+              <a:rPr sz="1200" b="0" i="0">
+                <a:solidFill>
+                  <a:srgbClr val="FFFFFF"/>
+                </a:solidFill>
+                <a:latin typeface="Alegreya Sans"/>
+              </a:rPr>
+              <a:t>Regulatory Strategy</a:t>
+            </a:r>
+          </a:p>
+          <a:p>
+            <a:pPr algn="l">
+              <a:spcBef>
+                <a:spcPts val="600"/>
+              </a:spcBef>
+              <a:spcAft>
+                <a:spcPts val="300"/>
+              </a:spcAft>
+            </a:pPr>
+            <a:r>
+              <a:rPr sz="1300" b="1" i="0">
+                <a:solidFill>
+                  <a:srgbClr val="3AEDE5"/>
+                </a:solidFill>
+                <a:latin typeface="Alegreya Sans"/>
+              </a:rPr>
+              <a:t>LANGUES</a:t>
+            </a:r>
+          </a:p>
+          <a:p>
+            <a:pPr algn="l">
+              <a:spcAft>
+                <a:spcPts val="100"/>
+              </a:spcAft>
+            </a:pPr>
+            <a:r>
+              <a:rPr sz="1200" b="1" i="0">
+                <a:solidFill>
+                  <a:srgbClr val="3AEDE5"/>
+                </a:solidFill>
+                <a:latin typeface="Alegreya Sans"/>
+              </a:rPr>
+              <a:t>•  </a:t>
+            </a:r>
+            <a:r>
+              <a:rPr sz="1200" b="0" i="0">
+                <a:solidFill>
+                  <a:srgbClr val="FFFFFF"/>
+                </a:solidFill>
+                <a:latin typeface="Alegreya Sans"/>
+              </a:rPr>
+              <a:t>Français — Langue maternelle</a:t>
+            </a:r>
+          </a:p>
+          <a:p>
+            <a:pPr algn="l">
+              <a:spcAft>
+                <a:spcPts val="100"/>
+              </a:spcAft>
+            </a:pPr>
+            <a:r>
+              <a:rPr sz="1200" b="1" i="0">
+                <a:solidFill>
+                  <a:srgbClr val="3AEDE5"/>
+                </a:solidFill>
+                <a:latin typeface="Alegreya Sans"/>
+              </a:rPr>
+              <a:t>•  </a:t>
+            </a:r>
+            <a:r>
+              <a:rPr sz="1200" b="0" i="0">
+                <a:solidFill>
+                  <a:srgbClr val="FFFFFF"/>
+                </a:solidFill>
+                <a:latin typeface="Alegreya Sans"/>
+              </a:rPr>
+              <a:t>Anglais — TOEIC 955/990</a:t>
+            </a:r>
+          </a:p>
+          <a:p>
+            <a:pPr algn="l">
+              <a:spcBef>
+                <a:spcPts val="600"/>
+              </a:spcBef>
+              <a:spcAft>
+                <a:spcPts val="300"/>
+              </a:spcAft>
+            </a:pPr>
+            <a:r>
+              <a:rPr sz="1300" b="1" i="0">
+                <a:solidFill>
+                  <a:srgbClr val="3AEDE5"/>
+                </a:solidFill>
+                <a:latin typeface="Alegreya Sans"/>
+              </a:rPr>
+              <a:t>FORMATION &amp; CERTIFICATIONS</a:t>
+            </a:r>
+          </a:p>
+          <a:p>
+            <a:pPr algn="l">
+              <a:spcAft>
+                <a:spcPts val="100"/>
+              </a:spcAft>
+            </a:pPr>
+            <a:r>
+              <a:rPr sz="1200" b="1" i="0">
+                <a:solidFill>
+                  <a:srgbClr val="3AEDE5"/>
+                </a:solidFill>
+                <a:latin typeface="Alegreya Sans"/>
+              </a:rPr>
+              <a:t>2024  </a:t>
+            </a:r>
+            <a:r>
+              <a:rPr sz="1200" b="1" i="0">
+                <a:solidFill>
+                  <a:srgbClr val="FFFFFF"/>
+                </a:solidFill>
+                <a:latin typeface="Alegreya Sans"/>
+              </a:rPr>
+              <a:t>EDHEC Business School</a:t>
+            </a:r>
+          </a:p>
+          <a:p>
+            <a:pPr algn="l">
+              <a:spcAft>
+                <a:spcPts val="300"/>
+              </a:spcAft>
+            </a:pPr>
+            <a:r>
+              <a:rPr sz="1200" b="0" i="1">
+                <a:solidFill>
+                  <a:srgbClr val="CCD6E8"/>
+                </a:solidFill>
+                <a:latin typeface="Alegreya Sans"/>
+              </a:rPr>
+              <a:t>Certification Digital Ethics Officer (av…</a:t>
+            </a:r>
+          </a:p>
+          <a:p>
+            <a:pPr algn="l">
+              <a:spcAft>
+                <a:spcPts val="100"/>
+              </a:spcAft>
+            </a:pPr>
+            <a:r>
+              <a:rPr sz="1200" b="1" i="0">
+                <a:solidFill>
+                  <a:srgbClr val="3AEDE5"/>
+                </a:solidFill>
+                <a:latin typeface="Alegreya Sans"/>
+              </a:rPr>
+              <a:t>2015 — 2020  </a:t>
+            </a:r>
+            <a:r>
+              <a:rPr sz="1200" b="1" i="0">
+                <a:solidFill>
+                  <a:srgbClr val="FFFFFF"/>
+                </a:solidFill>
+                <a:latin typeface="Alegreya Sans"/>
+              </a:rPr>
+              <a:t>Sciences Po Saint-Germain-en-Laye</a:t>
+            </a:r>
+          </a:p>
+          <a:p>
+            <a:pPr algn="l">
+              <a:spcAft>
+                <a:spcPts val="300"/>
+              </a:spcAft>
+            </a:pPr>
+            <a:r>
+              <a:rPr sz="1200" b="0" i="1">
+                <a:solidFill>
+                  <a:srgbClr val="CCD6E8"/>
+                </a:solidFill>
+                <a:latin typeface="Alegreya Sans"/>
+              </a:rPr>
+              <a:t>Master II Affaires européennes et intern…</a:t>
+            </a:r>
+          </a:p>
+          <a:p>
+            <a:pPr algn="l">
+              <a:spcAft>
+                <a:spcPts val="100"/>
+              </a:spcAft>
+            </a:pPr>
+            <a:r>
+              <a:rPr sz="1200" b="1" i="0">
+                <a:solidFill>
+                  <a:srgbClr val="3AEDE5"/>
+                </a:solidFill>
+                <a:latin typeface="Alegreya Sans"/>
+              </a:rPr>
+              <a:t>2020  </a:t>
+            </a:r>
+            <a:r>
+              <a:rPr sz="1200" b="1" i="0">
+                <a:solidFill>
+                  <a:srgbClr val="FFFFFF"/>
+                </a:solidFill>
+                <a:latin typeface="Alegreya Sans"/>
+              </a:rPr>
+              <a:t>Université de Versailles Saint-Quentin-en-Yvelines</a:t>
+            </a:r>
+          </a:p>
+          <a:p>
+            <a:pPr algn="l">
+              <a:spcAft>
+                <a:spcPts val="300"/>
+              </a:spcAft>
+            </a:pPr>
+            <a:r>
+              <a:rPr sz="1200" b="0" i="1">
+                <a:solidFill>
+                  <a:srgbClr val="CCD6E8"/>
+                </a:solidFill>
+                <a:latin typeface="Alegreya Sans"/>
+              </a:rPr>
+              <a:t>Master II Influence &amp; Affaires publiques…</a:t>
+            </a:r>
+          </a:p>
+          <a:p>
+            <a:pPr algn="l">
+              <a:spcBef>
+                <a:spcPts val="600"/>
+              </a:spcBef>
+              <a:spcAft>
+                <a:spcPts val="300"/>
+              </a:spcAft>
+            </a:pPr>
+            <a:r>
+              <a:rPr sz="1300" b="1" i="0">
+                <a:solidFill>
+                  <a:srgbClr val="3AEDE5"/>
+                </a:solidFill>
+                <a:latin typeface="Alegreya Sans"/>
+              </a:rPr>
+              <a:t>ENGAGEMENTS &amp; RÉALISATIONS</a:t>
+            </a:r>
+          </a:p>
+          <a:p>
+            <a:pPr algn="l">
+              <a:spcAft>
+                <a:spcPts val="200"/>
+              </a:spcAft>
+            </a:pPr>
+            <a:r>
+              <a:rPr sz="1200" b="1" i="0">
+                <a:solidFill>
+                  <a:srgbClr val="3AEDE5"/>
+                </a:solidFill>
+                <a:latin typeface="Alegreya Sans"/>
+              </a:rPr>
+              <a:t>• </a:t>
+            </a:r>
+            <a:r>
+              <a:rPr sz="1200" b="1" i="0">
+                <a:solidFill>
+                  <a:srgbClr val="FFFFFF"/>
+                </a:solidFill>
+                <a:latin typeface="Alegreya Sans"/>
+              </a:rPr>
+              <a:t>Conseiller Numérique</a:t>
+            </a:r>
+            <a:r>
+              <a:rPr sz="1200" b="0" i="1">
+                <a:solidFill>
+                  <a:srgbClr val="CCD6E8"/>
+                </a:solidFill>
+                <a:latin typeface="Alegreya Sans"/>
+              </a:rPr>
+              <a:t> — Bénévole au sein du Conseil du Numé…</a:t>
+            </a:r>
+          </a:p>
+          <a:p>
+            <a:pPr algn="l">
+              <a:spcAft>
+                <a:spcPts val="200"/>
+              </a:spcAft>
+            </a:pPr>
+            <a:r>
+              <a:rPr sz="1200" b="1" i="0">
+                <a:solidFill>
+                  <a:srgbClr val="3AEDE5"/>
+                </a:solidFill>
+                <a:latin typeface="Alegreya Sans"/>
+              </a:rPr>
+              <a:t>• </a:t>
+            </a:r>
+            <a:r>
+              <a:rPr sz="1200" b="1" i="0">
+                <a:solidFill>
+                  <a:srgbClr val="FFFFFF"/>
+                </a:solidFill>
+                <a:latin typeface="Alegreya Sans"/>
+              </a:rPr>
+              <a:t>Podcasteur</a:t>
+            </a:r>
+            <a:r>
+              <a:rPr sz="1200" b="0" i="1">
+                <a:solidFill>
+                  <a:srgbClr val="CCD6E8"/>
+                </a:solidFill>
+                <a:latin typeface="Alegreya Sans"/>
+              </a:rPr>
+              <a:t> — Créateur et animateur d'un podcast…</a:t>
+            </a:r>
+          </a:p>
+          <a:p>
+            <a:pPr algn="l">
+              <a:spcAft>
+                <a:spcPts val="200"/>
+              </a:spcAft>
+            </a:pPr>
+            <a:r>
+              <a:rPr sz="1200" b="1" i="0">
+                <a:solidFill>
+                  <a:srgbClr val="3AEDE5"/>
+                </a:solidFill>
+                <a:latin typeface="Alegreya Sans"/>
+              </a:rPr>
+              <a:t>• </a:t>
+            </a:r>
+            <a:r>
+              <a:rPr sz="1200" b="1" i="0">
+                <a:solidFill>
+                  <a:srgbClr val="FFFFFF"/>
+                </a:solidFill>
+                <a:latin typeface="Alegreya Sans"/>
+              </a:rPr>
+              <a:t>Conférencier</a:t>
+            </a:r>
+            <a:r>
+              <a:rPr sz="1200" b="0" i="1">
+                <a:solidFill>
+                  <a:srgbClr val="CCD6E8"/>
+                </a:solidFill>
+                <a:latin typeface="Alegreya Sans"/>
+              </a:rPr>
+              <a:t> — Intervenant sur l'IA et ses enjeux…</a:t>
+            </a:r>
+          </a:p>
+        </p:txBody>
+      </p:sp>
+      <p:sp>
+        <p:nvSpPr>
+          <p:cNvPr id="8" name="TextBox 7"/>
+          <p:cNvSpPr txBox="1"/>
+          <p:nvPr/>
+        </p:nvSpPr>
+        <p:spPr>
+          <a:xfrm>
+            <a:off x="4528600" y="1180000"/>
+            <a:ext cx="7434800" cy="5318000"/>
+          </a:xfrm>
+          <a:prstGeom prst="rect">
+            <a:avLst/>
+          </a:prstGeom>
+          <a:noFill/>
+        </p:spPr>
+        <p:txBody>
+          <a:bodyPr wrap="square" lIns="0" rIns="0" tIns="0" bIns="0">
+            <a:spAutoFit/>
+          </a:bodyPr>
+          <a:lstStyle/>
+          <a:p>
+            <a:pPr algn="l">
+              <a:spcAft>
+                <a:spcPts val="300"/>
+              </a:spcAft>
+            </a:pPr>
+            <a:r>
+              <a:rPr sz="1300" b="1" i="0">
+                <a:solidFill>
+                  <a:srgbClr val="3AEDE5"/>
+                </a:solidFill>
+                <a:latin typeface="Alegreya Sans"/>
+              </a:rPr>
+              <a:t>RÉSUMÉ</a:t>
+            </a:r>
+          </a:p>
+          <a:p>
+            <a:pPr algn="l">
+              <a:spcAft>
+                <a:spcPts val="300"/>
+              </a:spcAft>
+            </a:pPr>
+            <a:r>
+              <a:rPr sz="1200" b="0" i="0">
+                <a:solidFill>
+                  <a:srgbClr val="FFFFFF"/>
+                </a:solidFill>
+                <a:latin typeface="Alegreya Sans"/>
+              </a:rPr>
+              <a:t>Expert en gouvernance de l'IA, AI Risk Management et conformité réglementaire, avec près de 8 ans d'expérience auprès de grandes institutions bancaires. Spécialisé dans l'EU AI Act et le déploiement d…</a:t>
+            </a:r>
+          </a:p>
+          <a:p>
+            <a:pPr algn="l">
+              <a:spcBef>
+                <a:spcPts val="600"/>
+              </a:spcBef>
+              <a:spcAft>
+                <a:spcPts val="300"/>
+              </a:spcAft>
+            </a:pPr>
+            <a:r>
+              <a:rPr sz="1300" b="1" i="0">
+                <a:solidFill>
+                  <a:srgbClr val="3AEDE5"/>
+                </a:solidFill>
+                <a:latin typeface="Alegreya Sans"/>
+              </a:rPr>
+              <a:t>EXPÉRIENCE PROFESSIONNELLE</a:t>
+            </a:r>
+          </a:p>
+          <a:p>
+            <a:pPr algn="l">
+              <a:spcAft>
+                <a:spcPts val="100"/>
+              </a:spcAft>
+            </a:pPr>
+            <a:r>
+              <a:rPr sz="1200" b="1" i="0">
+                <a:solidFill>
+                  <a:srgbClr val="3AEDE5"/>
+                </a:solidFill>
+                <a:latin typeface="Alegreya Sans"/>
+              </a:rPr>
+              <a:t>▸ </a:t>
+            </a:r>
+            <a:r>
+              <a:rPr sz="1200" b="1" i="0">
+                <a:solidFill>
+                  <a:srgbClr val="FFFFFF"/>
+                </a:solidFill>
+                <a:latin typeface="Alegreya Sans"/>
+              </a:rPr>
+              <a:t>Top-tier CIB européenne</a:t>
+            </a:r>
+            <a:r>
+              <a:rPr sz="1200" b="0" i="0">
+                <a:solidFill>
+                  <a:srgbClr val="FFFFFF"/>
+                </a:solidFill>
+                <a:latin typeface="Alegreya Sans"/>
+              </a:rPr>
+              <a:t> — AI Compliance Lead (consultant)</a:t>
+            </a:r>
+            <a:r>
+              <a:rPr sz="1200" b="0" i="1">
+                <a:solidFill>
+                  <a:srgbClr val="3AEDE5"/>
+                </a:solidFill>
+                <a:latin typeface="Alegreya Sans"/>
+              </a:rPr>
+              <a:t>  (8 mois — en cours)</a:t>
+            </a:r>
+          </a:p>
+          <a:p>
+            <a:pPr algn="l" lvl="1">
+              <a:spcAft>
+                <a:spcPts val="100"/>
+              </a:spcAft>
+            </a:pPr>
+            <a:r>
+              <a:rPr sz="1200" b="1" i="0">
+                <a:solidFill>
+                  <a:srgbClr val="3AEDE5"/>
+                </a:solidFill>
+                <a:latin typeface="Alegreya Sans"/>
+              </a:rPr>
+              <a:t>•  </a:t>
+            </a:r>
+            <a:r>
+              <a:rPr sz="1200" b="0" i="0">
+                <a:solidFill>
+                  <a:srgbClr val="FFFFFF"/>
+                </a:solidFill>
+                <a:latin typeface="Alegreya Sans"/>
+              </a:rPr>
+              <a:t>Finalisation et mise en œuvre du cadre de gouvernance des risques IA : politiques internes, cartographie des risques, comitologie et coordin…</a:t>
+            </a:r>
+          </a:p>
+          <a:p>
+            <a:pPr algn="l" lvl="1">
+              <a:spcAft>
+                <a:spcPts val="100"/>
+              </a:spcAft>
+            </a:pPr>
+            <a:r>
+              <a:rPr sz="1200" b="1" i="0">
+                <a:solidFill>
+                  <a:srgbClr val="3AEDE5"/>
+                </a:solidFill>
+                <a:latin typeface="Alegreya Sans"/>
+              </a:rPr>
+              <a:t>•  </a:t>
+            </a:r>
+            <a:r>
+              <a:rPr sz="1200" b="0" i="0">
+                <a:solidFill>
+                  <a:srgbClr val="FFFFFF"/>
+                </a:solidFill>
+                <a:latin typeface="Alegreya Sans"/>
+              </a:rPr>
+              <a:t>Pilotage opérationnel de la gouvernance : identification, évaluation, priorisation, validation et remédiation des systèmes d'IA.</a:t>
+            </a:r>
+          </a:p>
+          <a:p>
+            <a:pPr algn="l">
+              <a:spcAft>
+                <a:spcPts val="100"/>
+              </a:spcAft>
+            </a:pPr>
+            <a:r>
+              <a:rPr sz="1200" b="1" i="0">
+                <a:solidFill>
+                  <a:srgbClr val="3AEDE5"/>
+                </a:solidFill>
+                <a:latin typeface="Alegreya Sans"/>
+              </a:rPr>
+              <a:t>▸ </a:t>
+            </a:r>
+            <a:r>
+              <a:rPr sz="1200" b="1" i="0">
+                <a:solidFill>
+                  <a:srgbClr val="FFFFFF"/>
+                </a:solidFill>
+                <a:latin typeface="Alegreya Sans"/>
+              </a:rPr>
+              <a:t>Sia Partners</a:t>
+            </a:r>
+            <a:r>
+              <a:rPr sz="1200" b="0" i="0">
+                <a:solidFill>
+                  <a:srgbClr val="FFFFFF"/>
+                </a:solidFill>
+                <a:latin typeface="Alegreya Sans"/>
+              </a:rPr>
+              <a:t> — Associate Manager</a:t>
+            </a:r>
+            <a:r>
+              <a:rPr sz="1200" b="0" i="1">
+                <a:solidFill>
+                  <a:srgbClr val="3AEDE5"/>
+                </a:solidFill>
+                <a:latin typeface="Alegreya Sans"/>
+              </a:rPr>
+              <a:t>  (10 mois — en cours)</a:t>
+            </a:r>
+          </a:p>
+          <a:p>
+            <a:pPr algn="l" lvl="1">
+              <a:spcAft>
+                <a:spcPts val="100"/>
+              </a:spcAft>
+            </a:pPr>
+            <a:r>
+              <a:rPr sz="1200" b="1" i="0">
+                <a:solidFill>
+                  <a:srgbClr val="3AEDE5"/>
+                </a:solidFill>
+                <a:latin typeface="Alegreya Sans"/>
+              </a:rPr>
+              <a:t>•  </a:t>
+            </a:r>
+            <a:r>
+              <a:rPr sz="1200" b="0" i="0">
+                <a:solidFill>
+                  <a:srgbClr val="FFFFFF"/>
+                </a:solidFill>
+                <a:latin typeface="Alegreya Sans"/>
+              </a:rPr>
+              <a:t>Responsable de l'offre AI Risk Management : coordination des réponses aux appels d'offres, veille stratégique et réglementaire, développemen…</a:t>
+            </a:r>
+          </a:p>
+          <a:p>
+            <a:pPr algn="l" lvl="1">
+              <a:spcAft>
+                <a:spcPts val="100"/>
+              </a:spcAft>
+            </a:pPr>
+            <a:r>
+              <a:rPr sz="1200" b="1" i="0">
+                <a:solidFill>
+                  <a:srgbClr val="3AEDE5"/>
+                </a:solidFill>
+                <a:latin typeface="Alegreya Sans"/>
+              </a:rPr>
+              <a:t>•  </a:t>
+            </a:r>
+            <a:r>
+              <a:rPr sz="1200" b="0" i="0">
+                <a:solidFill>
+                  <a:srgbClr val="FFFFFF"/>
+                </a:solidFill>
+                <a:latin typeface="Alegreya Sans"/>
+              </a:rPr>
+              <a:t>Pilotage et animation du groupe de travail IA de l'association Paris Europlace (+40 responsables du secteur financier) : rédaction de positi…</a:t>
+            </a:r>
+          </a:p>
+          <a:p>
+            <a:pPr algn="l">
+              <a:spcAft>
+                <a:spcPts val="100"/>
+              </a:spcAft>
+            </a:pPr>
+            <a:r>
+              <a:rPr sz="1200" b="1" i="0">
+                <a:solidFill>
+                  <a:srgbClr val="3AEDE5"/>
+                </a:solidFill>
+                <a:latin typeface="Alegreya Sans"/>
+              </a:rPr>
+              <a:t>▸ </a:t>
+            </a:r>
+            <a:r>
+              <a:rPr sz="1200" b="1" i="0">
+                <a:solidFill>
+                  <a:srgbClr val="FFFFFF"/>
+                </a:solidFill>
+                <a:latin typeface="Alegreya Sans"/>
+              </a:rPr>
+              <a:t>Groupe BPCE</a:t>
+            </a:r>
+            <a:r>
+              <a:rPr sz="1200" b="0" i="0">
+                <a:solidFill>
+                  <a:srgbClr val="FFFFFF"/>
+                </a:solidFill>
+                <a:latin typeface="Alegreya Sans"/>
+              </a:rPr>
+              <a:t> — Group EU AI Act Project Manager</a:t>
+            </a:r>
+            <a:r>
+              <a:rPr sz="1200" b="0" i="1">
+                <a:solidFill>
+                  <a:srgbClr val="3AEDE5"/>
+                </a:solidFill>
+                <a:latin typeface="Alegreya Sans"/>
+              </a:rPr>
+              <a:t>  (18 mois)</a:t>
+            </a:r>
+          </a:p>
+          <a:p>
+            <a:pPr algn="l" lvl="1">
+              <a:spcAft>
+                <a:spcPts val="100"/>
+              </a:spcAft>
+            </a:pPr>
+            <a:r>
+              <a:rPr sz="1200" b="1" i="0">
+                <a:solidFill>
+                  <a:srgbClr val="3AEDE5"/>
+                </a:solidFill>
+                <a:latin typeface="Alegreya Sans"/>
+              </a:rPr>
+              <a:t>•  </a:t>
+            </a:r>
+            <a:r>
+              <a:rPr sz="1200" b="0" i="0">
+                <a:solidFill>
+                  <a:srgbClr val="FFFFFF"/>
+                </a:solidFill>
+                <a:latin typeface="Alegreya Sans"/>
+              </a:rPr>
+              <a:t>Responsable du programme de mise en conformité EU AI Act du Groupe BPCE et de ses entités (Natixis, Oney, BRED, etc.) : cartographie et éval…</a:t>
+            </a:r>
+          </a:p>
+          <a:p>
+            <a:pPr algn="l" lvl="1">
+              <a:spcAft>
+                <a:spcPts val="100"/>
+              </a:spcAft>
+            </a:pPr>
+            <a:r>
+              <a:rPr sz="1200" b="1" i="0">
+                <a:solidFill>
+                  <a:srgbClr val="3AEDE5"/>
+                </a:solidFill>
+                <a:latin typeface="Alegreya Sans"/>
+              </a:rPr>
+              <a:t>•  </a:t>
+            </a:r>
+            <a:r>
+              <a:rPr sz="1200" b="0" i="0">
+                <a:solidFill>
+                  <a:srgbClr val="FFFFFF"/>
+                </a:solidFill>
+                <a:latin typeface="Alegreya Sans"/>
+              </a:rPr>
+              <a:t>Coordination et accompagnement de plus de 35 décideurs locaux (DPO, Chief Compliance Officer, CDO, etc.) dans la déclinaison du cadre normat…</a:t>
+            </a:r>
+          </a:p>
+          <a:p>
+            <a:pPr algn="l">
+              <a:spcAft>
+                <a:spcPts val="100"/>
+              </a:spcAft>
+            </a:pPr>
+            <a:r>
+              <a:rPr sz="1200" b="1" i="0">
+                <a:solidFill>
+                  <a:srgbClr val="3AEDE5"/>
+                </a:solidFill>
+                <a:latin typeface="Alegreya Sans"/>
+              </a:rPr>
+              <a:t>▸ </a:t>
+            </a:r>
+            <a:r>
+              <a:rPr sz="1200" b="1" i="0">
+                <a:solidFill>
+                  <a:srgbClr val="FFFFFF"/>
+                </a:solidFill>
+                <a:latin typeface="Alegreya Sans"/>
+              </a:rPr>
+              <a:t>Oney / Oneytrust</a:t>
+            </a:r>
+            <a:r>
+              <a:rPr sz="1200" b="0" i="0">
+                <a:solidFill>
+                  <a:srgbClr val="FFFFFF"/>
+                </a:solidFill>
+                <a:latin typeface="Alegreya Sans"/>
+              </a:rPr>
+              <a:t> — Expert Leader — Digital &amp; AI Compliance Officer</a:t>
+            </a:r>
+            <a:r>
+              <a:rPr sz="1200" b="0" i="1">
+                <a:solidFill>
+                  <a:srgbClr val="3AEDE5"/>
+                </a:solidFill>
+                <a:latin typeface="Alegreya Sans"/>
+              </a:rPr>
+              <a:t>  (38 mois)</a:t>
+            </a:r>
+          </a:p>
+          <a:p>
+            <a:pPr algn="l" lvl="1">
+              <a:spcAft>
+                <a:spcPts val="100"/>
+              </a:spcAft>
+            </a:pPr>
+            <a:r>
+              <a:rPr sz="1200" b="1" i="0">
+                <a:solidFill>
+                  <a:srgbClr val="3AEDE5"/>
+                </a:solidFill>
+                <a:latin typeface="Alegreya Sans"/>
+              </a:rPr>
+              <a:t>•  </a:t>
+            </a:r>
+            <a:r>
+              <a:rPr sz="1200" b="0" i="0">
+                <a:solidFill>
+                  <a:srgbClr val="FFFFFF"/>
+                </a:solidFill>
+                <a:latin typeface="Alegreya Sans"/>
+              </a:rPr>
+              <a:t>Structuration du cadre de gouvernance des risques IA avec le Chief Data Officer : inventaire des systèmes, formation des référents métiers e…</a:t>
+            </a:r>
+          </a:p>
+          <a:p>
+            <a:pPr algn="l" lvl="1">
+              <a:spcAft>
+                <a:spcPts val="100"/>
+              </a:spcAft>
+            </a:pPr>
+            <a:r>
+              <a:rPr sz="1200" b="1" i="0">
+                <a:solidFill>
+                  <a:srgbClr val="3AEDE5"/>
+                </a:solidFill>
+                <a:latin typeface="Alegreya Sans"/>
+              </a:rPr>
+              <a:t>•  </a:t>
+            </a:r>
+            <a:r>
+              <a:rPr sz="1200" b="0" i="0">
+                <a:solidFill>
+                  <a:srgbClr val="FFFFFF"/>
+                </a:solidFill>
+                <a:latin typeface="Alegreya Sans"/>
+              </a:rPr>
+              <a:t>Ambassadeur des outils d'IA Générative Groupe auprès de 3 000 collaborateurs Oney.</a:t>
+            </a:r>
+          </a:p>
+          <a:p>
+            <a:pPr algn="l">
+              <a:spcBef>
+                <a:spcPts val="600"/>
+              </a:spcBef>
+              <a:spcAft>
+                <a:spcPts val="300"/>
+              </a:spcAft>
+            </a:pPr>
+            <a:r>
+              <a:rPr sz="1300" b="1" i="0">
+                <a:solidFill>
+                  <a:srgbClr val="3AEDE5"/>
+                </a:solidFill>
+                <a:latin typeface="Alegreya Sans"/>
+              </a:rPr>
+              <a:t>RÉFÉRENCES</a:t>
+            </a:r>
+          </a:p>
+          <a:p>
+            <a:pPr algn="l">
+              <a:spcAft>
+                <a:spcPts val="200"/>
+              </a:spcAft>
+            </a:pPr>
+            <a:r>
+              <a:rPr sz="1200" b="0" i="1">
+                <a:solidFill>
+                  <a:srgbClr val="FFFFFF"/>
+                </a:solidFill>
+                <a:latin typeface="Alegreya Sans"/>
+              </a:rPr>
+              <a:t>Groupe BPCE, Natixis, Oney, Sia Partners, Paris Europlace</a:t>
+            </a:r>
+          </a:p>
+        </p:txBody>
+      </p:sp>
+      <p:sp>
+        <p:nvSpPr>
+          <p:cNvPr id="9" name="Rectangle 8"/>
           <p:cNvSpPr/>
           <p:nvPr/>
         </p:nvSpPr>
@@ -3232,1092 +4307,6 @@
           </a:p>
         </p:txBody>
       </p:sp>
-      <p:pic>
-        <p:nvPicPr>
-          <p:cNvPr id="5" name="Picture 4" descr="inside_circle_logo.png"/>
-          <p:cNvPicPr>
-            <a:picLocks noChangeAspect="1"/>
-          </p:cNvPicPr>
-          <p:nvPr/>
-        </p:nvPicPr>
-        <p:blipFill>
-          <a:blip r:embed="rId2"/>
-          <a:stretch>
-            <a:fillRect/>
-          </a:stretch>
-        </p:blipFill>
-        <p:spPr>
-          <a:xfrm>
-            <a:off x="10660000" y="130000"/>
-            <a:ext cx="1302000" cy="420000"/>
-          </a:xfrm>
-          <a:prstGeom prst="rect">
-            <a:avLst/>
-          </a:prstGeom>
-        </p:spPr>
-      </p:pic>
-      <p:sp>
-        <p:nvSpPr>
-          <p:cNvPr id="6" name="TextBox 5"/>
-          <p:cNvSpPr txBox="1"/>
-          <p:nvPr/>
-        </p:nvSpPr>
-        <p:spPr>
-          <a:xfrm>
-            <a:off x="228600" y="260000"/>
-            <a:ext cx="3842800" cy="800000"/>
-          </a:xfrm>
-          <a:prstGeom prst="rect">
-            <a:avLst/>
-          </a:prstGeom>
-          <a:noFill/>
-        </p:spPr>
-        <p:txBody>
-          <a:bodyPr wrap="square" lIns="0" rIns="0" tIns="0" bIns="0">
-            <a:spAutoFit/>
-          </a:bodyPr>
-          <a:lstStyle/>
-          <a:p>
-            <a:pPr algn="l"/>
-            <a:r>
-              <a:rPr sz="4800" b="1" i="0">
-                <a:solidFill>
-                  <a:srgbClr val="3AEDE5"/>
-                </a:solidFill>
-                <a:latin typeface="Alegreya Sans"/>
-              </a:rPr>
-              <a:t>A.P.</a:t>
-            </a:r>
-          </a:p>
-        </p:txBody>
-      </p:sp>
-      <p:sp>
-        <p:nvSpPr>
-          <p:cNvPr id="7" name="TextBox 6"/>
-          <p:cNvSpPr txBox="1"/>
-          <p:nvPr/>
-        </p:nvSpPr>
-        <p:spPr>
-          <a:xfrm>
-            <a:off x="4528600" y="300000"/>
-            <a:ext cx="5963400" cy="800000"/>
-          </a:xfrm>
-          <a:prstGeom prst="rect">
-            <a:avLst/>
-          </a:prstGeom>
-          <a:noFill/>
-        </p:spPr>
-        <p:txBody>
-          <a:bodyPr wrap="square" lIns="0" rIns="0" tIns="0" bIns="0">
-            <a:spAutoFit/>
-          </a:bodyPr>
-          <a:lstStyle/>
-          <a:p>
-            <a:r>
-              <a:rPr sz="2400" b="1" i="0">
-                <a:solidFill>
-                  <a:srgbClr val="FFFFFF"/>
-                </a:solidFill>
-                <a:latin typeface="Alegreya Sans"/>
-              </a:rPr>
-              <a:t>Spécialiste AI Governance, AI Risk &amp; EU AI Act</a:t>
-            </a:r>
-          </a:p>
-          <a:p>
-            <a:pPr>
-              <a:spcBef>
-                <a:spcPts val="200"/>
-              </a:spcBef>
-            </a:pPr>
-            <a:r>
-              <a:rPr sz="1500" b="0" i="1">
-                <a:solidFill>
-                  <a:srgbClr val="3AEDE5"/>
-                </a:solidFill>
-                <a:latin typeface="Alegreya Sans"/>
-              </a:rPr>
-              <a:t>Gouvernance IA &amp; Conformité réglementaire — Services financiers</a:t>
-            </a:r>
-          </a:p>
-        </p:txBody>
-      </p:sp>
-      <p:sp>
-        <p:nvSpPr>
-          <p:cNvPr id="8" name="TextBox 7"/>
-          <p:cNvSpPr txBox="1"/>
-          <p:nvPr/>
-        </p:nvSpPr>
-        <p:spPr>
-          <a:xfrm>
-            <a:off x="228600" y="1180000"/>
-            <a:ext cx="3842800" cy="5318000"/>
-          </a:xfrm>
-          <a:prstGeom prst="rect">
-            <a:avLst/>
-          </a:prstGeom>
-          <a:noFill/>
-        </p:spPr>
-        <p:txBody>
-          <a:bodyPr wrap="square" lIns="0" rIns="0" tIns="0" bIns="0">
-            <a:spAutoFit/>
-          </a:bodyPr>
-          <a:lstStyle/>
-          <a:p>
-            <a:pPr algn="l">
-              <a:spcAft>
-                <a:spcPts val="300"/>
-              </a:spcAft>
-            </a:pPr>
-            <a:r>
-              <a:rPr sz="1300" b="1" i="0">
-                <a:solidFill>
-                  <a:srgbClr val="3AEDE5"/>
-                </a:solidFill>
-                <a:latin typeface="Alegreya Sans"/>
-              </a:rPr>
-              <a:t>DOMAINES D'EXPERTISE</a:t>
-            </a:r>
-          </a:p>
-          <a:p>
-            <a:pPr algn="l">
-              <a:spcAft>
-                <a:spcPts val="100"/>
-              </a:spcAft>
-            </a:pPr>
-            <a:r>
-              <a:rPr sz="1200" b="1" i="0">
-                <a:solidFill>
-                  <a:srgbClr val="3AEDE5"/>
-                </a:solidFill>
-                <a:latin typeface="Alegreya Sans"/>
-              </a:rPr>
-              <a:t>•  </a:t>
-            </a:r>
-            <a:r>
-              <a:rPr sz="1200" b="0" i="0">
-                <a:solidFill>
-                  <a:srgbClr val="FFFFFF"/>
-                </a:solidFill>
-                <a:latin typeface="Alegreya Sans"/>
-              </a:rPr>
-              <a:t>AI Governance</a:t>
-            </a:r>
-          </a:p>
-          <a:p>
-            <a:pPr algn="l">
-              <a:spcAft>
-                <a:spcPts val="100"/>
-              </a:spcAft>
-            </a:pPr>
-            <a:r>
-              <a:rPr sz="1200" b="1" i="0">
-                <a:solidFill>
-                  <a:srgbClr val="3AEDE5"/>
-                </a:solidFill>
-                <a:latin typeface="Alegreya Sans"/>
-              </a:rPr>
-              <a:t>•  </a:t>
-            </a:r>
-            <a:r>
-              <a:rPr sz="1200" b="0" i="0">
-                <a:solidFill>
-                  <a:srgbClr val="FFFFFF"/>
-                </a:solidFill>
-                <a:latin typeface="Alegreya Sans"/>
-              </a:rPr>
-              <a:t>AI Risk Management</a:t>
-            </a:r>
-          </a:p>
-          <a:p>
-            <a:pPr algn="l">
-              <a:spcAft>
-                <a:spcPts val="100"/>
-              </a:spcAft>
-            </a:pPr>
-            <a:r>
-              <a:rPr sz="1200" b="1" i="0">
-                <a:solidFill>
-                  <a:srgbClr val="3AEDE5"/>
-                </a:solidFill>
-                <a:latin typeface="Alegreya Sans"/>
-              </a:rPr>
-              <a:t>•  </a:t>
-            </a:r>
-            <a:r>
-              <a:rPr sz="1200" b="0" i="0">
-                <a:solidFill>
-                  <a:srgbClr val="FFFFFF"/>
-                </a:solidFill>
-                <a:latin typeface="Alegreya Sans"/>
-              </a:rPr>
-              <a:t>EU AI Act</a:t>
-            </a:r>
-          </a:p>
-          <a:p>
-            <a:pPr algn="l">
-              <a:spcAft>
-                <a:spcPts val="100"/>
-              </a:spcAft>
-            </a:pPr>
-            <a:r>
-              <a:rPr sz="1200" b="1" i="0">
-                <a:solidFill>
-                  <a:srgbClr val="3AEDE5"/>
-                </a:solidFill>
-                <a:latin typeface="Alegreya Sans"/>
-              </a:rPr>
-              <a:t>•  </a:t>
-            </a:r>
-            <a:r>
-              <a:rPr sz="1200" b="0" i="0">
-                <a:solidFill>
-                  <a:srgbClr val="FFFFFF"/>
-                </a:solidFill>
-                <a:latin typeface="Alegreya Sans"/>
-              </a:rPr>
-              <a:t>Digital Compliance</a:t>
-            </a:r>
-          </a:p>
-          <a:p>
-            <a:pPr algn="l">
-              <a:spcAft>
-                <a:spcPts val="100"/>
-              </a:spcAft>
-            </a:pPr>
-            <a:r>
-              <a:rPr sz="1200" b="1" i="0">
-                <a:solidFill>
-                  <a:srgbClr val="3AEDE5"/>
-                </a:solidFill>
-                <a:latin typeface="Alegreya Sans"/>
-              </a:rPr>
-              <a:t>•  </a:t>
-            </a:r>
-            <a:r>
-              <a:rPr sz="1200" b="0" i="0">
-                <a:solidFill>
-                  <a:srgbClr val="FFFFFF"/>
-                </a:solidFill>
-                <a:latin typeface="Alegreya Sans"/>
-              </a:rPr>
-              <a:t>Regulatory Strategy</a:t>
-            </a:r>
-          </a:p>
-          <a:p>
-            <a:pPr algn="l">
-              <a:spcBef>
-                <a:spcPts val="600"/>
-              </a:spcBef>
-              <a:spcAft>
-                <a:spcPts val="300"/>
-              </a:spcAft>
-            </a:pPr>
-            <a:r>
-              <a:rPr sz="1300" b="1" i="0">
-                <a:solidFill>
-                  <a:srgbClr val="3AEDE5"/>
-                </a:solidFill>
-                <a:latin typeface="Alegreya Sans"/>
-              </a:rPr>
-              <a:t>LANGUES</a:t>
-            </a:r>
-          </a:p>
-          <a:p>
-            <a:pPr algn="l">
-              <a:spcAft>
-                <a:spcPts val="100"/>
-              </a:spcAft>
-            </a:pPr>
-            <a:r>
-              <a:rPr sz="1200" b="1" i="0">
-                <a:solidFill>
-                  <a:srgbClr val="3AEDE5"/>
-                </a:solidFill>
-                <a:latin typeface="Alegreya Sans"/>
-              </a:rPr>
-              <a:t>•  </a:t>
-            </a:r>
-            <a:r>
-              <a:rPr sz="1200" b="0" i="0">
-                <a:solidFill>
-                  <a:srgbClr val="FFFFFF"/>
-                </a:solidFill>
-                <a:latin typeface="Alegreya Sans"/>
-              </a:rPr>
-              <a:t>Français — Langue maternelle</a:t>
-            </a:r>
-          </a:p>
-          <a:p>
-            <a:pPr algn="l">
-              <a:spcAft>
-                <a:spcPts val="100"/>
-              </a:spcAft>
-            </a:pPr>
-            <a:r>
-              <a:rPr sz="1200" b="1" i="0">
-                <a:solidFill>
-                  <a:srgbClr val="3AEDE5"/>
-                </a:solidFill>
-                <a:latin typeface="Alegreya Sans"/>
-              </a:rPr>
-              <a:t>•  </a:t>
-            </a:r>
-            <a:r>
-              <a:rPr sz="1200" b="0" i="0">
-                <a:solidFill>
-                  <a:srgbClr val="FFFFFF"/>
-                </a:solidFill>
-                <a:latin typeface="Alegreya Sans"/>
-              </a:rPr>
-              <a:t>Anglais — TOEIC 955/990</a:t>
-            </a:r>
-          </a:p>
-          <a:p>
-            <a:pPr algn="l">
-              <a:spcBef>
-                <a:spcPts val="600"/>
-              </a:spcBef>
-              <a:spcAft>
-                <a:spcPts val="300"/>
-              </a:spcAft>
-            </a:pPr>
-            <a:r>
-              <a:rPr sz="1300" b="1" i="0">
-                <a:solidFill>
-                  <a:srgbClr val="3AEDE5"/>
-                </a:solidFill>
-                <a:latin typeface="Alegreya Sans"/>
-              </a:rPr>
-              <a:t>FORMATION &amp; CERTIFICATIONS</a:t>
-            </a:r>
-          </a:p>
-          <a:p>
-            <a:pPr algn="l">
-              <a:spcAft>
-                <a:spcPts val="100"/>
-              </a:spcAft>
-            </a:pPr>
-            <a:r>
-              <a:rPr sz="1200" b="1" i="0">
-                <a:solidFill>
-                  <a:srgbClr val="3AEDE5"/>
-                </a:solidFill>
-                <a:latin typeface="Alegreya Sans"/>
-              </a:rPr>
-              <a:t>2024  </a:t>
-            </a:r>
-            <a:r>
-              <a:rPr sz="1200" b="1" i="0">
-                <a:solidFill>
-                  <a:srgbClr val="FFFFFF"/>
-                </a:solidFill>
-                <a:latin typeface="Alegreya Sans"/>
-              </a:rPr>
-              <a:t>EDHEC Business School</a:t>
-            </a:r>
-          </a:p>
-          <a:p>
-            <a:pPr algn="l">
-              <a:spcAft>
-                <a:spcPts val="300"/>
-              </a:spcAft>
-            </a:pPr>
-            <a:r>
-              <a:rPr sz="1200" b="0" i="1">
-                <a:solidFill>
-                  <a:srgbClr val="CCD6E8"/>
-                </a:solidFill>
-                <a:latin typeface="Alegreya Sans"/>
-              </a:rPr>
-              <a:t>Certification Digital Ethics Officer (av…</a:t>
-            </a:r>
-          </a:p>
-          <a:p>
-            <a:pPr algn="l">
-              <a:spcAft>
-                <a:spcPts val="100"/>
-              </a:spcAft>
-            </a:pPr>
-            <a:r>
-              <a:rPr sz="1200" b="1" i="0">
-                <a:solidFill>
-                  <a:srgbClr val="3AEDE5"/>
-                </a:solidFill>
-                <a:latin typeface="Alegreya Sans"/>
-              </a:rPr>
-              <a:t>2015 — 2020  </a:t>
-            </a:r>
-            <a:r>
-              <a:rPr sz="1200" b="1" i="0">
-                <a:solidFill>
-                  <a:srgbClr val="FFFFFF"/>
-                </a:solidFill>
-                <a:latin typeface="Alegreya Sans"/>
-              </a:rPr>
-              <a:t>Sciences Po Saint-Germain-en-Laye</a:t>
-            </a:r>
-          </a:p>
-          <a:p>
-            <a:pPr algn="l">
-              <a:spcAft>
-                <a:spcPts val="300"/>
-              </a:spcAft>
-            </a:pPr>
-            <a:r>
-              <a:rPr sz="1200" b="0" i="1">
-                <a:solidFill>
-                  <a:srgbClr val="CCD6E8"/>
-                </a:solidFill>
-                <a:latin typeface="Alegreya Sans"/>
-              </a:rPr>
-              <a:t>Master II Affaires européennes et intern…</a:t>
-            </a:r>
-          </a:p>
-          <a:p>
-            <a:pPr algn="l">
-              <a:spcAft>
-                <a:spcPts val="100"/>
-              </a:spcAft>
-            </a:pPr>
-            <a:r>
-              <a:rPr sz="1200" b="1" i="0">
-                <a:solidFill>
-                  <a:srgbClr val="3AEDE5"/>
-                </a:solidFill>
-                <a:latin typeface="Alegreya Sans"/>
-              </a:rPr>
-              <a:t>2020  </a:t>
-            </a:r>
-            <a:r>
-              <a:rPr sz="1200" b="1" i="0">
-                <a:solidFill>
-                  <a:srgbClr val="FFFFFF"/>
-                </a:solidFill>
-                <a:latin typeface="Alegreya Sans"/>
-              </a:rPr>
-              <a:t>Université de Versailles Saint-Quentin-en-Yvelines</a:t>
-            </a:r>
-          </a:p>
-          <a:p>
-            <a:pPr algn="l">
-              <a:spcAft>
-                <a:spcPts val="300"/>
-              </a:spcAft>
-            </a:pPr>
-            <a:r>
-              <a:rPr sz="1200" b="0" i="1">
-                <a:solidFill>
-                  <a:srgbClr val="CCD6E8"/>
-                </a:solidFill>
-                <a:latin typeface="Alegreya Sans"/>
-              </a:rPr>
-              <a:t>Master II Influence &amp; Affaires publiques…</a:t>
-            </a:r>
-          </a:p>
-          <a:p>
-            <a:pPr algn="l">
-              <a:spcBef>
-                <a:spcPts val="600"/>
-              </a:spcBef>
-              <a:spcAft>
-                <a:spcPts val="300"/>
-              </a:spcAft>
-            </a:pPr>
-            <a:r>
-              <a:rPr sz="1300" b="1" i="0">
-                <a:solidFill>
-                  <a:srgbClr val="3AEDE5"/>
-                </a:solidFill>
-                <a:latin typeface="Alegreya Sans"/>
-              </a:rPr>
-              <a:t>ENGAGEMENTS &amp; RÉALISATIONS</a:t>
-            </a:r>
-          </a:p>
-          <a:p>
-            <a:pPr algn="l">
-              <a:spcAft>
-                <a:spcPts val="200"/>
-              </a:spcAft>
-            </a:pPr>
-            <a:r>
-              <a:rPr sz="1200" b="1" i="0">
-                <a:solidFill>
-                  <a:srgbClr val="3AEDE5"/>
-                </a:solidFill>
-                <a:latin typeface="Alegreya Sans"/>
-              </a:rPr>
-              <a:t>• </a:t>
-            </a:r>
-            <a:r>
-              <a:rPr sz="1200" b="1" i="0">
-                <a:solidFill>
-                  <a:srgbClr val="FFFFFF"/>
-                </a:solidFill>
-                <a:latin typeface="Alegreya Sans"/>
-              </a:rPr>
-              <a:t>Conseiller Numérique</a:t>
-            </a:r>
-            <a:r>
-              <a:rPr sz="1200" b="0" i="1">
-                <a:solidFill>
-                  <a:srgbClr val="CCD6E8"/>
-                </a:solidFill>
-                <a:latin typeface="Alegreya Sans"/>
-              </a:rPr>
-              <a:t> — Bénévole au sein du Conseil du Numé…</a:t>
-            </a:r>
-          </a:p>
-          <a:p>
-            <a:pPr algn="l">
-              <a:spcAft>
-                <a:spcPts val="200"/>
-              </a:spcAft>
-            </a:pPr>
-            <a:r>
-              <a:rPr sz="1200" b="1" i="0">
-                <a:solidFill>
-                  <a:srgbClr val="3AEDE5"/>
-                </a:solidFill>
-                <a:latin typeface="Alegreya Sans"/>
-              </a:rPr>
-              <a:t>• </a:t>
-            </a:r>
-            <a:r>
-              <a:rPr sz="1200" b="1" i="0">
-                <a:solidFill>
-                  <a:srgbClr val="FFFFFF"/>
-                </a:solidFill>
-                <a:latin typeface="Alegreya Sans"/>
-              </a:rPr>
-              <a:t>Podcasteur</a:t>
-            </a:r>
-            <a:r>
-              <a:rPr sz="1200" b="0" i="1">
-                <a:solidFill>
-                  <a:srgbClr val="CCD6E8"/>
-                </a:solidFill>
-                <a:latin typeface="Alegreya Sans"/>
-              </a:rPr>
-              <a:t> — Créateur et animateur d'un podcast…</a:t>
-            </a:r>
-          </a:p>
-          <a:p>
-            <a:pPr algn="l">
-              <a:spcAft>
-                <a:spcPts val="200"/>
-              </a:spcAft>
-            </a:pPr>
-            <a:r>
-              <a:rPr sz="1200" b="1" i="0">
-                <a:solidFill>
-                  <a:srgbClr val="3AEDE5"/>
-                </a:solidFill>
-                <a:latin typeface="Alegreya Sans"/>
-              </a:rPr>
-              <a:t>• </a:t>
-            </a:r>
-            <a:r>
-              <a:rPr sz="1200" b="1" i="0">
-                <a:solidFill>
-                  <a:srgbClr val="FFFFFF"/>
-                </a:solidFill>
-                <a:latin typeface="Alegreya Sans"/>
-              </a:rPr>
-              <a:t>Conférencier</a:t>
-            </a:r>
-            <a:r>
-              <a:rPr sz="1200" b="0" i="1">
-                <a:solidFill>
-                  <a:srgbClr val="CCD6E8"/>
-                </a:solidFill>
-                <a:latin typeface="Alegreya Sans"/>
-              </a:rPr>
-              <a:t> — Intervenant sur l'IA et ses enjeux…</a:t>
-            </a:r>
-          </a:p>
-        </p:txBody>
-      </p:sp>
-      <p:sp>
-        <p:nvSpPr>
-          <p:cNvPr id="9" name="TextBox 8"/>
-          <p:cNvSpPr txBox="1"/>
-          <p:nvPr/>
-        </p:nvSpPr>
-        <p:spPr>
-          <a:xfrm>
-            <a:off x="4528600" y="1180000"/>
-            <a:ext cx="7434800" cy="5318000"/>
-          </a:xfrm>
-          <a:prstGeom prst="rect">
-            <a:avLst/>
-          </a:prstGeom>
-          <a:noFill/>
-        </p:spPr>
-        <p:txBody>
-          <a:bodyPr wrap="square" lIns="0" rIns="0" tIns="0" bIns="0">
-            <a:spAutoFit/>
-          </a:bodyPr>
-          <a:lstStyle/>
-          <a:p>
-            <a:pPr algn="l">
-              <a:spcAft>
-                <a:spcPts val="300"/>
-              </a:spcAft>
-            </a:pPr>
-            <a:r>
-              <a:rPr sz="1300" b="1" i="0">
-                <a:solidFill>
-                  <a:srgbClr val="3AEDE5"/>
-                </a:solidFill>
-                <a:latin typeface="Alegreya Sans"/>
-              </a:rPr>
-              <a:t>RÉSUMÉ</a:t>
-            </a:r>
-          </a:p>
-          <a:p>
-            <a:pPr algn="l">
-              <a:spcAft>
-                <a:spcPts val="300"/>
-              </a:spcAft>
-            </a:pPr>
-            <a:r>
-              <a:rPr sz="1200" b="0" i="0">
-                <a:solidFill>
-                  <a:srgbClr val="FFFFFF"/>
-                </a:solidFill>
-                <a:latin typeface="Alegreya Sans"/>
-              </a:rPr>
-              <a:t>Expert en gouvernance de l'IA, AI Risk Management et conformité réglementaire, avec près de 8 ans d'expérience auprès de grandes institutions bancaires. Spécialisé dans l'EU AI Act et le déploiement d…</a:t>
-            </a:r>
-          </a:p>
-          <a:p>
-            <a:pPr algn="l">
-              <a:spcBef>
-                <a:spcPts val="600"/>
-              </a:spcBef>
-              <a:spcAft>
-                <a:spcPts val="300"/>
-              </a:spcAft>
-            </a:pPr>
-            <a:r>
-              <a:rPr sz="1300" b="1" i="0">
-                <a:solidFill>
-                  <a:srgbClr val="3AEDE5"/>
-                </a:solidFill>
-                <a:latin typeface="Alegreya Sans"/>
-              </a:rPr>
-              <a:t>EXPÉRIENCE PROFESSIONNELLE</a:t>
-            </a:r>
-          </a:p>
-          <a:p>
-            <a:pPr algn="l">
-              <a:spcAft>
-                <a:spcPts val="100"/>
-              </a:spcAft>
-            </a:pPr>
-            <a:r>
-              <a:rPr sz="1200" b="1" i="0">
-                <a:solidFill>
-                  <a:srgbClr val="3AEDE5"/>
-                </a:solidFill>
-                <a:latin typeface="Alegreya Sans"/>
-              </a:rPr>
-              <a:t>▸ </a:t>
-            </a:r>
-            <a:r>
-              <a:rPr sz="1200" b="1" i="0">
-                <a:solidFill>
-                  <a:srgbClr val="FFFFFF"/>
-                </a:solidFill>
-                <a:latin typeface="Alegreya Sans"/>
-              </a:rPr>
-              <a:t>Top-tier CIB européenne</a:t>
-            </a:r>
-            <a:r>
-              <a:rPr sz="1200" b="0" i="0">
-                <a:solidFill>
-                  <a:srgbClr val="FFFFFF"/>
-                </a:solidFill>
-                <a:latin typeface="Alegreya Sans"/>
-              </a:rPr>
-              <a:t> — AI Compliance Lead (consultant)</a:t>
-            </a:r>
-            <a:r>
-              <a:rPr sz="1200" b="0" i="1">
-                <a:solidFill>
-                  <a:srgbClr val="3AEDE5"/>
-                </a:solidFill>
-                <a:latin typeface="Alegreya Sans"/>
-              </a:rPr>
-              <a:t>  (8 mois — en cours)</a:t>
-            </a:r>
-          </a:p>
-          <a:p>
-            <a:pPr algn="l" lvl="1">
-              <a:spcAft>
-                <a:spcPts val="100"/>
-              </a:spcAft>
-            </a:pPr>
-            <a:r>
-              <a:rPr sz="1200" b="1" i="0">
-                <a:solidFill>
-                  <a:srgbClr val="3AEDE5"/>
-                </a:solidFill>
-                <a:latin typeface="Alegreya Sans"/>
-              </a:rPr>
-              <a:t>•  </a:t>
-            </a:r>
-            <a:r>
-              <a:rPr sz="1200" b="0" i="0">
-                <a:solidFill>
-                  <a:srgbClr val="FFFFFF"/>
-                </a:solidFill>
-                <a:latin typeface="Alegreya Sans"/>
-              </a:rPr>
-              <a:t>Finalisation et mise en œuvre du cadre de gouvernance des risques IA : politiques internes, cartographie des risques, comitologie et coordin…</a:t>
-            </a:r>
-          </a:p>
-          <a:p>
-            <a:pPr algn="l" lvl="1">
-              <a:spcAft>
-                <a:spcPts val="100"/>
-              </a:spcAft>
-            </a:pPr>
-            <a:r>
-              <a:rPr sz="1200" b="1" i="0">
-                <a:solidFill>
-                  <a:srgbClr val="3AEDE5"/>
-                </a:solidFill>
-                <a:latin typeface="Alegreya Sans"/>
-              </a:rPr>
-              <a:t>•  </a:t>
-            </a:r>
-            <a:r>
-              <a:rPr sz="1200" b="0" i="0">
-                <a:solidFill>
-                  <a:srgbClr val="FFFFFF"/>
-                </a:solidFill>
-                <a:latin typeface="Alegreya Sans"/>
-              </a:rPr>
-              <a:t>Pilotage opérationnel de la gouvernance : identification, évaluation, priorisation, validation et remédiation des systèmes d'IA.</a:t>
-            </a:r>
-          </a:p>
-          <a:p>
-            <a:pPr algn="l">
-              <a:spcAft>
-                <a:spcPts val="100"/>
-              </a:spcAft>
-            </a:pPr>
-            <a:r>
-              <a:rPr sz="1200" b="1" i="0">
-                <a:solidFill>
-                  <a:srgbClr val="3AEDE5"/>
-                </a:solidFill>
-                <a:latin typeface="Alegreya Sans"/>
-              </a:rPr>
-              <a:t>▸ </a:t>
-            </a:r>
-            <a:r>
-              <a:rPr sz="1200" b="1" i="0">
-                <a:solidFill>
-                  <a:srgbClr val="FFFFFF"/>
-                </a:solidFill>
-                <a:latin typeface="Alegreya Sans"/>
-              </a:rPr>
-              <a:t>Sia Partners</a:t>
-            </a:r>
-            <a:r>
-              <a:rPr sz="1200" b="0" i="0">
-                <a:solidFill>
-                  <a:srgbClr val="FFFFFF"/>
-                </a:solidFill>
-                <a:latin typeface="Alegreya Sans"/>
-              </a:rPr>
-              <a:t> — Associate Manager</a:t>
-            </a:r>
-            <a:r>
-              <a:rPr sz="1200" b="0" i="1">
-                <a:solidFill>
-                  <a:srgbClr val="3AEDE5"/>
-                </a:solidFill>
-                <a:latin typeface="Alegreya Sans"/>
-              </a:rPr>
-              <a:t>  (10 mois — en cours)</a:t>
-            </a:r>
-          </a:p>
-          <a:p>
-            <a:pPr algn="l" lvl="1">
-              <a:spcAft>
-                <a:spcPts val="100"/>
-              </a:spcAft>
-            </a:pPr>
-            <a:r>
-              <a:rPr sz="1200" b="1" i="0">
-                <a:solidFill>
-                  <a:srgbClr val="3AEDE5"/>
-                </a:solidFill>
-                <a:latin typeface="Alegreya Sans"/>
-              </a:rPr>
-              <a:t>•  </a:t>
-            </a:r>
-            <a:r>
-              <a:rPr sz="1200" b="0" i="0">
-                <a:solidFill>
-                  <a:srgbClr val="FFFFFF"/>
-                </a:solidFill>
-                <a:latin typeface="Alegreya Sans"/>
-              </a:rPr>
-              <a:t>Responsable de l'offre AI Risk Management : coordination des réponses aux appels d'offres, veille stratégique et réglementaire, développemen…</a:t>
-            </a:r>
-          </a:p>
-          <a:p>
-            <a:pPr algn="l" lvl="1">
-              <a:spcAft>
-                <a:spcPts val="100"/>
-              </a:spcAft>
-            </a:pPr>
-            <a:r>
-              <a:rPr sz="1200" b="1" i="0">
-                <a:solidFill>
-                  <a:srgbClr val="3AEDE5"/>
-                </a:solidFill>
-                <a:latin typeface="Alegreya Sans"/>
-              </a:rPr>
-              <a:t>•  </a:t>
-            </a:r>
-            <a:r>
-              <a:rPr sz="1200" b="0" i="0">
-                <a:solidFill>
-                  <a:srgbClr val="FFFFFF"/>
-                </a:solidFill>
-                <a:latin typeface="Alegreya Sans"/>
-              </a:rPr>
-              <a:t>Pilotage et animation du groupe de travail IA de l'association Paris Europlace (+40 responsables du secteur financier) : rédaction de positi…</a:t>
-            </a:r>
-          </a:p>
-          <a:p>
-            <a:pPr algn="l">
-              <a:spcAft>
-                <a:spcPts val="100"/>
-              </a:spcAft>
-            </a:pPr>
-            <a:r>
-              <a:rPr sz="1200" b="1" i="0">
-                <a:solidFill>
-                  <a:srgbClr val="3AEDE5"/>
-                </a:solidFill>
-                <a:latin typeface="Alegreya Sans"/>
-              </a:rPr>
-              <a:t>▸ </a:t>
-            </a:r>
-            <a:r>
-              <a:rPr sz="1200" b="1" i="0">
-                <a:solidFill>
-                  <a:srgbClr val="FFFFFF"/>
-                </a:solidFill>
-                <a:latin typeface="Alegreya Sans"/>
-              </a:rPr>
-              <a:t>Groupe BPCE</a:t>
-            </a:r>
-            <a:r>
-              <a:rPr sz="1200" b="0" i="0">
-                <a:solidFill>
-                  <a:srgbClr val="FFFFFF"/>
-                </a:solidFill>
-                <a:latin typeface="Alegreya Sans"/>
-              </a:rPr>
-              <a:t> — Group EU AI Act Project Manager</a:t>
-            </a:r>
-            <a:r>
-              <a:rPr sz="1200" b="0" i="1">
-                <a:solidFill>
-                  <a:srgbClr val="3AEDE5"/>
-                </a:solidFill>
-                <a:latin typeface="Alegreya Sans"/>
-              </a:rPr>
-              <a:t>  (18 mois)</a:t>
-            </a:r>
-          </a:p>
-          <a:p>
-            <a:pPr algn="l" lvl="1">
-              <a:spcAft>
-                <a:spcPts val="100"/>
-              </a:spcAft>
-            </a:pPr>
-            <a:r>
-              <a:rPr sz="1200" b="1" i="0">
-                <a:solidFill>
-                  <a:srgbClr val="3AEDE5"/>
-                </a:solidFill>
-                <a:latin typeface="Alegreya Sans"/>
-              </a:rPr>
-              <a:t>•  </a:t>
-            </a:r>
-            <a:r>
-              <a:rPr sz="1200" b="0" i="0">
-                <a:solidFill>
-                  <a:srgbClr val="FFFFFF"/>
-                </a:solidFill>
-                <a:latin typeface="Alegreya Sans"/>
-              </a:rPr>
-              <a:t>Responsable du programme de mise en conformité EU AI Act du Groupe BPCE et de ses entités (Natixis, Oney, BRED, etc.) : cartographie et éval…</a:t>
-            </a:r>
-          </a:p>
-          <a:p>
-            <a:pPr algn="l" lvl="1">
-              <a:spcAft>
-                <a:spcPts val="100"/>
-              </a:spcAft>
-            </a:pPr>
-            <a:r>
-              <a:rPr sz="1200" b="1" i="0">
-                <a:solidFill>
-                  <a:srgbClr val="3AEDE5"/>
-                </a:solidFill>
-                <a:latin typeface="Alegreya Sans"/>
-              </a:rPr>
-              <a:t>•  </a:t>
-            </a:r>
-            <a:r>
-              <a:rPr sz="1200" b="0" i="0">
-                <a:solidFill>
-                  <a:srgbClr val="FFFFFF"/>
-                </a:solidFill>
-                <a:latin typeface="Alegreya Sans"/>
-              </a:rPr>
-              <a:t>Coordination et accompagnement de plus de 35 décideurs locaux (DPO, Chief Compliance Officer, CDO, etc.) dans la déclinaison du cadre normat…</a:t>
-            </a:r>
-          </a:p>
-          <a:p>
-            <a:pPr algn="l">
-              <a:spcAft>
-                <a:spcPts val="100"/>
-              </a:spcAft>
-            </a:pPr>
-            <a:r>
-              <a:rPr sz="1200" b="1" i="0">
-                <a:solidFill>
-                  <a:srgbClr val="3AEDE5"/>
-                </a:solidFill>
-                <a:latin typeface="Alegreya Sans"/>
-              </a:rPr>
-              <a:t>▸ </a:t>
-            </a:r>
-            <a:r>
-              <a:rPr sz="1200" b="1" i="0">
-                <a:solidFill>
-                  <a:srgbClr val="FFFFFF"/>
-                </a:solidFill>
-                <a:latin typeface="Alegreya Sans"/>
-              </a:rPr>
-              <a:t>Oney / Oneytrust</a:t>
-            </a:r>
-            <a:r>
-              <a:rPr sz="1200" b="0" i="0">
-                <a:solidFill>
-                  <a:srgbClr val="FFFFFF"/>
-                </a:solidFill>
-                <a:latin typeface="Alegreya Sans"/>
-              </a:rPr>
-              <a:t> — Expert Leader — Digital &amp; AI Compliance Officer</a:t>
-            </a:r>
-            <a:r>
-              <a:rPr sz="1200" b="0" i="1">
-                <a:solidFill>
-                  <a:srgbClr val="3AEDE5"/>
-                </a:solidFill>
-                <a:latin typeface="Alegreya Sans"/>
-              </a:rPr>
-              <a:t>  (38 mois)</a:t>
-            </a:r>
-          </a:p>
-          <a:p>
-            <a:pPr algn="l" lvl="1">
-              <a:spcAft>
-                <a:spcPts val="100"/>
-              </a:spcAft>
-            </a:pPr>
-            <a:r>
-              <a:rPr sz="1200" b="1" i="0">
-                <a:solidFill>
-                  <a:srgbClr val="3AEDE5"/>
-                </a:solidFill>
-                <a:latin typeface="Alegreya Sans"/>
-              </a:rPr>
-              <a:t>•  </a:t>
-            </a:r>
-            <a:r>
-              <a:rPr sz="1200" b="0" i="0">
-                <a:solidFill>
-                  <a:srgbClr val="FFFFFF"/>
-                </a:solidFill>
-                <a:latin typeface="Alegreya Sans"/>
-              </a:rPr>
-              <a:t>Structuration du cadre de gouvernance des risques IA avec le Chief Data Officer : inventaire des systèmes, formation des référents métiers e…</a:t>
-            </a:r>
-          </a:p>
-          <a:p>
-            <a:pPr algn="l" lvl="1">
-              <a:spcAft>
-                <a:spcPts val="100"/>
-              </a:spcAft>
-            </a:pPr>
-            <a:r>
-              <a:rPr sz="1200" b="1" i="0">
-                <a:solidFill>
-                  <a:srgbClr val="3AEDE5"/>
-                </a:solidFill>
-                <a:latin typeface="Alegreya Sans"/>
-              </a:rPr>
-              <a:t>•  </a:t>
-            </a:r>
-            <a:r>
-              <a:rPr sz="1200" b="0" i="0">
-                <a:solidFill>
-                  <a:srgbClr val="FFFFFF"/>
-                </a:solidFill>
-                <a:latin typeface="Alegreya Sans"/>
-              </a:rPr>
-              <a:t>Ambassadeur des outils d'IA Générative Groupe auprès de 3 000 collaborateurs Oney.</a:t>
-            </a:r>
-          </a:p>
-          <a:p>
-            <a:pPr algn="l">
-              <a:spcBef>
-                <a:spcPts val="600"/>
-              </a:spcBef>
-              <a:spcAft>
-                <a:spcPts val="300"/>
-              </a:spcAft>
-            </a:pPr>
-            <a:r>
-              <a:rPr sz="1300" b="1" i="0">
-                <a:solidFill>
-                  <a:srgbClr val="3AEDE5"/>
-                </a:solidFill>
-                <a:latin typeface="Alegreya Sans"/>
-              </a:rPr>
-              <a:t>RÉFÉRENCES</a:t>
-            </a:r>
-          </a:p>
-          <a:p>
-            <a:pPr algn="l">
-              <a:spcAft>
-                <a:spcPts val="200"/>
-              </a:spcAft>
-            </a:pPr>
-            <a:r>
-              <a:rPr sz="1200" b="0" i="1">
-                <a:solidFill>
-                  <a:srgbClr val="FFFFFF"/>
-                </a:solidFill>
-                <a:latin typeface="Alegreya Sans"/>
-              </a:rPr>
-              <a:t>Groupe BPCE, Natixis, Oney, Sia Partners, Paris Europlace</a:t>
-            </a:r>
-          </a:p>
-        </p:txBody>
-      </p:sp>
       <p:sp>
         <p:nvSpPr>
           <p:cNvPr id="10" name="TextBox 9"/>
@@ -4381,61 +4370,6 @@
           <a:xfrm>
             <a:off x="0" y="0"/>
             <a:ext cx="12192000" cy="6858000"/>
-          </a:xfrm>
-          <a:prstGeom prst="rect">
-            <a:avLst/>
-          </a:prstGeom>
-          <a:ln>
-            <a:noFill/>
-          </a:ln>
-          <a:effectLst/>
-          <a:gradFill flip="none" rotWithShape="1">
-            <a:gsLst>
-              <a:gs pos="0">
-                <a:srgbClr val="07227A"/>
-              </a:gs>
-              <a:gs pos="85000">
-                <a:srgbClr val="07227A"/>
-              </a:gs>
-              <a:gs pos="100000">
-                <a:srgbClr val="1FCBD9"/>
-              </a:gs>
-            </a:gsLst>
-            <a:lin ang="2700000" scaled="0"/>
-          </a:gradFill>
-        </p:spPr>
-        <p:style>
-          <a:lnRef idx="1">
-            <a:schemeClr val="accent1"/>
-          </a:lnRef>
-          <a:fillRef idx="3">
-            <a:schemeClr val="accent1"/>
-          </a:fillRef>
-          <a:effectRef idx="2">
-            <a:schemeClr val="accent1"/>
-          </a:effectRef>
-          <a:fontRef idx="minor">
-            <a:schemeClr val="lt1"/>
-          </a:fontRef>
-        </p:style>
-        <p:txBody>
-          <a:bodyPr rtlCol="0" anchor="ctr"/>
-          <a:lstStyle/>
-          <a:p>
-            <a:pPr algn="ctr"/>
-          </a:p>
-        </p:txBody>
-      </p:sp>
-      <p:sp>
-        <p:nvSpPr>
-          <p:cNvPr id="3" name="Rectangle 2"/>
-          <p:cNvSpPr/>
-          <p:nvPr/>
-        </p:nvSpPr>
-        <p:spPr>
-          <a:xfrm>
-            <a:off x="0" y="0"/>
-            <a:ext cx="4300000" cy="6858000"/>
           </a:xfrm>
           <a:prstGeom prst="rect">
             <a:avLst/>
@@ -4472,7 +4406,1137 @@
       </p:sp>
       <p:sp>
         <p:nvSpPr>
-          <p:cNvPr id="4" name="Rectangle 3"/>
+          <p:cNvPr id="3" name="Rectangle 2"/>
+          <p:cNvSpPr/>
+          <p:nvPr/>
+        </p:nvSpPr>
+        <p:spPr>
+          <a:xfrm>
+            <a:off x="4300000" y="0"/>
+            <a:ext cx="15000" cy="6858000"/>
+          </a:xfrm>
+          <a:prstGeom prst="rect">
+            <a:avLst/>
+          </a:prstGeom>
+          <a:solidFill>
+            <a:srgbClr val="3AEDE5"/>
+          </a:solidFill>
+          <a:ln>
+            <a:noFill/>
+          </a:ln>
+          <a:effectLst/>
+        </p:spPr>
+        <p:style>
+          <a:lnRef idx="1">
+            <a:schemeClr val="accent1"/>
+          </a:lnRef>
+          <a:fillRef idx="3">
+            <a:schemeClr val="accent1"/>
+          </a:fillRef>
+          <a:effectRef idx="2">
+            <a:schemeClr val="accent1"/>
+          </a:effectRef>
+          <a:fontRef idx="minor">
+            <a:schemeClr val="lt1"/>
+          </a:fontRef>
+        </p:style>
+        <p:txBody>
+          <a:bodyPr rtlCol="0" anchor="ctr"/>
+          <a:lstStyle/>
+          <a:p>
+            <a:pPr algn="ctr"/>
+          </a:p>
+        </p:txBody>
+      </p:sp>
+      <p:pic>
+        <p:nvPicPr>
+          <p:cNvPr id="4" name="Picture 3" descr="inside_circle_logo.png"/>
+          <p:cNvPicPr>
+            <a:picLocks noChangeAspect="1"/>
+          </p:cNvPicPr>
+          <p:nvPr/>
+        </p:nvPicPr>
+        <p:blipFill>
+          <a:blip r:embed="rId2"/>
+          <a:stretch>
+            <a:fillRect/>
+          </a:stretch>
+        </p:blipFill>
+        <p:spPr>
+          <a:xfrm>
+            <a:off x="10660000" y="130000"/>
+            <a:ext cx="1302000" cy="420000"/>
+          </a:xfrm>
+          <a:prstGeom prst="rect">
+            <a:avLst/>
+          </a:prstGeom>
+        </p:spPr>
+      </p:pic>
+      <p:sp>
+        <p:nvSpPr>
+          <p:cNvPr id="5" name="TextBox 4"/>
+          <p:cNvSpPr txBox="1"/>
+          <p:nvPr/>
+        </p:nvSpPr>
+        <p:spPr>
+          <a:xfrm>
+            <a:off x="228600" y="260000"/>
+            <a:ext cx="3842800" cy="800000"/>
+          </a:xfrm>
+          <a:prstGeom prst="rect">
+            <a:avLst/>
+          </a:prstGeom>
+          <a:noFill/>
+        </p:spPr>
+        <p:txBody>
+          <a:bodyPr wrap="square" lIns="0" rIns="0" tIns="0" bIns="0">
+            <a:spAutoFit/>
+          </a:bodyPr>
+          <a:lstStyle/>
+          <a:p>
+            <a:pPr algn="l"/>
+            <a:r>
+              <a:rPr sz="4800" b="1" i="0">
+                <a:solidFill>
+                  <a:srgbClr val="3AEDE5"/>
+                </a:solidFill>
+                <a:latin typeface="Alegreya Sans"/>
+              </a:rPr>
+              <a:t>A.P.</a:t>
+            </a:r>
+          </a:p>
+        </p:txBody>
+      </p:sp>
+      <p:sp>
+        <p:nvSpPr>
+          <p:cNvPr id="6" name="TextBox 5"/>
+          <p:cNvSpPr txBox="1"/>
+          <p:nvPr/>
+        </p:nvSpPr>
+        <p:spPr>
+          <a:xfrm>
+            <a:off x="4528600" y="300000"/>
+            <a:ext cx="5963400" cy="800000"/>
+          </a:xfrm>
+          <a:prstGeom prst="rect">
+            <a:avLst/>
+          </a:prstGeom>
+          <a:noFill/>
+        </p:spPr>
+        <p:txBody>
+          <a:bodyPr wrap="square" lIns="0" rIns="0" tIns="0" bIns="0">
+            <a:spAutoFit/>
+          </a:bodyPr>
+          <a:lstStyle/>
+          <a:p>
+            <a:r>
+              <a:rPr sz="2400" b="1" i="0">
+                <a:solidFill>
+                  <a:srgbClr val="FFFFFF"/>
+                </a:solidFill>
+                <a:latin typeface="Alegreya Sans"/>
+              </a:rPr>
+              <a:t>AI Governance, AI Risk &amp; EU AI Act Specialist</a:t>
+            </a:r>
+          </a:p>
+          <a:p>
+            <a:pPr>
+              <a:spcBef>
+                <a:spcPts val="200"/>
+              </a:spcBef>
+            </a:pPr>
+            <a:r>
+              <a:rPr sz="1500" b="0" i="1">
+                <a:solidFill>
+                  <a:srgbClr val="3AEDE5"/>
+                </a:solidFill>
+                <a:latin typeface="Alegreya Sans"/>
+              </a:rPr>
+              <a:t>AI Governance &amp; Regulatory Compliance — Financial Services</a:t>
+            </a:r>
+          </a:p>
+        </p:txBody>
+      </p:sp>
+      <p:sp>
+        <p:nvSpPr>
+          <p:cNvPr id="7" name="TextBox 6"/>
+          <p:cNvSpPr txBox="1"/>
+          <p:nvPr/>
+        </p:nvSpPr>
+        <p:spPr>
+          <a:xfrm>
+            <a:off x="228600" y="1180000"/>
+            <a:ext cx="3842800" cy="5318000"/>
+          </a:xfrm>
+          <a:prstGeom prst="rect">
+            <a:avLst/>
+          </a:prstGeom>
+          <a:noFill/>
+        </p:spPr>
+        <p:txBody>
+          <a:bodyPr wrap="square" lIns="0" rIns="0" tIns="0" bIns="0">
+            <a:spAutoFit/>
+          </a:bodyPr>
+          <a:lstStyle/>
+          <a:p>
+            <a:pPr algn="l">
+              <a:spcAft>
+                <a:spcPts val="300"/>
+              </a:spcAft>
+            </a:pPr>
+            <a:r>
+              <a:rPr sz="1300" b="1" i="0">
+                <a:solidFill>
+                  <a:srgbClr val="3AEDE5"/>
+                </a:solidFill>
+                <a:latin typeface="Alegreya Sans"/>
+              </a:rPr>
+              <a:t>MAIN AREAS OF EXPERTISE</a:t>
+            </a:r>
+          </a:p>
+          <a:p>
+            <a:pPr algn="l">
+              <a:spcAft>
+                <a:spcPts val="100"/>
+              </a:spcAft>
+            </a:pPr>
+            <a:r>
+              <a:rPr sz="1200" b="1" i="0">
+                <a:solidFill>
+                  <a:srgbClr val="3AEDE5"/>
+                </a:solidFill>
+                <a:latin typeface="Alegreya Sans"/>
+              </a:rPr>
+              <a:t>•  </a:t>
+            </a:r>
+            <a:r>
+              <a:rPr sz="1200" b="0" i="0">
+                <a:solidFill>
+                  <a:srgbClr val="FFFFFF"/>
+                </a:solidFill>
+                <a:latin typeface="Alegreya Sans"/>
+              </a:rPr>
+              <a:t>AI Governance</a:t>
+            </a:r>
+          </a:p>
+          <a:p>
+            <a:pPr algn="l">
+              <a:spcAft>
+                <a:spcPts val="100"/>
+              </a:spcAft>
+            </a:pPr>
+            <a:r>
+              <a:rPr sz="1200" b="1" i="0">
+                <a:solidFill>
+                  <a:srgbClr val="3AEDE5"/>
+                </a:solidFill>
+                <a:latin typeface="Alegreya Sans"/>
+              </a:rPr>
+              <a:t>•  </a:t>
+            </a:r>
+            <a:r>
+              <a:rPr sz="1200" b="0" i="0">
+                <a:solidFill>
+                  <a:srgbClr val="FFFFFF"/>
+                </a:solidFill>
+                <a:latin typeface="Alegreya Sans"/>
+              </a:rPr>
+              <a:t>AI Risk Management</a:t>
+            </a:r>
+          </a:p>
+          <a:p>
+            <a:pPr algn="l">
+              <a:spcAft>
+                <a:spcPts val="100"/>
+              </a:spcAft>
+            </a:pPr>
+            <a:r>
+              <a:rPr sz="1200" b="1" i="0">
+                <a:solidFill>
+                  <a:srgbClr val="3AEDE5"/>
+                </a:solidFill>
+                <a:latin typeface="Alegreya Sans"/>
+              </a:rPr>
+              <a:t>•  </a:t>
+            </a:r>
+            <a:r>
+              <a:rPr sz="1200" b="0" i="0">
+                <a:solidFill>
+                  <a:srgbClr val="FFFFFF"/>
+                </a:solidFill>
+                <a:latin typeface="Alegreya Sans"/>
+              </a:rPr>
+              <a:t>EU AI Act</a:t>
+            </a:r>
+          </a:p>
+          <a:p>
+            <a:pPr algn="l">
+              <a:spcAft>
+                <a:spcPts val="100"/>
+              </a:spcAft>
+            </a:pPr>
+            <a:r>
+              <a:rPr sz="1200" b="1" i="0">
+                <a:solidFill>
+                  <a:srgbClr val="3AEDE5"/>
+                </a:solidFill>
+                <a:latin typeface="Alegreya Sans"/>
+              </a:rPr>
+              <a:t>•  </a:t>
+            </a:r>
+            <a:r>
+              <a:rPr sz="1200" b="0" i="0">
+                <a:solidFill>
+                  <a:srgbClr val="FFFFFF"/>
+                </a:solidFill>
+                <a:latin typeface="Alegreya Sans"/>
+              </a:rPr>
+              <a:t>Digital Compliance</a:t>
+            </a:r>
+          </a:p>
+          <a:p>
+            <a:pPr algn="l">
+              <a:spcAft>
+                <a:spcPts val="100"/>
+              </a:spcAft>
+            </a:pPr>
+            <a:r>
+              <a:rPr sz="1200" b="1" i="0">
+                <a:solidFill>
+                  <a:srgbClr val="3AEDE5"/>
+                </a:solidFill>
+                <a:latin typeface="Alegreya Sans"/>
+              </a:rPr>
+              <a:t>•  </a:t>
+            </a:r>
+            <a:r>
+              <a:rPr sz="1200" b="0" i="0">
+                <a:solidFill>
+                  <a:srgbClr val="FFFFFF"/>
+                </a:solidFill>
+                <a:latin typeface="Alegreya Sans"/>
+              </a:rPr>
+              <a:t>Regulatory Strategy</a:t>
+            </a:r>
+          </a:p>
+          <a:p>
+            <a:pPr algn="l">
+              <a:spcBef>
+                <a:spcPts val="600"/>
+              </a:spcBef>
+              <a:spcAft>
+                <a:spcPts val="300"/>
+              </a:spcAft>
+            </a:pPr>
+            <a:r>
+              <a:rPr sz="1300" b="1" i="0">
+                <a:solidFill>
+                  <a:srgbClr val="3AEDE5"/>
+                </a:solidFill>
+                <a:latin typeface="Alegreya Sans"/>
+              </a:rPr>
+              <a:t>LANGUAGES</a:t>
+            </a:r>
+          </a:p>
+          <a:p>
+            <a:pPr algn="l">
+              <a:spcAft>
+                <a:spcPts val="100"/>
+              </a:spcAft>
+            </a:pPr>
+            <a:r>
+              <a:rPr sz="1200" b="1" i="0">
+                <a:solidFill>
+                  <a:srgbClr val="3AEDE5"/>
+                </a:solidFill>
+                <a:latin typeface="Alegreya Sans"/>
+              </a:rPr>
+              <a:t>•  </a:t>
+            </a:r>
+            <a:r>
+              <a:rPr sz="1200" b="0" i="0">
+                <a:solidFill>
+                  <a:srgbClr val="FFFFFF"/>
+                </a:solidFill>
+                <a:latin typeface="Alegreya Sans"/>
+              </a:rPr>
+              <a:t>French — Native</a:t>
+            </a:r>
+          </a:p>
+          <a:p>
+            <a:pPr algn="l">
+              <a:spcAft>
+                <a:spcPts val="100"/>
+              </a:spcAft>
+            </a:pPr>
+            <a:r>
+              <a:rPr sz="1200" b="1" i="0">
+                <a:solidFill>
+                  <a:srgbClr val="3AEDE5"/>
+                </a:solidFill>
+                <a:latin typeface="Alegreya Sans"/>
+              </a:rPr>
+              <a:t>•  </a:t>
+            </a:r>
+            <a:r>
+              <a:rPr sz="1200" b="0" i="0">
+                <a:solidFill>
+                  <a:srgbClr val="FFFFFF"/>
+                </a:solidFill>
+                <a:latin typeface="Alegreya Sans"/>
+              </a:rPr>
+              <a:t>English — TOEIC 955/990</a:t>
+            </a:r>
+          </a:p>
+          <a:p>
+            <a:pPr algn="l">
+              <a:spcBef>
+                <a:spcPts val="600"/>
+              </a:spcBef>
+              <a:spcAft>
+                <a:spcPts val="300"/>
+              </a:spcAft>
+            </a:pPr>
+            <a:r>
+              <a:rPr sz="1300" b="1" i="0">
+                <a:solidFill>
+                  <a:srgbClr val="3AEDE5"/>
+                </a:solidFill>
+                <a:latin typeface="Alegreya Sans"/>
+              </a:rPr>
+              <a:t>EDUCATION &amp; CERTIFICATIONS</a:t>
+            </a:r>
+          </a:p>
+          <a:p>
+            <a:pPr algn="l">
+              <a:spcAft>
+                <a:spcPts val="100"/>
+              </a:spcAft>
+            </a:pPr>
+            <a:r>
+              <a:rPr sz="1200" b="1" i="0">
+                <a:solidFill>
+                  <a:srgbClr val="3AEDE5"/>
+                </a:solidFill>
+                <a:latin typeface="Alegreya Sans"/>
+              </a:rPr>
+              <a:t>2024  </a:t>
+            </a:r>
+            <a:r>
+              <a:rPr sz="1200" b="1" i="0">
+                <a:solidFill>
+                  <a:srgbClr val="FFFFFF"/>
+                </a:solidFill>
+                <a:latin typeface="Alegreya Sans"/>
+              </a:rPr>
+              <a:t>EDHEC Business School</a:t>
+            </a:r>
+          </a:p>
+          <a:p>
+            <a:pPr algn="l">
+              <a:spcAft>
+                <a:spcPts val="300"/>
+              </a:spcAft>
+            </a:pPr>
+            <a:r>
+              <a:rPr sz="1200" b="0" i="1">
+                <a:solidFill>
+                  <a:srgbClr val="CCD6E8"/>
+                </a:solidFill>
+                <a:latin typeface="Alegreya Sans"/>
+              </a:rPr>
+              <a:t>Digital Ethics Officer certification (wi…</a:t>
+            </a:r>
+          </a:p>
+          <a:p>
+            <a:pPr algn="l">
+              <a:spcAft>
+                <a:spcPts val="100"/>
+              </a:spcAft>
+            </a:pPr>
+            <a:r>
+              <a:rPr sz="1200" b="1" i="0">
+                <a:solidFill>
+                  <a:srgbClr val="3AEDE5"/>
+                </a:solidFill>
+                <a:latin typeface="Alegreya Sans"/>
+              </a:rPr>
+              <a:t>2015 — 2020  </a:t>
+            </a:r>
+            <a:r>
+              <a:rPr sz="1200" b="1" i="0">
+                <a:solidFill>
+                  <a:srgbClr val="FFFFFF"/>
+                </a:solidFill>
+                <a:latin typeface="Alegreya Sans"/>
+              </a:rPr>
+              <a:t>Sciences Po Saint-Germain-en-Laye</a:t>
+            </a:r>
+          </a:p>
+          <a:p>
+            <a:pPr algn="l">
+              <a:spcAft>
+                <a:spcPts val="300"/>
+              </a:spcAft>
+            </a:pPr>
+            <a:r>
+              <a:rPr sz="1200" b="0" i="1">
+                <a:solidFill>
+                  <a:srgbClr val="CCD6E8"/>
+                </a:solidFill>
+                <a:latin typeface="Alegreya Sans"/>
+              </a:rPr>
+              <a:t>Master's in European &amp; International Aff…</a:t>
+            </a:r>
+          </a:p>
+          <a:p>
+            <a:pPr algn="l">
+              <a:spcAft>
+                <a:spcPts val="100"/>
+              </a:spcAft>
+            </a:pPr>
+            <a:r>
+              <a:rPr sz="1200" b="1" i="0">
+                <a:solidFill>
+                  <a:srgbClr val="3AEDE5"/>
+                </a:solidFill>
+                <a:latin typeface="Alegreya Sans"/>
+              </a:rPr>
+              <a:t>2020  </a:t>
+            </a:r>
+            <a:r>
+              <a:rPr sz="1200" b="1" i="0">
+                <a:solidFill>
+                  <a:srgbClr val="FFFFFF"/>
+                </a:solidFill>
+                <a:latin typeface="Alegreya Sans"/>
+              </a:rPr>
+              <a:t>University of Versailles Saint-Quentin-en-Yvelines</a:t>
+            </a:r>
+          </a:p>
+          <a:p>
+            <a:pPr algn="l">
+              <a:spcAft>
+                <a:spcPts val="300"/>
+              </a:spcAft>
+            </a:pPr>
+            <a:r>
+              <a:rPr sz="1200" b="0" i="1">
+                <a:solidFill>
+                  <a:srgbClr val="CCD6E8"/>
+                </a:solidFill>
+                <a:latin typeface="Alegreya Sans"/>
+              </a:rPr>
+              <a:t>Master's in Influence &amp; Public Affairs (…</a:t>
+            </a:r>
+          </a:p>
+          <a:p>
+            <a:pPr algn="l">
+              <a:spcBef>
+                <a:spcPts val="600"/>
+              </a:spcBef>
+              <a:spcAft>
+                <a:spcPts val="300"/>
+              </a:spcAft>
+            </a:pPr>
+            <a:r>
+              <a:rPr sz="1300" b="1" i="0">
+                <a:solidFill>
+                  <a:srgbClr val="3AEDE5"/>
+                </a:solidFill>
+                <a:latin typeface="Alegreya Sans"/>
+              </a:rPr>
+              <a:t>ENGAGEMENTS &amp; ACHIEVEMENTS</a:t>
+            </a:r>
+          </a:p>
+          <a:p>
+            <a:pPr algn="l">
+              <a:spcAft>
+                <a:spcPts val="200"/>
+              </a:spcAft>
+            </a:pPr>
+            <a:r>
+              <a:rPr sz="1200" b="1" i="0">
+                <a:solidFill>
+                  <a:srgbClr val="3AEDE5"/>
+                </a:solidFill>
+                <a:latin typeface="Alegreya Sans"/>
+              </a:rPr>
+              <a:t>• </a:t>
+            </a:r>
+            <a:r>
+              <a:rPr sz="1200" b="1" i="0">
+                <a:solidFill>
+                  <a:srgbClr val="FFFFFF"/>
+                </a:solidFill>
+                <a:latin typeface="Alegreya Sans"/>
+              </a:rPr>
+              <a:t>Digital Council Advisor</a:t>
+            </a:r>
+            <a:r>
+              <a:rPr sz="1200" b="0" i="1">
+                <a:solidFill>
+                  <a:srgbClr val="CCD6E8"/>
+                </a:solidFill>
+                <a:latin typeface="Alegreya Sans"/>
+              </a:rPr>
+              <a:t> — Volunteer at a local Digital Counci…</a:t>
+            </a:r>
+          </a:p>
+          <a:p>
+            <a:pPr algn="l">
+              <a:spcAft>
+                <a:spcPts val="200"/>
+              </a:spcAft>
+            </a:pPr>
+            <a:r>
+              <a:rPr sz="1200" b="1" i="0">
+                <a:solidFill>
+                  <a:srgbClr val="3AEDE5"/>
+                </a:solidFill>
+                <a:latin typeface="Alegreya Sans"/>
+              </a:rPr>
+              <a:t>• </a:t>
+            </a:r>
+            <a:r>
+              <a:rPr sz="1200" b="1" i="0">
+                <a:solidFill>
+                  <a:srgbClr val="FFFFFF"/>
+                </a:solidFill>
+                <a:latin typeface="Alegreya Sans"/>
+              </a:rPr>
+              <a:t>Podcaster</a:t>
+            </a:r>
+            <a:r>
+              <a:rPr sz="1200" b="0" i="1">
+                <a:solidFill>
+                  <a:srgbClr val="CCD6E8"/>
+                </a:solidFill>
+                <a:latin typeface="Alegreya Sans"/>
+              </a:rPr>
+              <a:t> — Creator and host of an AI podcast f…</a:t>
+            </a:r>
+          </a:p>
+          <a:p>
+            <a:pPr algn="l">
+              <a:spcAft>
+                <a:spcPts val="200"/>
+              </a:spcAft>
+            </a:pPr>
+            <a:r>
+              <a:rPr sz="1200" b="1" i="0">
+                <a:solidFill>
+                  <a:srgbClr val="3AEDE5"/>
+                </a:solidFill>
+                <a:latin typeface="Alegreya Sans"/>
+              </a:rPr>
+              <a:t>• </a:t>
+            </a:r>
+            <a:r>
+              <a:rPr sz="1200" b="1" i="0">
+                <a:solidFill>
+                  <a:srgbClr val="FFFFFF"/>
+                </a:solidFill>
+                <a:latin typeface="Alegreya Sans"/>
+              </a:rPr>
+              <a:t>Speaker</a:t>
+            </a:r>
+            <a:r>
+              <a:rPr sz="1200" b="0" i="1">
+                <a:solidFill>
+                  <a:srgbClr val="CCD6E8"/>
+                </a:solidFill>
+                <a:latin typeface="Alegreya Sans"/>
+              </a:rPr>
+              <a:t> — Speaker on AI and its challenges (b…</a:t>
+            </a:r>
+          </a:p>
+        </p:txBody>
+      </p:sp>
+      <p:sp>
+        <p:nvSpPr>
+          <p:cNvPr id="8" name="TextBox 7"/>
+          <p:cNvSpPr txBox="1"/>
+          <p:nvPr/>
+        </p:nvSpPr>
+        <p:spPr>
+          <a:xfrm>
+            <a:off x="4528600" y="1180000"/>
+            <a:ext cx="7434800" cy="5318000"/>
+          </a:xfrm>
+          <a:prstGeom prst="rect">
+            <a:avLst/>
+          </a:prstGeom>
+          <a:noFill/>
+        </p:spPr>
+        <p:txBody>
+          <a:bodyPr wrap="square" lIns="0" rIns="0" tIns="0" bIns="0">
+            <a:spAutoFit/>
+          </a:bodyPr>
+          <a:lstStyle/>
+          <a:p>
+            <a:pPr algn="l">
+              <a:spcAft>
+                <a:spcPts val="300"/>
+              </a:spcAft>
+            </a:pPr>
+            <a:r>
+              <a:rPr sz="1300" b="1" i="0">
+                <a:solidFill>
+                  <a:srgbClr val="3AEDE5"/>
+                </a:solidFill>
+                <a:latin typeface="Alegreya Sans"/>
+              </a:rPr>
+              <a:t>SUMMARY</a:t>
+            </a:r>
+          </a:p>
+          <a:p>
+            <a:pPr algn="l">
+              <a:spcAft>
+                <a:spcPts val="300"/>
+              </a:spcAft>
+            </a:pPr>
+            <a:r>
+              <a:rPr sz="1200" b="0" i="0">
+                <a:solidFill>
+                  <a:srgbClr val="FFFFFF"/>
+                </a:solidFill>
+                <a:latin typeface="Alegreya Sans"/>
+              </a:rPr>
+              <a:t>Expert in AI Governance, AI Risk Management and regulatory compliance, with nearly 8 years of experience advising major banking institutions. Specialised in the EU AI Act and the international rollout…</a:t>
+            </a:r>
+          </a:p>
+          <a:p>
+            <a:pPr algn="l">
+              <a:spcBef>
+                <a:spcPts val="600"/>
+              </a:spcBef>
+              <a:spcAft>
+                <a:spcPts val="300"/>
+              </a:spcAft>
+            </a:pPr>
+            <a:r>
+              <a:rPr sz="1300" b="1" i="0">
+                <a:solidFill>
+                  <a:srgbClr val="3AEDE5"/>
+                </a:solidFill>
+                <a:latin typeface="Alegreya Sans"/>
+              </a:rPr>
+              <a:t>PROFESSIONAL EXPERIENCE</a:t>
+            </a:r>
+          </a:p>
+          <a:p>
+            <a:pPr algn="l">
+              <a:spcAft>
+                <a:spcPts val="100"/>
+              </a:spcAft>
+            </a:pPr>
+            <a:r>
+              <a:rPr sz="1200" b="1" i="0">
+                <a:solidFill>
+                  <a:srgbClr val="3AEDE5"/>
+                </a:solidFill>
+                <a:latin typeface="Alegreya Sans"/>
+              </a:rPr>
+              <a:t>▸ </a:t>
+            </a:r>
+            <a:r>
+              <a:rPr sz="1200" b="1" i="0">
+                <a:solidFill>
+                  <a:srgbClr val="FFFFFF"/>
+                </a:solidFill>
+                <a:latin typeface="Alegreya Sans"/>
+              </a:rPr>
+              <a:t>Top-tier European CIB</a:t>
+            </a:r>
+            <a:r>
+              <a:rPr sz="1200" b="0" i="0">
+                <a:solidFill>
+                  <a:srgbClr val="FFFFFF"/>
+                </a:solidFill>
+                <a:latin typeface="Alegreya Sans"/>
+              </a:rPr>
+              <a:t> — AI Compliance Lead (consultant)</a:t>
+            </a:r>
+            <a:r>
+              <a:rPr sz="1200" b="0" i="1">
+                <a:solidFill>
+                  <a:srgbClr val="3AEDE5"/>
+                </a:solidFill>
+                <a:latin typeface="Alegreya Sans"/>
+              </a:rPr>
+              <a:t>  (8 months — ongoing)</a:t>
+            </a:r>
+          </a:p>
+          <a:p>
+            <a:pPr algn="l" lvl="1">
+              <a:spcAft>
+                <a:spcPts val="100"/>
+              </a:spcAft>
+            </a:pPr>
+            <a:r>
+              <a:rPr sz="1200" b="1" i="0">
+                <a:solidFill>
+                  <a:srgbClr val="3AEDE5"/>
+                </a:solidFill>
+                <a:latin typeface="Alegreya Sans"/>
+              </a:rPr>
+              <a:t>•  </a:t>
+            </a:r>
+            <a:r>
+              <a:rPr sz="1200" b="0" i="0">
+                <a:solidFill>
+                  <a:srgbClr val="FFFFFF"/>
+                </a:solidFill>
+                <a:latin typeface="Alegreya Sans"/>
+              </a:rPr>
+              <a:t>Finalisation and rollout of the AI risk governance framework: internal policies, risk mapping, committee design, coordination of support and…</a:t>
+            </a:r>
+          </a:p>
+          <a:p>
+            <a:pPr algn="l" lvl="1">
+              <a:spcAft>
+                <a:spcPts val="100"/>
+              </a:spcAft>
+            </a:pPr>
+            <a:r>
+              <a:rPr sz="1200" b="1" i="0">
+                <a:solidFill>
+                  <a:srgbClr val="3AEDE5"/>
+                </a:solidFill>
+                <a:latin typeface="Alegreya Sans"/>
+              </a:rPr>
+              <a:t>•  </a:t>
+            </a:r>
+            <a:r>
+              <a:rPr sz="1200" b="0" i="0">
+                <a:solidFill>
+                  <a:srgbClr val="FFFFFF"/>
+                </a:solidFill>
+                <a:latin typeface="Alegreya Sans"/>
+              </a:rPr>
+              <a:t>Operational pilot of AI governance: identification, assessment, prioritisation, validation and remediation of AI systems.</a:t>
+            </a:r>
+          </a:p>
+          <a:p>
+            <a:pPr algn="l">
+              <a:spcAft>
+                <a:spcPts val="100"/>
+              </a:spcAft>
+            </a:pPr>
+            <a:r>
+              <a:rPr sz="1200" b="1" i="0">
+                <a:solidFill>
+                  <a:srgbClr val="3AEDE5"/>
+                </a:solidFill>
+                <a:latin typeface="Alegreya Sans"/>
+              </a:rPr>
+              <a:t>▸ </a:t>
+            </a:r>
+            <a:r>
+              <a:rPr sz="1200" b="1" i="0">
+                <a:solidFill>
+                  <a:srgbClr val="FFFFFF"/>
+                </a:solidFill>
+                <a:latin typeface="Alegreya Sans"/>
+              </a:rPr>
+              <a:t>Sia Partners</a:t>
+            </a:r>
+            <a:r>
+              <a:rPr sz="1200" b="0" i="0">
+                <a:solidFill>
+                  <a:srgbClr val="FFFFFF"/>
+                </a:solidFill>
+                <a:latin typeface="Alegreya Sans"/>
+              </a:rPr>
+              <a:t> — Associate Manager</a:t>
+            </a:r>
+            <a:r>
+              <a:rPr sz="1200" b="0" i="1">
+                <a:solidFill>
+                  <a:srgbClr val="3AEDE5"/>
+                </a:solidFill>
+                <a:latin typeface="Alegreya Sans"/>
+              </a:rPr>
+              <a:t>  (10 months — ongoing)</a:t>
+            </a:r>
+          </a:p>
+          <a:p>
+            <a:pPr algn="l" lvl="1">
+              <a:spcAft>
+                <a:spcPts val="100"/>
+              </a:spcAft>
+            </a:pPr>
+            <a:r>
+              <a:rPr sz="1200" b="1" i="0">
+                <a:solidFill>
+                  <a:srgbClr val="3AEDE5"/>
+                </a:solidFill>
+                <a:latin typeface="Alegreya Sans"/>
+              </a:rPr>
+              <a:t>•  </a:t>
+            </a:r>
+            <a:r>
+              <a:rPr sz="1200" b="0" i="0">
+                <a:solidFill>
+                  <a:srgbClr val="FFFFFF"/>
+                </a:solidFill>
+                <a:latin typeface="Alegreya Sans"/>
+              </a:rPr>
+              <a:t>Head of the AI Risk Management offering: RFP coordination, strategic and regulatory watch, business development and financial-ecosystem anim…</a:t>
+            </a:r>
+          </a:p>
+          <a:p>
+            <a:pPr algn="l" lvl="1">
+              <a:spcAft>
+                <a:spcPts val="100"/>
+              </a:spcAft>
+            </a:pPr>
+            <a:r>
+              <a:rPr sz="1200" b="1" i="0">
+                <a:solidFill>
+                  <a:srgbClr val="3AEDE5"/>
+                </a:solidFill>
+                <a:latin typeface="Alegreya Sans"/>
+              </a:rPr>
+              <a:t>•  </a:t>
+            </a:r>
+            <a:r>
+              <a:rPr sz="1200" b="0" i="0">
+                <a:solidFill>
+                  <a:srgbClr val="FFFFFF"/>
+                </a:solidFill>
+                <a:latin typeface="Alegreya Sans"/>
+              </a:rPr>
+              <a:t>Lead of the AI working group at Paris Europlace association (40+ senior financial-sector representatives): position papers, EU consultation…</a:t>
+            </a:r>
+          </a:p>
+          <a:p>
+            <a:pPr algn="l">
+              <a:spcAft>
+                <a:spcPts val="100"/>
+              </a:spcAft>
+            </a:pPr>
+            <a:r>
+              <a:rPr sz="1200" b="1" i="0">
+                <a:solidFill>
+                  <a:srgbClr val="3AEDE5"/>
+                </a:solidFill>
+                <a:latin typeface="Alegreya Sans"/>
+              </a:rPr>
+              <a:t>▸ </a:t>
+            </a:r>
+            <a:r>
+              <a:rPr sz="1200" b="1" i="0">
+                <a:solidFill>
+                  <a:srgbClr val="FFFFFF"/>
+                </a:solidFill>
+                <a:latin typeface="Alegreya Sans"/>
+              </a:rPr>
+              <a:t>Groupe BPCE</a:t>
+            </a:r>
+            <a:r>
+              <a:rPr sz="1200" b="0" i="0">
+                <a:solidFill>
+                  <a:srgbClr val="FFFFFF"/>
+                </a:solidFill>
+                <a:latin typeface="Alegreya Sans"/>
+              </a:rPr>
+              <a:t> — Group EU AI Act Project Manager</a:t>
+            </a:r>
+            <a:r>
+              <a:rPr sz="1200" b="0" i="1">
+                <a:solidFill>
+                  <a:srgbClr val="3AEDE5"/>
+                </a:solidFill>
+                <a:latin typeface="Alegreya Sans"/>
+              </a:rPr>
+              <a:t>  (18 months)</a:t>
+            </a:r>
+          </a:p>
+          <a:p>
+            <a:pPr algn="l" lvl="1">
+              <a:spcAft>
+                <a:spcPts val="100"/>
+              </a:spcAft>
+            </a:pPr>
+            <a:r>
+              <a:rPr sz="1200" b="1" i="0">
+                <a:solidFill>
+                  <a:srgbClr val="3AEDE5"/>
+                </a:solidFill>
+                <a:latin typeface="Alegreya Sans"/>
+              </a:rPr>
+              <a:t>•  </a:t>
+            </a:r>
+            <a:r>
+              <a:rPr sz="1200" b="0" i="0">
+                <a:solidFill>
+                  <a:srgbClr val="FFFFFF"/>
+                </a:solidFill>
+                <a:latin typeface="Alegreya Sans"/>
+              </a:rPr>
+              <a:t>Lead of the EU AI Act compliance programme for Groupe BPCE and its entities (Natixis, Oney, BRED, etc.): AI risk mapping and assessment, def…</a:t>
+            </a:r>
+          </a:p>
+          <a:p>
+            <a:pPr algn="l" lvl="1">
+              <a:spcAft>
+                <a:spcPts val="100"/>
+              </a:spcAft>
+            </a:pPr>
+            <a:r>
+              <a:rPr sz="1200" b="1" i="0">
+                <a:solidFill>
+                  <a:srgbClr val="3AEDE5"/>
+                </a:solidFill>
+                <a:latin typeface="Alegreya Sans"/>
+              </a:rPr>
+              <a:t>•  </a:t>
+            </a:r>
+            <a:r>
+              <a:rPr sz="1200" b="0" i="0">
+                <a:solidFill>
+                  <a:srgbClr val="FFFFFF"/>
+                </a:solidFill>
+                <a:latin typeface="Alegreya Sans"/>
+              </a:rPr>
+              <a:t>Coordination and support of 35+ local decision-makers (DPO, Chief Compliance Officer, CDO, etc.) in deploying the Group framework.</a:t>
+            </a:r>
+          </a:p>
+          <a:p>
+            <a:pPr algn="l">
+              <a:spcAft>
+                <a:spcPts val="100"/>
+              </a:spcAft>
+            </a:pPr>
+            <a:r>
+              <a:rPr sz="1200" b="1" i="0">
+                <a:solidFill>
+                  <a:srgbClr val="3AEDE5"/>
+                </a:solidFill>
+                <a:latin typeface="Alegreya Sans"/>
+              </a:rPr>
+              <a:t>▸ </a:t>
+            </a:r>
+            <a:r>
+              <a:rPr sz="1200" b="1" i="0">
+                <a:solidFill>
+                  <a:srgbClr val="FFFFFF"/>
+                </a:solidFill>
+                <a:latin typeface="Alegreya Sans"/>
+              </a:rPr>
+              <a:t>Oney / Oneytrust</a:t>
+            </a:r>
+            <a:r>
+              <a:rPr sz="1200" b="0" i="0">
+                <a:solidFill>
+                  <a:srgbClr val="FFFFFF"/>
+                </a:solidFill>
+                <a:latin typeface="Alegreya Sans"/>
+              </a:rPr>
+              <a:t> — Expert Leader — Digital &amp; AI Compliance Officer</a:t>
+            </a:r>
+            <a:r>
+              <a:rPr sz="1200" b="0" i="1">
+                <a:solidFill>
+                  <a:srgbClr val="3AEDE5"/>
+                </a:solidFill>
+                <a:latin typeface="Alegreya Sans"/>
+              </a:rPr>
+              <a:t>  (38 months)</a:t>
+            </a:r>
+          </a:p>
+          <a:p>
+            <a:pPr algn="l" lvl="1">
+              <a:spcAft>
+                <a:spcPts val="100"/>
+              </a:spcAft>
+            </a:pPr>
+            <a:r>
+              <a:rPr sz="1200" b="1" i="0">
+                <a:solidFill>
+                  <a:srgbClr val="3AEDE5"/>
+                </a:solidFill>
+                <a:latin typeface="Alegreya Sans"/>
+              </a:rPr>
+              <a:t>•  </a:t>
+            </a:r>
+            <a:r>
+              <a:rPr sz="1200" b="0" i="0">
+                <a:solidFill>
+                  <a:srgbClr val="FFFFFF"/>
+                </a:solidFill>
+                <a:latin typeface="Alegreya Sans"/>
+              </a:rPr>
+              <a:t>Built the AI risk governance framework with the Chief Data Officer: systems inventory, training of business reference owners, EU AI Act comp…</a:t>
+            </a:r>
+          </a:p>
+          <a:p>
+            <a:pPr algn="l" lvl="1">
+              <a:spcAft>
+                <a:spcPts val="100"/>
+              </a:spcAft>
+            </a:pPr>
+            <a:r>
+              <a:rPr sz="1200" b="1" i="0">
+                <a:solidFill>
+                  <a:srgbClr val="3AEDE5"/>
+                </a:solidFill>
+                <a:latin typeface="Alegreya Sans"/>
+              </a:rPr>
+              <a:t>•  </a:t>
+            </a:r>
+            <a:r>
+              <a:rPr sz="1200" b="0" i="0">
+                <a:solidFill>
+                  <a:srgbClr val="FFFFFF"/>
+                </a:solidFill>
+                <a:latin typeface="Alegreya Sans"/>
+              </a:rPr>
+              <a:t>Group GenAI tools ambassador to 3,000 Oney employees.</a:t>
+            </a:r>
+          </a:p>
+          <a:p>
+            <a:pPr algn="l">
+              <a:spcBef>
+                <a:spcPts val="600"/>
+              </a:spcBef>
+              <a:spcAft>
+                <a:spcPts val="300"/>
+              </a:spcAft>
+            </a:pPr>
+            <a:r>
+              <a:rPr sz="1300" b="1" i="0">
+                <a:solidFill>
+                  <a:srgbClr val="3AEDE5"/>
+                </a:solidFill>
+                <a:latin typeface="Alegreya Sans"/>
+              </a:rPr>
+              <a:t>MAIN REFERENCES</a:t>
+            </a:r>
+          </a:p>
+          <a:p>
+            <a:pPr algn="l">
+              <a:spcAft>
+                <a:spcPts val="200"/>
+              </a:spcAft>
+            </a:pPr>
+            <a:r>
+              <a:rPr sz="1200" b="0" i="1">
+                <a:solidFill>
+                  <a:srgbClr val="FFFFFF"/>
+                </a:solidFill>
+                <a:latin typeface="Alegreya Sans"/>
+              </a:rPr>
+              <a:t>Groupe BPCE, Natixis, Oney, Sia Partners, Paris Europlace</a:t>
+            </a:r>
+          </a:p>
+        </p:txBody>
+      </p:sp>
+      <p:sp>
+        <p:nvSpPr>
+          <p:cNvPr id="9" name="Rectangle 8"/>
           <p:cNvSpPr/>
           <p:nvPr/>
         </p:nvSpPr>
@@ -4511,1092 +5575,6 @@
           <a:lstStyle/>
           <a:p>
             <a:pPr algn="ctr"/>
-          </a:p>
-        </p:txBody>
-      </p:sp>
-      <p:pic>
-        <p:nvPicPr>
-          <p:cNvPr id="5" name="Picture 4" descr="inside_circle_logo.png"/>
-          <p:cNvPicPr>
-            <a:picLocks noChangeAspect="1"/>
-          </p:cNvPicPr>
-          <p:nvPr/>
-        </p:nvPicPr>
-        <p:blipFill>
-          <a:blip r:embed="rId2"/>
-          <a:stretch>
-            <a:fillRect/>
-          </a:stretch>
-        </p:blipFill>
-        <p:spPr>
-          <a:xfrm>
-            <a:off x="10660000" y="130000"/>
-            <a:ext cx="1302000" cy="420000"/>
-          </a:xfrm>
-          <a:prstGeom prst="rect">
-            <a:avLst/>
-          </a:prstGeom>
-        </p:spPr>
-      </p:pic>
-      <p:sp>
-        <p:nvSpPr>
-          <p:cNvPr id="6" name="TextBox 5"/>
-          <p:cNvSpPr txBox="1"/>
-          <p:nvPr/>
-        </p:nvSpPr>
-        <p:spPr>
-          <a:xfrm>
-            <a:off x="228600" y="260000"/>
-            <a:ext cx="3842800" cy="800000"/>
-          </a:xfrm>
-          <a:prstGeom prst="rect">
-            <a:avLst/>
-          </a:prstGeom>
-          <a:noFill/>
-        </p:spPr>
-        <p:txBody>
-          <a:bodyPr wrap="square" lIns="0" rIns="0" tIns="0" bIns="0">
-            <a:spAutoFit/>
-          </a:bodyPr>
-          <a:lstStyle/>
-          <a:p>
-            <a:pPr algn="l"/>
-            <a:r>
-              <a:rPr sz="4800" b="1" i="0">
-                <a:solidFill>
-                  <a:srgbClr val="3AEDE5"/>
-                </a:solidFill>
-                <a:latin typeface="Alegreya Sans"/>
-              </a:rPr>
-              <a:t>A.P.</a:t>
-            </a:r>
-          </a:p>
-        </p:txBody>
-      </p:sp>
-      <p:sp>
-        <p:nvSpPr>
-          <p:cNvPr id="7" name="TextBox 6"/>
-          <p:cNvSpPr txBox="1"/>
-          <p:nvPr/>
-        </p:nvSpPr>
-        <p:spPr>
-          <a:xfrm>
-            <a:off x="4528600" y="300000"/>
-            <a:ext cx="5963400" cy="800000"/>
-          </a:xfrm>
-          <a:prstGeom prst="rect">
-            <a:avLst/>
-          </a:prstGeom>
-          <a:noFill/>
-        </p:spPr>
-        <p:txBody>
-          <a:bodyPr wrap="square" lIns="0" rIns="0" tIns="0" bIns="0">
-            <a:spAutoFit/>
-          </a:bodyPr>
-          <a:lstStyle/>
-          <a:p>
-            <a:r>
-              <a:rPr sz="2400" b="1" i="0">
-                <a:solidFill>
-                  <a:srgbClr val="FFFFFF"/>
-                </a:solidFill>
-                <a:latin typeface="Alegreya Sans"/>
-              </a:rPr>
-              <a:t>AI Governance, AI Risk &amp; EU AI Act Specialist</a:t>
-            </a:r>
-          </a:p>
-          <a:p>
-            <a:pPr>
-              <a:spcBef>
-                <a:spcPts val="200"/>
-              </a:spcBef>
-            </a:pPr>
-            <a:r>
-              <a:rPr sz="1500" b="0" i="1">
-                <a:solidFill>
-                  <a:srgbClr val="3AEDE5"/>
-                </a:solidFill>
-                <a:latin typeface="Alegreya Sans"/>
-              </a:rPr>
-              <a:t>AI Governance &amp; Regulatory Compliance — Financial Services</a:t>
-            </a:r>
-          </a:p>
-        </p:txBody>
-      </p:sp>
-      <p:sp>
-        <p:nvSpPr>
-          <p:cNvPr id="8" name="TextBox 7"/>
-          <p:cNvSpPr txBox="1"/>
-          <p:nvPr/>
-        </p:nvSpPr>
-        <p:spPr>
-          <a:xfrm>
-            <a:off x="228600" y="1180000"/>
-            <a:ext cx="3842800" cy="5318000"/>
-          </a:xfrm>
-          <a:prstGeom prst="rect">
-            <a:avLst/>
-          </a:prstGeom>
-          <a:noFill/>
-        </p:spPr>
-        <p:txBody>
-          <a:bodyPr wrap="square" lIns="0" rIns="0" tIns="0" bIns="0">
-            <a:spAutoFit/>
-          </a:bodyPr>
-          <a:lstStyle/>
-          <a:p>
-            <a:pPr algn="l">
-              <a:spcAft>
-                <a:spcPts val="300"/>
-              </a:spcAft>
-            </a:pPr>
-            <a:r>
-              <a:rPr sz="1300" b="1" i="0">
-                <a:solidFill>
-                  <a:srgbClr val="3AEDE5"/>
-                </a:solidFill>
-                <a:latin typeface="Alegreya Sans"/>
-              </a:rPr>
-              <a:t>MAIN AREAS OF EXPERTISE</a:t>
-            </a:r>
-          </a:p>
-          <a:p>
-            <a:pPr algn="l">
-              <a:spcAft>
-                <a:spcPts val="100"/>
-              </a:spcAft>
-            </a:pPr>
-            <a:r>
-              <a:rPr sz="1200" b="1" i="0">
-                <a:solidFill>
-                  <a:srgbClr val="3AEDE5"/>
-                </a:solidFill>
-                <a:latin typeface="Alegreya Sans"/>
-              </a:rPr>
-              <a:t>•  </a:t>
-            </a:r>
-            <a:r>
-              <a:rPr sz="1200" b="0" i="0">
-                <a:solidFill>
-                  <a:srgbClr val="FFFFFF"/>
-                </a:solidFill>
-                <a:latin typeface="Alegreya Sans"/>
-              </a:rPr>
-              <a:t>AI Governance</a:t>
-            </a:r>
-          </a:p>
-          <a:p>
-            <a:pPr algn="l">
-              <a:spcAft>
-                <a:spcPts val="100"/>
-              </a:spcAft>
-            </a:pPr>
-            <a:r>
-              <a:rPr sz="1200" b="1" i="0">
-                <a:solidFill>
-                  <a:srgbClr val="3AEDE5"/>
-                </a:solidFill>
-                <a:latin typeface="Alegreya Sans"/>
-              </a:rPr>
-              <a:t>•  </a:t>
-            </a:r>
-            <a:r>
-              <a:rPr sz="1200" b="0" i="0">
-                <a:solidFill>
-                  <a:srgbClr val="FFFFFF"/>
-                </a:solidFill>
-                <a:latin typeface="Alegreya Sans"/>
-              </a:rPr>
-              <a:t>AI Risk Management</a:t>
-            </a:r>
-          </a:p>
-          <a:p>
-            <a:pPr algn="l">
-              <a:spcAft>
-                <a:spcPts val="100"/>
-              </a:spcAft>
-            </a:pPr>
-            <a:r>
-              <a:rPr sz="1200" b="1" i="0">
-                <a:solidFill>
-                  <a:srgbClr val="3AEDE5"/>
-                </a:solidFill>
-                <a:latin typeface="Alegreya Sans"/>
-              </a:rPr>
-              <a:t>•  </a:t>
-            </a:r>
-            <a:r>
-              <a:rPr sz="1200" b="0" i="0">
-                <a:solidFill>
-                  <a:srgbClr val="FFFFFF"/>
-                </a:solidFill>
-                <a:latin typeface="Alegreya Sans"/>
-              </a:rPr>
-              <a:t>EU AI Act</a:t>
-            </a:r>
-          </a:p>
-          <a:p>
-            <a:pPr algn="l">
-              <a:spcAft>
-                <a:spcPts val="100"/>
-              </a:spcAft>
-            </a:pPr>
-            <a:r>
-              <a:rPr sz="1200" b="1" i="0">
-                <a:solidFill>
-                  <a:srgbClr val="3AEDE5"/>
-                </a:solidFill>
-                <a:latin typeface="Alegreya Sans"/>
-              </a:rPr>
-              <a:t>•  </a:t>
-            </a:r>
-            <a:r>
-              <a:rPr sz="1200" b="0" i="0">
-                <a:solidFill>
-                  <a:srgbClr val="FFFFFF"/>
-                </a:solidFill>
-                <a:latin typeface="Alegreya Sans"/>
-              </a:rPr>
-              <a:t>Digital Compliance</a:t>
-            </a:r>
-          </a:p>
-          <a:p>
-            <a:pPr algn="l">
-              <a:spcAft>
-                <a:spcPts val="100"/>
-              </a:spcAft>
-            </a:pPr>
-            <a:r>
-              <a:rPr sz="1200" b="1" i="0">
-                <a:solidFill>
-                  <a:srgbClr val="3AEDE5"/>
-                </a:solidFill>
-                <a:latin typeface="Alegreya Sans"/>
-              </a:rPr>
-              <a:t>•  </a:t>
-            </a:r>
-            <a:r>
-              <a:rPr sz="1200" b="0" i="0">
-                <a:solidFill>
-                  <a:srgbClr val="FFFFFF"/>
-                </a:solidFill>
-                <a:latin typeface="Alegreya Sans"/>
-              </a:rPr>
-              <a:t>Regulatory Strategy</a:t>
-            </a:r>
-          </a:p>
-          <a:p>
-            <a:pPr algn="l">
-              <a:spcBef>
-                <a:spcPts val="600"/>
-              </a:spcBef>
-              <a:spcAft>
-                <a:spcPts val="300"/>
-              </a:spcAft>
-            </a:pPr>
-            <a:r>
-              <a:rPr sz="1300" b="1" i="0">
-                <a:solidFill>
-                  <a:srgbClr val="3AEDE5"/>
-                </a:solidFill>
-                <a:latin typeface="Alegreya Sans"/>
-              </a:rPr>
-              <a:t>LANGUAGES</a:t>
-            </a:r>
-          </a:p>
-          <a:p>
-            <a:pPr algn="l">
-              <a:spcAft>
-                <a:spcPts val="100"/>
-              </a:spcAft>
-            </a:pPr>
-            <a:r>
-              <a:rPr sz="1200" b="1" i="0">
-                <a:solidFill>
-                  <a:srgbClr val="3AEDE5"/>
-                </a:solidFill>
-                <a:latin typeface="Alegreya Sans"/>
-              </a:rPr>
-              <a:t>•  </a:t>
-            </a:r>
-            <a:r>
-              <a:rPr sz="1200" b="0" i="0">
-                <a:solidFill>
-                  <a:srgbClr val="FFFFFF"/>
-                </a:solidFill>
-                <a:latin typeface="Alegreya Sans"/>
-              </a:rPr>
-              <a:t>French — Native</a:t>
-            </a:r>
-          </a:p>
-          <a:p>
-            <a:pPr algn="l">
-              <a:spcAft>
-                <a:spcPts val="100"/>
-              </a:spcAft>
-            </a:pPr>
-            <a:r>
-              <a:rPr sz="1200" b="1" i="0">
-                <a:solidFill>
-                  <a:srgbClr val="3AEDE5"/>
-                </a:solidFill>
-                <a:latin typeface="Alegreya Sans"/>
-              </a:rPr>
-              <a:t>•  </a:t>
-            </a:r>
-            <a:r>
-              <a:rPr sz="1200" b="0" i="0">
-                <a:solidFill>
-                  <a:srgbClr val="FFFFFF"/>
-                </a:solidFill>
-                <a:latin typeface="Alegreya Sans"/>
-              </a:rPr>
-              <a:t>English — TOEIC 955/990</a:t>
-            </a:r>
-          </a:p>
-          <a:p>
-            <a:pPr algn="l">
-              <a:spcBef>
-                <a:spcPts val="600"/>
-              </a:spcBef>
-              <a:spcAft>
-                <a:spcPts val="300"/>
-              </a:spcAft>
-            </a:pPr>
-            <a:r>
-              <a:rPr sz="1300" b="1" i="0">
-                <a:solidFill>
-                  <a:srgbClr val="3AEDE5"/>
-                </a:solidFill>
-                <a:latin typeface="Alegreya Sans"/>
-              </a:rPr>
-              <a:t>EDUCATION &amp; CERTIFICATIONS</a:t>
-            </a:r>
-          </a:p>
-          <a:p>
-            <a:pPr algn="l">
-              <a:spcAft>
-                <a:spcPts val="100"/>
-              </a:spcAft>
-            </a:pPr>
-            <a:r>
-              <a:rPr sz="1200" b="1" i="0">
-                <a:solidFill>
-                  <a:srgbClr val="3AEDE5"/>
-                </a:solidFill>
-                <a:latin typeface="Alegreya Sans"/>
-              </a:rPr>
-              <a:t>2024  </a:t>
-            </a:r>
-            <a:r>
-              <a:rPr sz="1200" b="1" i="0">
-                <a:solidFill>
-                  <a:srgbClr val="FFFFFF"/>
-                </a:solidFill>
-                <a:latin typeface="Alegreya Sans"/>
-              </a:rPr>
-              <a:t>EDHEC Business School</a:t>
-            </a:r>
-          </a:p>
-          <a:p>
-            <a:pPr algn="l">
-              <a:spcAft>
-                <a:spcPts val="300"/>
-              </a:spcAft>
-            </a:pPr>
-            <a:r>
-              <a:rPr sz="1200" b="0" i="1">
-                <a:solidFill>
-                  <a:srgbClr val="CCD6E8"/>
-                </a:solidFill>
-                <a:latin typeface="Alegreya Sans"/>
-              </a:rPr>
-              <a:t>Digital Ethics Officer certification (wi…</a:t>
-            </a:r>
-          </a:p>
-          <a:p>
-            <a:pPr algn="l">
-              <a:spcAft>
-                <a:spcPts val="100"/>
-              </a:spcAft>
-            </a:pPr>
-            <a:r>
-              <a:rPr sz="1200" b="1" i="0">
-                <a:solidFill>
-                  <a:srgbClr val="3AEDE5"/>
-                </a:solidFill>
-                <a:latin typeface="Alegreya Sans"/>
-              </a:rPr>
-              <a:t>2015 — 2020  </a:t>
-            </a:r>
-            <a:r>
-              <a:rPr sz="1200" b="1" i="0">
-                <a:solidFill>
-                  <a:srgbClr val="FFFFFF"/>
-                </a:solidFill>
-                <a:latin typeface="Alegreya Sans"/>
-              </a:rPr>
-              <a:t>Sciences Po Saint-Germain-en-Laye</a:t>
-            </a:r>
-          </a:p>
-          <a:p>
-            <a:pPr algn="l">
-              <a:spcAft>
-                <a:spcPts val="300"/>
-              </a:spcAft>
-            </a:pPr>
-            <a:r>
-              <a:rPr sz="1200" b="0" i="1">
-                <a:solidFill>
-                  <a:srgbClr val="CCD6E8"/>
-                </a:solidFill>
-                <a:latin typeface="Alegreya Sans"/>
-              </a:rPr>
-              <a:t>Master's in European &amp; International Aff…</a:t>
-            </a:r>
-          </a:p>
-          <a:p>
-            <a:pPr algn="l">
-              <a:spcAft>
-                <a:spcPts val="100"/>
-              </a:spcAft>
-            </a:pPr>
-            <a:r>
-              <a:rPr sz="1200" b="1" i="0">
-                <a:solidFill>
-                  <a:srgbClr val="3AEDE5"/>
-                </a:solidFill>
-                <a:latin typeface="Alegreya Sans"/>
-              </a:rPr>
-              <a:t>2020  </a:t>
-            </a:r>
-            <a:r>
-              <a:rPr sz="1200" b="1" i="0">
-                <a:solidFill>
-                  <a:srgbClr val="FFFFFF"/>
-                </a:solidFill>
-                <a:latin typeface="Alegreya Sans"/>
-              </a:rPr>
-              <a:t>University of Versailles Saint-Quentin-en-Yvelines</a:t>
-            </a:r>
-          </a:p>
-          <a:p>
-            <a:pPr algn="l">
-              <a:spcAft>
-                <a:spcPts val="300"/>
-              </a:spcAft>
-            </a:pPr>
-            <a:r>
-              <a:rPr sz="1200" b="0" i="1">
-                <a:solidFill>
-                  <a:srgbClr val="CCD6E8"/>
-                </a:solidFill>
-                <a:latin typeface="Alegreya Sans"/>
-              </a:rPr>
-              <a:t>Master's in Influence &amp; Public Affairs (…</a:t>
-            </a:r>
-          </a:p>
-          <a:p>
-            <a:pPr algn="l">
-              <a:spcBef>
-                <a:spcPts val="600"/>
-              </a:spcBef>
-              <a:spcAft>
-                <a:spcPts val="300"/>
-              </a:spcAft>
-            </a:pPr>
-            <a:r>
-              <a:rPr sz="1300" b="1" i="0">
-                <a:solidFill>
-                  <a:srgbClr val="3AEDE5"/>
-                </a:solidFill>
-                <a:latin typeface="Alegreya Sans"/>
-              </a:rPr>
-              <a:t>ENGAGEMENTS &amp; ACHIEVEMENTS</a:t>
-            </a:r>
-          </a:p>
-          <a:p>
-            <a:pPr algn="l">
-              <a:spcAft>
-                <a:spcPts val="200"/>
-              </a:spcAft>
-            </a:pPr>
-            <a:r>
-              <a:rPr sz="1200" b="1" i="0">
-                <a:solidFill>
-                  <a:srgbClr val="3AEDE5"/>
-                </a:solidFill>
-                <a:latin typeface="Alegreya Sans"/>
-              </a:rPr>
-              <a:t>• </a:t>
-            </a:r>
-            <a:r>
-              <a:rPr sz="1200" b="1" i="0">
-                <a:solidFill>
-                  <a:srgbClr val="FFFFFF"/>
-                </a:solidFill>
-                <a:latin typeface="Alegreya Sans"/>
-              </a:rPr>
-              <a:t>Digital Council Advisor</a:t>
-            </a:r>
-            <a:r>
-              <a:rPr sz="1200" b="0" i="1">
-                <a:solidFill>
-                  <a:srgbClr val="CCD6E8"/>
-                </a:solidFill>
-                <a:latin typeface="Alegreya Sans"/>
-              </a:rPr>
-              <a:t> — Volunteer at a local Digital Counci…</a:t>
-            </a:r>
-          </a:p>
-          <a:p>
-            <a:pPr algn="l">
-              <a:spcAft>
-                <a:spcPts val="200"/>
-              </a:spcAft>
-            </a:pPr>
-            <a:r>
-              <a:rPr sz="1200" b="1" i="0">
-                <a:solidFill>
-                  <a:srgbClr val="3AEDE5"/>
-                </a:solidFill>
-                <a:latin typeface="Alegreya Sans"/>
-              </a:rPr>
-              <a:t>• </a:t>
-            </a:r>
-            <a:r>
-              <a:rPr sz="1200" b="1" i="0">
-                <a:solidFill>
-                  <a:srgbClr val="FFFFFF"/>
-                </a:solidFill>
-                <a:latin typeface="Alegreya Sans"/>
-              </a:rPr>
-              <a:t>Podcaster</a:t>
-            </a:r>
-            <a:r>
-              <a:rPr sz="1200" b="0" i="1">
-                <a:solidFill>
-                  <a:srgbClr val="CCD6E8"/>
-                </a:solidFill>
-                <a:latin typeface="Alegreya Sans"/>
-              </a:rPr>
-              <a:t> — Creator and host of an AI podcast f…</a:t>
-            </a:r>
-          </a:p>
-          <a:p>
-            <a:pPr algn="l">
-              <a:spcAft>
-                <a:spcPts val="200"/>
-              </a:spcAft>
-            </a:pPr>
-            <a:r>
-              <a:rPr sz="1200" b="1" i="0">
-                <a:solidFill>
-                  <a:srgbClr val="3AEDE5"/>
-                </a:solidFill>
-                <a:latin typeface="Alegreya Sans"/>
-              </a:rPr>
-              <a:t>• </a:t>
-            </a:r>
-            <a:r>
-              <a:rPr sz="1200" b="1" i="0">
-                <a:solidFill>
-                  <a:srgbClr val="FFFFFF"/>
-                </a:solidFill>
-                <a:latin typeface="Alegreya Sans"/>
-              </a:rPr>
-              <a:t>Speaker</a:t>
-            </a:r>
-            <a:r>
-              <a:rPr sz="1200" b="0" i="1">
-                <a:solidFill>
-                  <a:srgbClr val="CCD6E8"/>
-                </a:solidFill>
-                <a:latin typeface="Alegreya Sans"/>
-              </a:rPr>
-              <a:t> — Speaker on AI and its challenges (b…</a:t>
-            </a:r>
-          </a:p>
-        </p:txBody>
-      </p:sp>
-      <p:sp>
-        <p:nvSpPr>
-          <p:cNvPr id="9" name="TextBox 8"/>
-          <p:cNvSpPr txBox="1"/>
-          <p:nvPr/>
-        </p:nvSpPr>
-        <p:spPr>
-          <a:xfrm>
-            <a:off x="4528600" y="1180000"/>
-            <a:ext cx="7434800" cy="5318000"/>
-          </a:xfrm>
-          <a:prstGeom prst="rect">
-            <a:avLst/>
-          </a:prstGeom>
-          <a:noFill/>
-        </p:spPr>
-        <p:txBody>
-          <a:bodyPr wrap="square" lIns="0" rIns="0" tIns="0" bIns="0">
-            <a:spAutoFit/>
-          </a:bodyPr>
-          <a:lstStyle/>
-          <a:p>
-            <a:pPr algn="l">
-              <a:spcAft>
-                <a:spcPts val="300"/>
-              </a:spcAft>
-            </a:pPr>
-            <a:r>
-              <a:rPr sz="1300" b="1" i="0">
-                <a:solidFill>
-                  <a:srgbClr val="3AEDE5"/>
-                </a:solidFill>
-                <a:latin typeface="Alegreya Sans"/>
-              </a:rPr>
-              <a:t>SUMMARY</a:t>
-            </a:r>
-          </a:p>
-          <a:p>
-            <a:pPr algn="l">
-              <a:spcAft>
-                <a:spcPts val="300"/>
-              </a:spcAft>
-            </a:pPr>
-            <a:r>
-              <a:rPr sz="1200" b="0" i="0">
-                <a:solidFill>
-                  <a:srgbClr val="FFFFFF"/>
-                </a:solidFill>
-                <a:latin typeface="Alegreya Sans"/>
-              </a:rPr>
-              <a:t>Expert in AI Governance, AI Risk Management and regulatory compliance, with nearly 8 years of experience advising major banking institutions. Specialised in the EU AI Act and the international rollout…</a:t>
-            </a:r>
-          </a:p>
-          <a:p>
-            <a:pPr algn="l">
-              <a:spcBef>
-                <a:spcPts val="600"/>
-              </a:spcBef>
-              <a:spcAft>
-                <a:spcPts val="300"/>
-              </a:spcAft>
-            </a:pPr>
-            <a:r>
-              <a:rPr sz="1300" b="1" i="0">
-                <a:solidFill>
-                  <a:srgbClr val="3AEDE5"/>
-                </a:solidFill>
-                <a:latin typeface="Alegreya Sans"/>
-              </a:rPr>
-              <a:t>PROFESSIONAL EXPERIENCE</a:t>
-            </a:r>
-          </a:p>
-          <a:p>
-            <a:pPr algn="l">
-              <a:spcAft>
-                <a:spcPts val="100"/>
-              </a:spcAft>
-            </a:pPr>
-            <a:r>
-              <a:rPr sz="1200" b="1" i="0">
-                <a:solidFill>
-                  <a:srgbClr val="3AEDE5"/>
-                </a:solidFill>
-                <a:latin typeface="Alegreya Sans"/>
-              </a:rPr>
-              <a:t>▸ </a:t>
-            </a:r>
-            <a:r>
-              <a:rPr sz="1200" b="1" i="0">
-                <a:solidFill>
-                  <a:srgbClr val="FFFFFF"/>
-                </a:solidFill>
-                <a:latin typeface="Alegreya Sans"/>
-              </a:rPr>
-              <a:t>Top-tier European CIB</a:t>
-            </a:r>
-            <a:r>
-              <a:rPr sz="1200" b="0" i="0">
-                <a:solidFill>
-                  <a:srgbClr val="FFFFFF"/>
-                </a:solidFill>
-                <a:latin typeface="Alegreya Sans"/>
-              </a:rPr>
-              <a:t> — AI Compliance Lead (consultant)</a:t>
-            </a:r>
-            <a:r>
-              <a:rPr sz="1200" b="0" i="1">
-                <a:solidFill>
-                  <a:srgbClr val="3AEDE5"/>
-                </a:solidFill>
-                <a:latin typeface="Alegreya Sans"/>
-              </a:rPr>
-              <a:t>  (8 months — ongoing)</a:t>
-            </a:r>
-          </a:p>
-          <a:p>
-            <a:pPr algn="l" lvl="1">
-              <a:spcAft>
-                <a:spcPts val="100"/>
-              </a:spcAft>
-            </a:pPr>
-            <a:r>
-              <a:rPr sz="1200" b="1" i="0">
-                <a:solidFill>
-                  <a:srgbClr val="3AEDE5"/>
-                </a:solidFill>
-                <a:latin typeface="Alegreya Sans"/>
-              </a:rPr>
-              <a:t>•  </a:t>
-            </a:r>
-            <a:r>
-              <a:rPr sz="1200" b="0" i="0">
-                <a:solidFill>
-                  <a:srgbClr val="FFFFFF"/>
-                </a:solidFill>
-                <a:latin typeface="Alegreya Sans"/>
-              </a:rPr>
-              <a:t>Finalisation and rollout of the AI risk governance framework: internal policies, risk mapping, committee design, coordination of support and…</a:t>
-            </a:r>
-          </a:p>
-          <a:p>
-            <a:pPr algn="l" lvl="1">
-              <a:spcAft>
-                <a:spcPts val="100"/>
-              </a:spcAft>
-            </a:pPr>
-            <a:r>
-              <a:rPr sz="1200" b="1" i="0">
-                <a:solidFill>
-                  <a:srgbClr val="3AEDE5"/>
-                </a:solidFill>
-                <a:latin typeface="Alegreya Sans"/>
-              </a:rPr>
-              <a:t>•  </a:t>
-            </a:r>
-            <a:r>
-              <a:rPr sz="1200" b="0" i="0">
-                <a:solidFill>
-                  <a:srgbClr val="FFFFFF"/>
-                </a:solidFill>
-                <a:latin typeface="Alegreya Sans"/>
-              </a:rPr>
-              <a:t>Operational pilot of AI governance: identification, assessment, prioritisation, validation and remediation of AI systems.</a:t>
-            </a:r>
-          </a:p>
-          <a:p>
-            <a:pPr algn="l">
-              <a:spcAft>
-                <a:spcPts val="100"/>
-              </a:spcAft>
-            </a:pPr>
-            <a:r>
-              <a:rPr sz="1200" b="1" i="0">
-                <a:solidFill>
-                  <a:srgbClr val="3AEDE5"/>
-                </a:solidFill>
-                <a:latin typeface="Alegreya Sans"/>
-              </a:rPr>
-              <a:t>▸ </a:t>
-            </a:r>
-            <a:r>
-              <a:rPr sz="1200" b="1" i="0">
-                <a:solidFill>
-                  <a:srgbClr val="FFFFFF"/>
-                </a:solidFill>
-                <a:latin typeface="Alegreya Sans"/>
-              </a:rPr>
-              <a:t>Sia Partners</a:t>
-            </a:r>
-            <a:r>
-              <a:rPr sz="1200" b="0" i="0">
-                <a:solidFill>
-                  <a:srgbClr val="FFFFFF"/>
-                </a:solidFill>
-                <a:latin typeface="Alegreya Sans"/>
-              </a:rPr>
-              <a:t> — Associate Manager</a:t>
-            </a:r>
-            <a:r>
-              <a:rPr sz="1200" b="0" i="1">
-                <a:solidFill>
-                  <a:srgbClr val="3AEDE5"/>
-                </a:solidFill>
-                <a:latin typeface="Alegreya Sans"/>
-              </a:rPr>
-              <a:t>  (10 months — ongoing)</a:t>
-            </a:r>
-          </a:p>
-          <a:p>
-            <a:pPr algn="l" lvl="1">
-              <a:spcAft>
-                <a:spcPts val="100"/>
-              </a:spcAft>
-            </a:pPr>
-            <a:r>
-              <a:rPr sz="1200" b="1" i="0">
-                <a:solidFill>
-                  <a:srgbClr val="3AEDE5"/>
-                </a:solidFill>
-                <a:latin typeface="Alegreya Sans"/>
-              </a:rPr>
-              <a:t>•  </a:t>
-            </a:r>
-            <a:r>
-              <a:rPr sz="1200" b="0" i="0">
-                <a:solidFill>
-                  <a:srgbClr val="FFFFFF"/>
-                </a:solidFill>
-                <a:latin typeface="Alegreya Sans"/>
-              </a:rPr>
-              <a:t>Head of the AI Risk Management offering: RFP coordination, strategic and regulatory watch, business development and financial-ecosystem anim…</a:t>
-            </a:r>
-          </a:p>
-          <a:p>
-            <a:pPr algn="l" lvl="1">
-              <a:spcAft>
-                <a:spcPts val="100"/>
-              </a:spcAft>
-            </a:pPr>
-            <a:r>
-              <a:rPr sz="1200" b="1" i="0">
-                <a:solidFill>
-                  <a:srgbClr val="3AEDE5"/>
-                </a:solidFill>
-                <a:latin typeface="Alegreya Sans"/>
-              </a:rPr>
-              <a:t>•  </a:t>
-            </a:r>
-            <a:r>
-              <a:rPr sz="1200" b="0" i="0">
-                <a:solidFill>
-                  <a:srgbClr val="FFFFFF"/>
-                </a:solidFill>
-                <a:latin typeface="Alegreya Sans"/>
-              </a:rPr>
-              <a:t>Lead of the AI working group at Paris Europlace association (40+ senior financial-sector representatives): position papers, EU consultation…</a:t>
-            </a:r>
-          </a:p>
-          <a:p>
-            <a:pPr algn="l">
-              <a:spcAft>
-                <a:spcPts val="100"/>
-              </a:spcAft>
-            </a:pPr>
-            <a:r>
-              <a:rPr sz="1200" b="1" i="0">
-                <a:solidFill>
-                  <a:srgbClr val="3AEDE5"/>
-                </a:solidFill>
-                <a:latin typeface="Alegreya Sans"/>
-              </a:rPr>
-              <a:t>▸ </a:t>
-            </a:r>
-            <a:r>
-              <a:rPr sz="1200" b="1" i="0">
-                <a:solidFill>
-                  <a:srgbClr val="FFFFFF"/>
-                </a:solidFill>
-                <a:latin typeface="Alegreya Sans"/>
-              </a:rPr>
-              <a:t>Groupe BPCE</a:t>
-            </a:r>
-            <a:r>
-              <a:rPr sz="1200" b="0" i="0">
-                <a:solidFill>
-                  <a:srgbClr val="FFFFFF"/>
-                </a:solidFill>
-                <a:latin typeface="Alegreya Sans"/>
-              </a:rPr>
-              <a:t> — Group EU AI Act Project Manager</a:t>
-            </a:r>
-            <a:r>
-              <a:rPr sz="1200" b="0" i="1">
-                <a:solidFill>
-                  <a:srgbClr val="3AEDE5"/>
-                </a:solidFill>
-                <a:latin typeface="Alegreya Sans"/>
-              </a:rPr>
-              <a:t>  (18 months)</a:t>
-            </a:r>
-          </a:p>
-          <a:p>
-            <a:pPr algn="l" lvl="1">
-              <a:spcAft>
-                <a:spcPts val="100"/>
-              </a:spcAft>
-            </a:pPr>
-            <a:r>
-              <a:rPr sz="1200" b="1" i="0">
-                <a:solidFill>
-                  <a:srgbClr val="3AEDE5"/>
-                </a:solidFill>
-                <a:latin typeface="Alegreya Sans"/>
-              </a:rPr>
-              <a:t>•  </a:t>
-            </a:r>
-            <a:r>
-              <a:rPr sz="1200" b="0" i="0">
-                <a:solidFill>
-                  <a:srgbClr val="FFFFFF"/>
-                </a:solidFill>
-                <a:latin typeface="Alegreya Sans"/>
-              </a:rPr>
-              <a:t>Lead of the EU AI Act compliance programme for Groupe BPCE and its entities (Natixis, Oney, BRED, etc.): AI risk mapping and assessment, def…</a:t>
-            </a:r>
-          </a:p>
-          <a:p>
-            <a:pPr algn="l" lvl="1">
-              <a:spcAft>
-                <a:spcPts val="100"/>
-              </a:spcAft>
-            </a:pPr>
-            <a:r>
-              <a:rPr sz="1200" b="1" i="0">
-                <a:solidFill>
-                  <a:srgbClr val="3AEDE5"/>
-                </a:solidFill>
-                <a:latin typeface="Alegreya Sans"/>
-              </a:rPr>
-              <a:t>•  </a:t>
-            </a:r>
-            <a:r>
-              <a:rPr sz="1200" b="0" i="0">
-                <a:solidFill>
-                  <a:srgbClr val="FFFFFF"/>
-                </a:solidFill>
-                <a:latin typeface="Alegreya Sans"/>
-              </a:rPr>
-              <a:t>Coordination and support of 35+ local decision-makers (DPO, Chief Compliance Officer, CDO, etc.) in deploying the Group framework.</a:t>
-            </a:r>
-          </a:p>
-          <a:p>
-            <a:pPr algn="l">
-              <a:spcAft>
-                <a:spcPts val="100"/>
-              </a:spcAft>
-            </a:pPr>
-            <a:r>
-              <a:rPr sz="1200" b="1" i="0">
-                <a:solidFill>
-                  <a:srgbClr val="3AEDE5"/>
-                </a:solidFill>
-                <a:latin typeface="Alegreya Sans"/>
-              </a:rPr>
-              <a:t>▸ </a:t>
-            </a:r>
-            <a:r>
-              <a:rPr sz="1200" b="1" i="0">
-                <a:solidFill>
-                  <a:srgbClr val="FFFFFF"/>
-                </a:solidFill>
-                <a:latin typeface="Alegreya Sans"/>
-              </a:rPr>
-              <a:t>Oney / Oneytrust</a:t>
-            </a:r>
-            <a:r>
-              <a:rPr sz="1200" b="0" i="0">
-                <a:solidFill>
-                  <a:srgbClr val="FFFFFF"/>
-                </a:solidFill>
-                <a:latin typeface="Alegreya Sans"/>
-              </a:rPr>
-              <a:t> — Expert Leader — Digital &amp; AI Compliance Officer</a:t>
-            </a:r>
-            <a:r>
-              <a:rPr sz="1200" b="0" i="1">
-                <a:solidFill>
-                  <a:srgbClr val="3AEDE5"/>
-                </a:solidFill>
-                <a:latin typeface="Alegreya Sans"/>
-              </a:rPr>
-              <a:t>  (38 months)</a:t>
-            </a:r>
-          </a:p>
-          <a:p>
-            <a:pPr algn="l" lvl="1">
-              <a:spcAft>
-                <a:spcPts val="100"/>
-              </a:spcAft>
-            </a:pPr>
-            <a:r>
-              <a:rPr sz="1200" b="1" i="0">
-                <a:solidFill>
-                  <a:srgbClr val="3AEDE5"/>
-                </a:solidFill>
-                <a:latin typeface="Alegreya Sans"/>
-              </a:rPr>
-              <a:t>•  </a:t>
-            </a:r>
-            <a:r>
-              <a:rPr sz="1200" b="0" i="0">
-                <a:solidFill>
-                  <a:srgbClr val="FFFFFF"/>
-                </a:solidFill>
-                <a:latin typeface="Alegreya Sans"/>
-              </a:rPr>
-              <a:t>Built the AI risk governance framework with the Chief Data Officer: systems inventory, training of business reference owners, EU AI Act comp…</a:t>
-            </a:r>
-          </a:p>
-          <a:p>
-            <a:pPr algn="l" lvl="1">
-              <a:spcAft>
-                <a:spcPts val="100"/>
-              </a:spcAft>
-            </a:pPr>
-            <a:r>
-              <a:rPr sz="1200" b="1" i="0">
-                <a:solidFill>
-                  <a:srgbClr val="3AEDE5"/>
-                </a:solidFill>
-                <a:latin typeface="Alegreya Sans"/>
-              </a:rPr>
-              <a:t>•  </a:t>
-            </a:r>
-            <a:r>
-              <a:rPr sz="1200" b="0" i="0">
-                <a:solidFill>
-                  <a:srgbClr val="FFFFFF"/>
-                </a:solidFill>
-                <a:latin typeface="Alegreya Sans"/>
-              </a:rPr>
-              <a:t>Group GenAI tools ambassador to 3,000 Oney employees.</a:t>
-            </a:r>
-          </a:p>
-          <a:p>
-            <a:pPr algn="l">
-              <a:spcBef>
-                <a:spcPts val="600"/>
-              </a:spcBef>
-              <a:spcAft>
-                <a:spcPts val="300"/>
-              </a:spcAft>
-            </a:pPr>
-            <a:r>
-              <a:rPr sz="1300" b="1" i="0">
-                <a:solidFill>
-                  <a:srgbClr val="3AEDE5"/>
-                </a:solidFill>
-                <a:latin typeface="Alegreya Sans"/>
-              </a:rPr>
-              <a:t>MAIN REFERENCES</a:t>
-            </a:r>
-          </a:p>
-          <a:p>
-            <a:pPr algn="l">
-              <a:spcAft>
-                <a:spcPts val="200"/>
-              </a:spcAft>
-            </a:pPr>
-            <a:r>
-              <a:rPr sz="1200" b="0" i="1">
-                <a:solidFill>
-                  <a:srgbClr val="FFFFFF"/>
-                </a:solidFill>
-                <a:latin typeface="Alegreya Sans"/>
-              </a:rPr>
-              <a:t>Groupe BPCE, Natixis, Oney, Sia Partners, Paris Europlace</a:t>
-            </a:r>
           </a:p>
         </p:txBody>
       </p:sp>

</xml_diff>

<commit_message>
2 new CVs (C.P., D.L.) + no more mid-string truncation
- Ajoute Christophe POBEREJSKY (source bilingue FR/EN — chaque
  version utilisée telle quelle) et David LECLERCQ (source FR
  seule → traduction EN).
- Supprime toute la logique de troncature texte + "…" :
  MAX_BULLET_CHARS, MAX_SUMMARY_CHARS, MAX_ENGAGEMENT_DESC_CHARS
  et MAX_DEGREE_CHARS retirés. Le contenu textuel doit être écrit
  à la bonne longueur en phase d'extraction (règle produit).
- Les caps restants (MAX_EXPERIENCES, MAX_BULLETS_PER_EXP, etc.)
  droppent uniquement des ITEMS ENTIERS, jamais mid-string.
- Ajoute _adaptive_main_trim() : drop entier des références quand
  la main column risque de déborder (marge de sécurité 20pt).

Co-Authored-By: Claude Opus 4.7 <noreply@anthropic.com>
Claude-Session: https://claude.ai/code/session_01P34Y9PqaSyqWxj7EA7cQyd
</commit_message>
<xml_diff>
--- a/outputs/A.P._ai_governance.pptx
+++ b/outputs/A.P._ai_governance.pptx
@@ -3574,7 +3574,7 @@
                 </a:solidFill>
                 <a:latin typeface="Alegreya Sans"/>
               </a:rPr>
-              <a:t>Certification Digital Ethics Officer (av…</a:t>
+              <a:t>Certification Digital Ethics Officer (avec Mention)</a:t>
             </a:r>
           </a:p>
           <a:p>
@@ -3615,7 +3615,7 @@
                 </a:solidFill>
                 <a:latin typeface="Alegreya Sans"/>
               </a:rPr>
-              <a:t>Master II Affaires européennes et intern…</a:t>
+              <a:t>Master II Affaires européennes et internationales (avec Mention)</a:t>
             </a:r>
           </a:p>
           <a:p>
@@ -3656,7 +3656,7 @@
                 </a:solidFill>
                 <a:latin typeface="Alegreya Sans"/>
               </a:rPr>
-              <a:t>Master II Influence &amp; Affaires publiques…</a:t>
+              <a:t>Master II Influence &amp; Affaires publiques (avec Mention)</a:t>
             </a:r>
           </a:p>
           <a:p>
@@ -3702,15 +3702,6 @@
               </a:rPr>
               <a:t>Conseiller Numérique</a:t>
             </a:r>
-            <a:r>
-              <a:rPr sz="1200" b="0" i="1">
-                <a:solidFill>
-                  <a:srgbClr val="CCD6E8"/>
-                </a:solidFill>
-                <a:latin typeface="Alegreya Sans"/>
-              </a:rPr>
-              <a:t> — Bénévole au sein du Conseil du Numé…</a:t>
-            </a:r>
           </a:p>
           <a:p>
             <a:pPr algn="l">
@@ -3736,15 +3727,6 @@
               </a:rPr>
               <a:t>Podcasteur</a:t>
             </a:r>
-            <a:r>
-              <a:rPr sz="1200" b="0" i="1">
-                <a:solidFill>
-                  <a:srgbClr val="CCD6E8"/>
-                </a:solidFill>
-                <a:latin typeface="Alegreya Sans"/>
-              </a:rPr>
-              <a:t> — Créateur et animateur d'un podcast…</a:t>
-            </a:r>
           </a:p>
           <a:p>
             <a:pPr algn="l">
@@ -3769,15 +3751,6 @@
                 <a:latin typeface="Alegreya Sans"/>
               </a:rPr>
               <a:t>Conférencier</a:t>
-            </a:r>
-            <a:r>
-              <a:rPr sz="1200" b="0" i="1">
-                <a:solidFill>
-                  <a:srgbClr val="CCD6E8"/>
-                </a:solidFill>
-                <a:latin typeface="Alegreya Sans"/>
-              </a:rPr>
-              <a:t> — Intervenant sur l'IA et ses enjeux…</a:t>
             </a:r>
           </a:p>
         </p:txBody>
@@ -3832,7 +3805,7 @@
                 </a:solidFill>
                 <a:latin typeface="Alegreya Sans"/>
               </a:rPr>
-              <a:t>Expert en gouvernance de l'IA, AI Risk Management et conformité réglementaire, avec près de 8 ans d'expérience auprès de grandes institutions bancaires. Spécialisé dans l'EU AI Act et le déploiement d…</a:t>
+              <a:t>Expert en gouvernance de l'IA, AI Risk Management et conformité réglementaire, avec près de 8 ans d'expérience auprès de grandes institutions bancaires. Spécialisé dans l'EU AI Act et le déploiement de dispositifs de gouvernance IA à l'échelle internationale.</a:t>
             </a:r>
           </a:p>
           <a:p>
@@ -3919,7 +3892,7 @@
                 </a:solidFill>
                 <a:latin typeface="Alegreya Sans"/>
               </a:rPr>
-              <a:t>Finalisation et mise en œuvre du cadre de gouvernance des risques IA : politiques internes, cartographie des risques, comitologie et coordin…</a:t>
+              <a:t>Finalisation et mise en œuvre du cadre de gouvernance des risques IA : politiques internes, cartographie des risques, comitologie et coordination des fonctions support et métiers.</a:t>
             </a:r>
           </a:p>
           <a:p>
@@ -4012,7 +3985,7 @@
                 </a:solidFill>
                 <a:latin typeface="Alegreya Sans"/>
               </a:rPr>
-              <a:t>Responsable de l'offre AI Risk Management : coordination des réponses aux appels d'offres, veille stratégique et réglementaire, développemen…</a:t>
+              <a:t>Responsable de l'offre AI Risk Management : coordination des réponses aux appels d'offres, veille stratégique et réglementaire, développement commercial et animation de l'écosystème financier.</a:t>
             </a:r>
           </a:p>
           <a:p>
@@ -4037,7 +4010,7 @@
                 </a:solidFill>
                 <a:latin typeface="Alegreya Sans"/>
               </a:rPr>
-              <a:t>Pilotage et animation du groupe de travail IA de l'association Paris Europlace (+40 responsables du secteur financier) : rédaction de positi…</a:t>
+              <a:t>Pilotage et animation du groupe de travail IA de l'association Paris Europlace (+40 responsables du secteur financier) : rédaction de position papers et de réponses aux consultations européennes, benchmarks.</a:t>
             </a:r>
           </a:p>
           <a:p>
@@ -4105,7 +4078,7 @@
                 </a:solidFill>
                 <a:latin typeface="Alegreya Sans"/>
               </a:rPr>
-              <a:t>Responsable du programme de mise en conformité EU AI Act du Groupe BPCE et de ses entités (Natixis, Oney, BRED, etc.) : cartographie et éval…</a:t>
+              <a:t>Responsable du programme de mise en conformité EU AI Act du Groupe BPCE et de ses entités (Natixis, Oney, BRED, etc.) : cartographie et évaluation des risques IA, définition de la politique et du cadre normatif Groupe, évolution des processus opérationnels, animation du comité de pilotage.</a:t>
             </a:r>
           </a:p>
           <a:p>
@@ -4130,7 +4103,7 @@
                 </a:solidFill>
                 <a:latin typeface="Alegreya Sans"/>
               </a:rPr>
-              <a:t>Coordination et accompagnement de plus de 35 décideurs locaux (DPO, Chief Compliance Officer, CDO, etc.) dans la déclinaison du cadre normat…</a:t>
+              <a:t>Coordination et accompagnement de plus de 35 décideurs locaux (DPO, Chief Compliance Officer, CDO, etc.) dans la déclinaison du cadre normatif Groupe.</a:t>
             </a:r>
           </a:p>
           <a:p>
@@ -4198,7 +4171,7 @@
                 </a:solidFill>
                 <a:latin typeface="Alegreya Sans"/>
               </a:rPr>
-              <a:t>Structuration du cadre de gouvernance des risques IA avec le Chief Data Officer : inventaire des systèmes, formation des référents métiers e…</a:t>
+              <a:t>Structuration du cadre de gouvernance des risques IA avec le Chief Data Officer : inventaire des systèmes, formation des référents métiers et pilotage de la conformité EU AI Act dans plus de 10 entités internationales.</a:t>
             </a:r>
           </a:p>
           <a:p>
@@ -4224,41 +4197,6 @@
                 <a:latin typeface="Alegreya Sans"/>
               </a:rPr>
               <a:t>Ambassadeur des outils d'IA Générative Groupe auprès de 3 000 collaborateurs Oney.</a:t>
-            </a:r>
-          </a:p>
-          <a:p>
-            <a:pPr algn="l">
-              <a:spcBef>
-                <a:spcPts val="600"/>
-              </a:spcBef>
-              <a:spcAft>
-                <a:spcPts val="300"/>
-              </a:spcAft>
-            </a:pPr>
-            <a:r>
-              <a:rPr sz="1300" b="1" i="0">
-                <a:solidFill>
-                  <a:srgbClr val="3AEDE5"/>
-                </a:solidFill>
-                <a:latin typeface="Alegreya Sans"/>
-              </a:rPr>
-              <a:t>RÉFÉRENCES</a:t>
-            </a:r>
-          </a:p>
-          <a:p>
-            <a:pPr algn="l">
-              <a:spcAft>
-                <a:spcPts val="200"/>
-              </a:spcAft>
-            </a:pPr>
-            <a:r>
-              <a:rPr sz="1200" b="0" i="1">
-                <a:solidFill>
-                  <a:srgbClr val="FFFFFF"/>
-                </a:solidFill>
-                <a:latin typeface="Alegreya Sans"/>
-              </a:rPr>
-              <a:t>Groupe BPCE, Natixis, Oney, Sia Partners, Paris Europlace</a:t>
             </a:r>
           </a:p>
         </p:txBody>
@@ -4845,7 +4783,7 @@
                 </a:solidFill>
                 <a:latin typeface="Alegreya Sans"/>
               </a:rPr>
-              <a:t>Digital Ethics Officer certification (wi…</a:t>
+              <a:t>Digital Ethics Officer certification (with Distinction)</a:t>
             </a:r>
           </a:p>
           <a:p>
@@ -4886,7 +4824,7 @@
                 </a:solidFill>
                 <a:latin typeface="Alegreya Sans"/>
               </a:rPr>
-              <a:t>Master's in European &amp; International Aff…</a:t>
+              <a:t>Master's in European &amp; International Affairs (with Distinction)</a:t>
             </a:r>
           </a:p>
           <a:p>
@@ -4927,7 +4865,7 @@
                 </a:solidFill>
                 <a:latin typeface="Alegreya Sans"/>
               </a:rPr>
-              <a:t>Master's in Influence &amp; Public Affairs (…</a:t>
+              <a:t>Master's in Influence &amp; Public Affairs (with Distinction)</a:t>
             </a:r>
           </a:p>
           <a:p>
@@ -4973,15 +4911,6 @@
               </a:rPr>
               <a:t>Digital Council Advisor</a:t>
             </a:r>
-            <a:r>
-              <a:rPr sz="1200" b="0" i="1">
-                <a:solidFill>
-                  <a:srgbClr val="CCD6E8"/>
-                </a:solidFill>
-                <a:latin typeface="Alegreya Sans"/>
-              </a:rPr>
-              <a:t> — Volunteer at a local Digital Counci…</a:t>
-            </a:r>
           </a:p>
           <a:p>
             <a:pPr algn="l">
@@ -5007,15 +4936,6 @@
               </a:rPr>
               <a:t>Podcaster</a:t>
             </a:r>
-            <a:r>
-              <a:rPr sz="1200" b="0" i="1">
-                <a:solidFill>
-                  <a:srgbClr val="CCD6E8"/>
-                </a:solidFill>
-                <a:latin typeface="Alegreya Sans"/>
-              </a:rPr>
-              <a:t> — Creator and host of an AI podcast f…</a:t>
-            </a:r>
           </a:p>
           <a:p>
             <a:pPr algn="l">
@@ -5040,15 +4960,6 @@
                 <a:latin typeface="Alegreya Sans"/>
               </a:rPr>
               <a:t>Speaker</a:t>
-            </a:r>
-            <a:r>
-              <a:rPr sz="1200" b="0" i="1">
-                <a:solidFill>
-                  <a:srgbClr val="CCD6E8"/>
-                </a:solidFill>
-                <a:latin typeface="Alegreya Sans"/>
-              </a:rPr>
-              <a:t> — Speaker on AI and its challenges (b…</a:t>
             </a:r>
           </a:p>
         </p:txBody>
@@ -5103,7 +5014,7 @@
                 </a:solidFill>
                 <a:latin typeface="Alegreya Sans"/>
               </a:rPr>
-              <a:t>Expert in AI Governance, AI Risk Management and regulatory compliance, with nearly 8 years of experience advising major banking institutions. Specialised in the EU AI Act and the international rollout…</a:t>
+              <a:t>Expert in AI Governance, AI Risk Management and regulatory compliance, with nearly 8 years of experience advising major banking institutions. Specialised in the EU AI Act and the international rollout of AI governance frameworks.</a:t>
             </a:r>
           </a:p>
           <a:p>
@@ -5190,7 +5101,7 @@
                 </a:solidFill>
                 <a:latin typeface="Alegreya Sans"/>
               </a:rPr>
-              <a:t>Finalisation and rollout of the AI risk governance framework: internal policies, risk mapping, committee design, coordination of support and…</a:t>
+              <a:t>Finalisation and rollout of the AI risk governance framework: internal policies, risk mapping, committee design, coordination of support and business functions.</a:t>
             </a:r>
           </a:p>
           <a:p>
@@ -5283,7 +5194,7 @@
                 </a:solidFill>
                 <a:latin typeface="Alegreya Sans"/>
               </a:rPr>
-              <a:t>Head of the AI Risk Management offering: RFP coordination, strategic and regulatory watch, business development and financial-ecosystem anim…</a:t>
+              <a:t>Head of the AI Risk Management offering: RFP coordination, strategic and regulatory watch, business development and financial-ecosystem animation.</a:t>
             </a:r>
           </a:p>
           <a:p>
@@ -5308,7 +5219,7 @@
                 </a:solidFill>
                 <a:latin typeface="Alegreya Sans"/>
               </a:rPr>
-              <a:t>Lead of the AI working group at Paris Europlace association (40+ senior financial-sector representatives): position papers, EU consultation…</a:t>
+              <a:t>Lead of the AI working group at Paris Europlace association (40+ senior financial-sector representatives): position papers, EU consultation responses, benchmarks.</a:t>
             </a:r>
           </a:p>
           <a:p>
@@ -5376,7 +5287,7 @@
                 </a:solidFill>
                 <a:latin typeface="Alegreya Sans"/>
               </a:rPr>
-              <a:t>Lead of the EU AI Act compliance programme for Groupe BPCE and its entities (Natixis, Oney, BRED, etc.): AI risk mapping and assessment, def…</a:t>
+              <a:t>Lead of the EU AI Act compliance programme for Groupe BPCE and its entities (Natixis, Oney, BRED, etc.): AI risk mapping and assessment, definition of Group policy and standards, operational process evolution, steering-committee animation.</a:t>
             </a:r>
           </a:p>
           <a:p>
@@ -5469,7 +5380,7 @@
                 </a:solidFill>
                 <a:latin typeface="Alegreya Sans"/>
               </a:rPr>
-              <a:t>Built the AI risk governance framework with the Chief Data Officer: systems inventory, training of business reference owners, EU AI Act comp…</a:t>
+              <a:t>Built the AI risk governance framework with the Chief Data Officer: systems inventory, training of business reference owners, EU AI Act compliance pilot across 10+ international entities.</a:t>
             </a:r>
           </a:p>
           <a:p>
@@ -5495,41 +5406,6 @@
                 <a:latin typeface="Alegreya Sans"/>
               </a:rPr>
               <a:t>Group GenAI tools ambassador to 3,000 Oney employees.</a:t>
-            </a:r>
-          </a:p>
-          <a:p>
-            <a:pPr algn="l">
-              <a:spcBef>
-                <a:spcPts val="600"/>
-              </a:spcBef>
-              <a:spcAft>
-                <a:spcPts val="300"/>
-              </a:spcAft>
-            </a:pPr>
-            <a:r>
-              <a:rPr sz="1300" b="1" i="0">
-                <a:solidFill>
-                  <a:srgbClr val="3AEDE5"/>
-                </a:solidFill>
-                <a:latin typeface="Alegreya Sans"/>
-              </a:rPr>
-              <a:t>MAIN REFERENCES</a:t>
-            </a:r>
-          </a:p>
-          <a:p>
-            <a:pPr algn="l">
-              <a:spcAft>
-                <a:spcPts val="200"/>
-              </a:spcAft>
-            </a:pPr>
-            <a:r>
-              <a:rPr sz="1200" b="0" i="1">
-                <a:solidFill>
-                  <a:srgbClr val="FFFFFF"/>
-                </a:solidFill>
-                <a:latin typeface="Alegreya Sans"/>
-              </a:rPr>
-              <a:t>Groupe BPCE, Natixis, Oney, Sia Partners, Paris Europlace</a:t>
             </a:r>
           </a:p>
         </p:txBody>

</xml_diff>